<commit_message>
Add click-controlled image-first entry slide animations
</commit_message>
<xml_diff>
--- a/second-placement/planning/2026-09-18-Friday-Icebreaker-Goods-Services-Ideas-Revised-v2.pptx
+++ b/second-placement/planning/2026-09-18-Friday-Icebreaker-Goods-Services-Ideas-Revised-v2.pptx
@@ -458,6 +458,11 @@
               <a:t>Source: Chapter 1, Introduction to Business and Marketing, B.E. Publishing, p. 4. Local source: /Users/pitergarcia/DataScience/Semester5/Semester3(UofR)/TeachingPlacement/second-placement/Chapter 1 Introduction to Business and Marketing.pdf</a:t>
             </a:r>
           </a:p>
+          <a:p xmlns:a="http://schemas.openxmlformats.org/drawingml/2006/main">
+            <a:r>
+              <a:t>CLICK CUES: Whole scene first. Click once for the item/task/idea prompt. Give ten seconds to notice, then advance.</a:t>
+            </a:r>
+          </a:p>
         </p:txBody>
       </p:sp>
       <p:sp>
@@ -538,6 +543,11 @@
               <a:t>Source: Chapter 1, Introduction to Business and Marketing, B.E. Publishing, p. 4. Local source: /Users/pitergarcia/DataScience/Semester5/Semester3(UofR)/TeachingPlacement/second-placement/Chapter 1 Introduction to Business and Marketing.pdf</a:t>
             </a:r>
           </a:p>
+          <a:p xmlns:a="http://schemas.openxmlformats.org/drawingml/2006/main">
+            <a:r>
+              <a:t>CLICK CUES: Six clicks: picture 1, number 1, replace with picture 2, number 2, replace with picture 3, number 3. Ask for a G/S/I response while each picture is visible. Read the definition clues aloud as needed. Students can say, point to a clue, or write the category. Back revisits the previous picture. Advance only after all three responses.</a:t>
+            </a:r>
+          </a:p>
         </p:txBody>
       </p:sp>
       <p:sp>
@@ -618,6 +628,11 @@
               <a:t>Source: Chapter 1, Introduction to Business and Marketing, B.E. Publishing, p. 4. Local source: /Users/pitergarcia/DataScience/Semester5/Semester3(UofR)/TeachingPlacement/second-placement/Chapter 1 Introduction to Business and Marketing.pdf</a:t>
             </a:r>
           </a:p>
+          <a:p xmlns:a="http://schemas.openxmlformats.org/drawingml/2006/main">
+            <a:r>
+              <a:t>CLICK CUES: Click once per answer row, then once for the full matching key. Keep the previously revealed rows visible for reference.</a:t>
+            </a:r>
+          </a:p>
         </p:txBody>
       </p:sp>
       <p:sp>
@@ -696,6 +711,11 @@
           <a:p xmlns:a="http://schemas.openxmlformats.org/drawingml/2006/main">
             <a:r>
               <a:t>Source: Chapter 1, Introduction to Business and Marketing, B.E. Publishing, p. 4. Local source: /Users/pitergarcia/DataScience/Semester5/Semester3(UofR)/TeachingPlacement/second-placement/Chapter 1 Introduction to Business and Marketing.pdf</a:t>
+            </a:r>
+          </a:p>
+          <a:p xmlns:a="http://schemas.openxmlformats.org/drawingml/2006/main">
+            <a:r>
+              <a:t>CLICK CUES: Click once per definition, then once for the closing connection and next step. Keep earlier definitions visible.</a:t>
             </a:r>
           </a:p>
         </p:txBody>
@@ -1779,6 +1799,81 @@
       </p:ext>
     </p:extLst>
   </p:cSld>
+  <p:timing>
+    <p:tnLst>
+      <p:par>
+        <p:cTn id="1" dur="indefinite" restart="never" nodeType="tmRoot">
+          <p:childTnLst>
+            <p:seq concurrent="1" nextAc="seek">
+              <p:cTn id="2" dur="indefinite" nodeType="mainSeq">
+                <p:childTnLst>
+                  <p:par>
+                    <p:cTn id="3" fill="hold">
+                      <p:stCondLst>
+                        <p:cond delay="indefinite"/>
+                      </p:stCondLst>
+                      <p:childTnLst>
+                        <p:par>
+                          <p:cTn id="4" fill="hold">
+                            <p:stCondLst>
+                              <p:cond delay="0"/>
+                            </p:stCondLst>
+                            <p:childTnLst>
+                              <p:par>
+                                <p:cTn id="5" presetID="1" presetClass="entr" presetSubtype="0" fill="hold" nodeType="clickEffect">
+                                  <p:stCondLst>
+                                    <p:cond delay="0"/>
+                                  </p:stCondLst>
+                                  <p:childTnLst>
+                                    <p:set>
+                                      <p:cBhvr>
+                                        <p:cTn id="6" dur="1" fill="hold">
+                                          <p:stCondLst>
+                                            <p:cond delay="0"/>
+                                          </p:stCondLst>
+                                        </p:cTn>
+                                        <p:tgtEl>
+                                          <p:spTgt spid="4"/>
+                                        </p:tgtEl>
+                                        <p:attrNameLst>
+                                          <p:attrName>style.visibility</p:attrName>
+                                        </p:attrNameLst>
+                                      </p:cBhvr>
+                                      <p:to>
+                                        <p:strVal val="visible"/>
+                                      </p:to>
+                                    </p:set>
+                                  </p:childTnLst>
+                                </p:cTn>
+                              </p:par>
+                            </p:childTnLst>
+                          </p:cTn>
+                        </p:par>
+                      </p:childTnLst>
+                    </p:cTn>
+                  </p:par>
+                </p:childTnLst>
+              </p:cTn>
+              <p:prevCondLst>
+                <p:cond evt="onPrev" delay="0">
+                  <p:tgtEl>
+                    <p:sldTgt/>
+                  </p:tgtEl>
+                </p:cond>
+              </p:prevCondLst>
+              <p:nextCondLst>
+                <p:cond evt="onNext" delay="0">
+                  <p:tgtEl>
+                    <p:sldTgt/>
+                  </p:tgtEl>
+                </p:cond>
+              </p:nextCondLst>
+            </p:seq>
+          </p:childTnLst>
+        </p:cTn>
+      </p:par>
+    </p:tnLst>
+  </p:timing>
 </p:sld>
 </file>
 
@@ -2553,6 +2648,414 @@
       </p:ext>
     </p:extLst>
   </p:cSld>
+  <p:timing>
+    <p:tnLst>
+      <p:par>
+        <p:cTn id="1" dur="indefinite" restart="never" nodeType="tmRoot">
+          <p:childTnLst>
+            <p:seq concurrent="1" nextAc="seek">
+              <p:cTn id="2" dur="indefinite" nodeType="mainSeq">
+                <p:childTnLst>
+                  <p:par>
+                    <p:cTn id="3" fill="hold">
+                      <p:stCondLst>
+                        <p:cond delay="indefinite"/>
+                      </p:stCondLst>
+                      <p:childTnLst>
+                        <p:par>
+                          <p:cTn id="4" fill="hold">
+                            <p:stCondLst>
+                              <p:cond delay="0"/>
+                            </p:stCondLst>
+                            <p:childTnLst>
+                              <p:par>
+                                <p:cTn id="5" presetID="1" presetClass="entr" presetSubtype="0" fill="hold" nodeType="clickEffect">
+                                  <p:stCondLst>
+                                    <p:cond delay="0"/>
+                                  </p:stCondLst>
+                                  <p:childTnLst>
+                                    <p:set>
+                                      <p:cBhvr>
+                                        <p:cTn id="6" dur="1" fill="hold">
+                                          <p:stCondLst>
+                                            <p:cond delay="0"/>
+                                          </p:stCondLst>
+                                        </p:cTn>
+                                        <p:tgtEl>
+                                          <p:spTgt spid="25"/>
+                                        </p:tgtEl>
+                                        <p:attrNameLst>
+                                          <p:attrName>style.visibility</p:attrName>
+                                        </p:attrNameLst>
+                                      </p:cBhvr>
+                                      <p:to>
+                                        <p:strVal val="visible"/>
+                                      </p:to>
+                                    </p:set>
+                                  </p:childTnLst>
+                                </p:cTn>
+                              </p:par>
+                            </p:childTnLst>
+                          </p:cTn>
+                        </p:par>
+                      </p:childTnLst>
+                    </p:cTn>
+                  </p:par>
+                  <p:par>
+                    <p:cTn id="7" fill="hold">
+                      <p:stCondLst>
+                        <p:cond delay="indefinite"/>
+                      </p:stCondLst>
+                      <p:childTnLst>
+                        <p:par>
+                          <p:cTn id="8" fill="hold">
+                            <p:stCondLst>
+                              <p:cond delay="0"/>
+                            </p:stCondLst>
+                            <p:childTnLst>
+                              <p:par>
+                                <p:cTn id="9" presetID="1" presetClass="entr" presetSubtype="0" fill="hold" nodeType="clickEffect">
+                                  <p:stCondLst>
+                                    <p:cond delay="0"/>
+                                  </p:stCondLst>
+                                  <p:childTnLst>
+                                    <p:set>
+                                      <p:cBhvr>
+                                        <p:cTn id="10" dur="1" fill="hold">
+                                          <p:stCondLst>
+                                            <p:cond delay="0"/>
+                                          </p:stCondLst>
+                                        </p:cTn>
+                                        <p:tgtEl>
+                                          <p:spTgt spid="12"/>
+                                        </p:tgtEl>
+                                        <p:attrNameLst>
+                                          <p:attrName>style.visibility</p:attrName>
+                                        </p:attrNameLst>
+                                      </p:cBhvr>
+                                      <p:to>
+                                        <p:strVal val="visible"/>
+                                      </p:to>
+                                    </p:set>
+                                  </p:childTnLst>
+                                </p:cTn>
+                              </p:par>
+                            </p:childTnLst>
+                          </p:cTn>
+                        </p:par>
+                      </p:childTnLst>
+                    </p:cTn>
+                  </p:par>
+                  <p:par>
+                    <p:cTn id="11" fill="hold">
+                      <p:stCondLst>
+                        <p:cond delay="indefinite"/>
+                      </p:stCondLst>
+                      <p:childTnLst>
+                        <p:par>
+                          <p:cTn id="12" fill="hold">
+                            <p:stCondLst>
+                              <p:cond delay="0"/>
+                            </p:stCondLst>
+                            <p:childTnLst>
+                              <p:par>
+                                <p:cTn id="13" presetID="1" presetClass="exit" presetSubtype="0" fill="hold" nodeType="clickEffect">
+                                  <p:stCondLst>
+                                    <p:cond delay="0"/>
+                                  </p:stCondLst>
+                                  <p:childTnLst>
+                                    <p:set>
+                                      <p:cBhvr>
+                                        <p:cTn id="14" dur="1" fill="hold">
+                                          <p:stCondLst>
+                                            <p:cond delay="0"/>
+                                          </p:stCondLst>
+                                        </p:cTn>
+                                        <p:tgtEl>
+                                          <p:spTgt spid="25"/>
+                                        </p:tgtEl>
+                                        <p:attrNameLst>
+                                          <p:attrName>style.visibility</p:attrName>
+                                        </p:attrNameLst>
+                                      </p:cBhvr>
+                                      <p:to>
+                                        <p:strVal val="hidden"/>
+                                      </p:to>
+                                    </p:set>
+                                  </p:childTnLst>
+                                </p:cTn>
+                              </p:par>
+                              <p:par>
+                                <p:cTn id="15" presetID="1" presetClass="exit" presetSubtype="0" fill="hold" nodeType="withEffect">
+                                  <p:stCondLst>
+                                    <p:cond delay="0"/>
+                                  </p:stCondLst>
+                                  <p:childTnLst>
+                                    <p:set>
+                                      <p:cBhvr>
+                                        <p:cTn id="16" dur="1" fill="hold">
+                                          <p:stCondLst>
+                                            <p:cond delay="0"/>
+                                          </p:stCondLst>
+                                        </p:cTn>
+                                        <p:tgtEl>
+                                          <p:spTgt spid="12"/>
+                                        </p:tgtEl>
+                                        <p:attrNameLst>
+                                          <p:attrName>style.visibility</p:attrName>
+                                        </p:attrNameLst>
+                                      </p:cBhvr>
+                                      <p:to>
+                                        <p:strVal val="hidden"/>
+                                      </p:to>
+                                    </p:set>
+                                  </p:childTnLst>
+                                </p:cTn>
+                              </p:par>
+                              <p:par>
+                                <p:cTn id="17" presetID="1" presetClass="entr" presetSubtype="0" fill="hold" nodeType="withEffect">
+                                  <p:stCondLst>
+                                    <p:cond delay="0"/>
+                                  </p:stCondLst>
+                                  <p:childTnLst>
+                                    <p:set>
+                                      <p:cBhvr>
+                                        <p:cTn id="18" dur="1" fill="hold">
+                                          <p:stCondLst>
+                                            <p:cond delay="0"/>
+                                          </p:stCondLst>
+                                        </p:cTn>
+                                        <p:tgtEl>
+                                          <p:spTgt spid="26"/>
+                                        </p:tgtEl>
+                                        <p:attrNameLst>
+                                          <p:attrName>style.visibility</p:attrName>
+                                        </p:attrNameLst>
+                                      </p:cBhvr>
+                                      <p:to>
+                                        <p:strVal val="visible"/>
+                                      </p:to>
+                                    </p:set>
+                                  </p:childTnLst>
+                                </p:cTn>
+                              </p:par>
+                            </p:childTnLst>
+                          </p:cTn>
+                        </p:par>
+                      </p:childTnLst>
+                    </p:cTn>
+                  </p:par>
+                  <p:par>
+                    <p:cTn id="19" fill="hold">
+                      <p:stCondLst>
+                        <p:cond delay="indefinite"/>
+                      </p:stCondLst>
+                      <p:childTnLst>
+                        <p:par>
+                          <p:cTn id="20" fill="hold">
+                            <p:stCondLst>
+                              <p:cond delay="0"/>
+                            </p:stCondLst>
+                            <p:childTnLst>
+                              <p:par>
+                                <p:cTn id="21" presetID="1" presetClass="entr" presetSubtype="0" fill="hold" nodeType="clickEffect">
+                                  <p:stCondLst>
+                                    <p:cond delay="0"/>
+                                  </p:stCondLst>
+                                  <p:childTnLst>
+                                    <p:set>
+                                      <p:cBhvr>
+                                        <p:cTn id="22" dur="1" fill="hold">
+                                          <p:stCondLst>
+                                            <p:cond delay="0"/>
+                                          </p:stCondLst>
+                                        </p:cTn>
+                                        <p:tgtEl>
+                                          <p:spTgt spid="13"/>
+                                        </p:tgtEl>
+                                        <p:attrNameLst>
+                                          <p:attrName>style.visibility</p:attrName>
+                                        </p:attrNameLst>
+                                      </p:cBhvr>
+                                      <p:to>
+                                        <p:strVal val="visible"/>
+                                      </p:to>
+                                    </p:set>
+                                  </p:childTnLst>
+                                </p:cTn>
+                              </p:par>
+                            </p:childTnLst>
+                          </p:cTn>
+                        </p:par>
+                      </p:childTnLst>
+                    </p:cTn>
+                  </p:par>
+                  <p:par>
+                    <p:cTn id="23" fill="hold">
+                      <p:stCondLst>
+                        <p:cond delay="indefinite"/>
+                      </p:stCondLst>
+                      <p:childTnLst>
+                        <p:par>
+                          <p:cTn id="24" fill="hold">
+                            <p:stCondLst>
+                              <p:cond delay="0"/>
+                            </p:stCondLst>
+                            <p:childTnLst>
+                              <p:par>
+                                <p:cTn id="25" presetID="1" presetClass="exit" presetSubtype="0" fill="hold" nodeType="clickEffect">
+                                  <p:stCondLst>
+                                    <p:cond delay="0"/>
+                                  </p:stCondLst>
+                                  <p:childTnLst>
+                                    <p:set>
+                                      <p:cBhvr>
+                                        <p:cTn id="26" dur="1" fill="hold">
+                                          <p:stCondLst>
+                                            <p:cond delay="0"/>
+                                          </p:stCondLst>
+                                        </p:cTn>
+                                        <p:tgtEl>
+                                          <p:spTgt spid="26"/>
+                                        </p:tgtEl>
+                                        <p:attrNameLst>
+                                          <p:attrName>style.visibility</p:attrName>
+                                        </p:attrNameLst>
+                                      </p:cBhvr>
+                                      <p:to>
+                                        <p:strVal val="hidden"/>
+                                      </p:to>
+                                    </p:set>
+                                  </p:childTnLst>
+                                </p:cTn>
+                              </p:par>
+                              <p:par>
+                                <p:cTn id="27" presetID="1" presetClass="exit" presetSubtype="0" fill="hold" nodeType="withEffect">
+                                  <p:stCondLst>
+                                    <p:cond delay="0"/>
+                                  </p:stCondLst>
+                                  <p:childTnLst>
+                                    <p:set>
+                                      <p:cBhvr>
+                                        <p:cTn id="28" dur="1" fill="hold">
+                                          <p:stCondLst>
+                                            <p:cond delay="0"/>
+                                          </p:stCondLst>
+                                        </p:cTn>
+                                        <p:tgtEl>
+                                          <p:spTgt spid="13"/>
+                                        </p:tgtEl>
+                                        <p:attrNameLst>
+                                          <p:attrName>style.visibility</p:attrName>
+                                        </p:attrNameLst>
+                                      </p:cBhvr>
+                                      <p:to>
+                                        <p:strVal val="hidden"/>
+                                      </p:to>
+                                    </p:set>
+                                  </p:childTnLst>
+                                </p:cTn>
+                              </p:par>
+                              <p:par>
+                                <p:cTn id="29" presetID="1" presetClass="entr" presetSubtype="0" fill="hold" nodeType="withEffect">
+                                  <p:stCondLst>
+                                    <p:cond delay="0"/>
+                                  </p:stCondLst>
+                                  <p:childTnLst>
+                                    <p:set>
+                                      <p:cBhvr>
+                                        <p:cTn id="30" dur="1" fill="hold">
+                                          <p:stCondLst>
+                                            <p:cond delay="0"/>
+                                          </p:stCondLst>
+                                        </p:cTn>
+                                        <p:tgtEl>
+                                          <p:spTgt spid="27"/>
+                                        </p:tgtEl>
+                                        <p:attrNameLst>
+                                          <p:attrName>style.visibility</p:attrName>
+                                        </p:attrNameLst>
+                                      </p:cBhvr>
+                                      <p:to>
+                                        <p:strVal val="visible"/>
+                                      </p:to>
+                                    </p:set>
+                                  </p:childTnLst>
+                                </p:cTn>
+                              </p:par>
+                            </p:childTnLst>
+                          </p:cTn>
+                        </p:par>
+                      </p:childTnLst>
+                    </p:cTn>
+                  </p:par>
+                  <p:par>
+                    <p:cTn id="31" fill="hold">
+                      <p:stCondLst>
+                        <p:cond delay="indefinite"/>
+                      </p:stCondLst>
+                      <p:childTnLst>
+                        <p:par>
+                          <p:cTn id="32" fill="hold">
+                            <p:stCondLst>
+                              <p:cond delay="0"/>
+                            </p:stCondLst>
+                            <p:childTnLst>
+                              <p:par>
+                                <p:cTn id="33" presetID="1" presetClass="entr" presetSubtype="0" fill="hold" nodeType="clickEffect">
+                                  <p:stCondLst>
+                                    <p:cond delay="0"/>
+                                  </p:stCondLst>
+                                  <p:childTnLst>
+                                    <p:set>
+                                      <p:cBhvr>
+                                        <p:cTn id="34" dur="1" fill="hold">
+                                          <p:stCondLst>
+                                            <p:cond delay="0"/>
+                                          </p:stCondLst>
+                                        </p:cTn>
+                                        <p:tgtEl>
+                                          <p:spTgt spid="14"/>
+                                        </p:tgtEl>
+                                        <p:attrNameLst>
+                                          <p:attrName>style.visibility</p:attrName>
+                                        </p:attrNameLst>
+                                      </p:cBhvr>
+                                      <p:to>
+                                        <p:strVal val="visible"/>
+                                      </p:to>
+                                    </p:set>
+                                  </p:childTnLst>
+                                </p:cTn>
+                              </p:par>
+                            </p:childTnLst>
+                          </p:cTn>
+                        </p:par>
+                      </p:childTnLst>
+                    </p:cTn>
+                  </p:par>
+                </p:childTnLst>
+              </p:cTn>
+              <p:prevCondLst>
+                <p:cond evt="onPrev" delay="0">
+                  <p:tgtEl>
+                    <p:sldTgt/>
+                  </p:tgtEl>
+                </p:cond>
+              </p:prevCondLst>
+              <p:nextCondLst>
+                <p:cond evt="onNext" delay="0">
+                  <p:tgtEl>
+                    <p:sldTgt/>
+                  </p:tgtEl>
+                </p:cond>
+              </p:nextCondLst>
+            </p:seq>
+          </p:childTnLst>
+        </p:cTn>
+      </p:par>
+    </p:tnLst>
+  </p:timing>
 </p:sld>
 </file>
 
@@ -3627,6 +4130,486 @@
       </p:ext>
     </p:extLst>
   </p:cSld>
+  <p:timing>
+    <p:tnLst>
+      <p:par>
+        <p:cTn id="1" dur="indefinite" restart="never" nodeType="tmRoot">
+          <p:childTnLst>
+            <p:seq concurrent="1" nextAc="seek">
+              <p:cTn id="2" dur="indefinite" nodeType="mainSeq">
+                <p:childTnLst>
+                  <p:par>
+                    <p:cTn id="3" fill="hold">
+                      <p:stCondLst>
+                        <p:cond delay="indefinite"/>
+                      </p:stCondLst>
+                      <p:childTnLst>
+                        <p:par>
+                          <p:cTn id="4" fill="hold">
+                            <p:stCondLst>
+                              <p:cond delay="0"/>
+                            </p:stCondLst>
+                            <p:childTnLst>
+                              <p:par>
+                                <p:cTn id="5" presetID="1" presetClass="entr" presetSubtype="0" fill="hold" nodeType="clickEffect">
+                                  <p:stCondLst>
+                                    <p:cond delay="0"/>
+                                  </p:stCondLst>
+                                  <p:childTnLst>
+                                    <p:set>
+                                      <p:cBhvr>
+                                        <p:cTn id="6" dur="1" fill="hold">
+                                          <p:stCondLst>
+                                            <p:cond delay="0"/>
+                                          </p:stCondLst>
+                                        </p:cTn>
+                                        <p:tgtEl>
+                                          <p:spTgt spid="8"/>
+                                        </p:tgtEl>
+                                        <p:attrNameLst>
+                                          <p:attrName>style.visibility</p:attrName>
+                                        </p:attrNameLst>
+                                      </p:cBhvr>
+                                      <p:to>
+                                        <p:strVal val="visible"/>
+                                      </p:to>
+                                    </p:set>
+                                  </p:childTnLst>
+                                </p:cTn>
+                              </p:par>
+                              <p:par>
+                                <p:cTn id="7" presetID="1" presetClass="entr" presetSubtype="0" fill="hold" nodeType="withEffect">
+                                  <p:stCondLst>
+                                    <p:cond delay="0"/>
+                                  </p:stCondLst>
+                                  <p:childTnLst>
+                                    <p:set>
+                                      <p:cBhvr>
+                                        <p:cTn id="8" dur="1" fill="hold">
+                                          <p:stCondLst>
+                                            <p:cond delay="0"/>
+                                          </p:stCondLst>
+                                        </p:cTn>
+                                        <p:tgtEl>
+                                          <p:spTgt spid="9"/>
+                                        </p:tgtEl>
+                                        <p:attrNameLst>
+                                          <p:attrName>style.visibility</p:attrName>
+                                        </p:attrNameLst>
+                                      </p:cBhvr>
+                                      <p:to>
+                                        <p:strVal val="visible"/>
+                                      </p:to>
+                                    </p:set>
+                                  </p:childTnLst>
+                                </p:cTn>
+                              </p:par>
+                              <p:par>
+                                <p:cTn id="9" presetID="1" presetClass="entr" presetSubtype="0" fill="hold" nodeType="withEffect">
+                                  <p:stCondLst>
+                                    <p:cond delay="0"/>
+                                  </p:stCondLst>
+                                  <p:childTnLst>
+                                    <p:set>
+                                      <p:cBhvr>
+                                        <p:cTn id="10" dur="1" fill="hold">
+                                          <p:stCondLst>
+                                            <p:cond delay="0"/>
+                                          </p:stCondLst>
+                                        </p:cTn>
+                                        <p:tgtEl>
+                                          <p:spTgt spid="10"/>
+                                        </p:tgtEl>
+                                        <p:attrNameLst>
+                                          <p:attrName>style.visibility</p:attrName>
+                                        </p:attrNameLst>
+                                      </p:cBhvr>
+                                      <p:to>
+                                        <p:strVal val="visible"/>
+                                      </p:to>
+                                    </p:set>
+                                  </p:childTnLst>
+                                </p:cTn>
+                              </p:par>
+                              <p:par>
+                                <p:cTn id="11" presetID="1" presetClass="entr" presetSubtype="0" fill="hold" nodeType="withEffect">
+                                  <p:stCondLst>
+                                    <p:cond delay="0"/>
+                                  </p:stCondLst>
+                                  <p:childTnLst>
+                                    <p:set>
+                                      <p:cBhvr>
+                                        <p:cTn id="12" dur="1" fill="hold">
+                                          <p:stCondLst>
+                                            <p:cond delay="0"/>
+                                          </p:stCondLst>
+                                        </p:cTn>
+                                        <p:tgtEl>
+                                          <p:spTgt spid="11"/>
+                                        </p:tgtEl>
+                                        <p:attrNameLst>
+                                          <p:attrName>style.visibility</p:attrName>
+                                        </p:attrNameLst>
+                                      </p:cBhvr>
+                                      <p:to>
+                                        <p:strVal val="visible"/>
+                                      </p:to>
+                                    </p:set>
+                                  </p:childTnLst>
+                                </p:cTn>
+                              </p:par>
+                            </p:childTnLst>
+                          </p:cTn>
+                        </p:par>
+                      </p:childTnLst>
+                    </p:cTn>
+                  </p:par>
+                  <p:par>
+                    <p:cTn id="13" fill="hold">
+                      <p:stCondLst>
+                        <p:cond delay="indefinite"/>
+                      </p:stCondLst>
+                      <p:childTnLst>
+                        <p:par>
+                          <p:cTn id="14" fill="hold">
+                            <p:stCondLst>
+                              <p:cond delay="0"/>
+                            </p:stCondLst>
+                            <p:childTnLst>
+                              <p:par>
+                                <p:cTn id="15" presetID="1" presetClass="entr" presetSubtype="0" fill="hold" nodeType="clickEffect">
+                                  <p:stCondLst>
+                                    <p:cond delay="0"/>
+                                  </p:stCondLst>
+                                  <p:childTnLst>
+                                    <p:set>
+                                      <p:cBhvr>
+                                        <p:cTn id="16" dur="1" fill="hold">
+                                          <p:stCondLst>
+                                            <p:cond delay="0"/>
+                                          </p:stCondLst>
+                                        </p:cTn>
+                                        <p:tgtEl>
+                                          <p:spTgt spid="12"/>
+                                        </p:tgtEl>
+                                        <p:attrNameLst>
+                                          <p:attrName>style.visibility</p:attrName>
+                                        </p:attrNameLst>
+                                      </p:cBhvr>
+                                      <p:to>
+                                        <p:strVal val="visible"/>
+                                      </p:to>
+                                    </p:set>
+                                  </p:childTnLst>
+                                </p:cTn>
+                              </p:par>
+                              <p:par>
+                                <p:cTn id="17" presetID="1" presetClass="entr" presetSubtype="0" fill="hold" nodeType="withEffect">
+                                  <p:stCondLst>
+                                    <p:cond delay="0"/>
+                                  </p:stCondLst>
+                                  <p:childTnLst>
+                                    <p:set>
+                                      <p:cBhvr>
+                                        <p:cTn id="18" dur="1" fill="hold">
+                                          <p:stCondLst>
+                                            <p:cond delay="0"/>
+                                          </p:stCondLst>
+                                        </p:cTn>
+                                        <p:tgtEl>
+                                          <p:spTgt spid="13"/>
+                                        </p:tgtEl>
+                                        <p:attrNameLst>
+                                          <p:attrName>style.visibility</p:attrName>
+                                        </p:attrNameLst>
+                                      </p:cBhvr>
+                                      <p:to>
+                                        <p:strVal val="visible"/>
+                                      </p:to>
+                                    </p:set>
+                                  </p:childTnLst>
+                                </p:cTn>
+                              </p:par>
+                              <p:par>
+                                <p:cTn id="19" presetID="1" presetClass="entr" presetSubtype="0" fill="hold" nodeType="withEffect">
+                                  <p:stCondLst>
+                                    <p:cond delay="0"/>
+                                  </p:stCondLst>
+                                  <p:childTnLst>
+                                    <p:set>
+                                      <p:cBhvr>
+                                        <p:cTn id="20" dur="1" fill="hold">
+                                          <p:stCondLst>
+                                            <p:cond delay="0"/>
+                                          </p:stCondLst>
+                                        </p:cTn>
+                                        <p:tgtEl>
+                                          <p:spTgt spid="14"/>
+                                        </p:tgtEl>
+                                        <p:attrNameLst>
+                                          <p:attrName>style.visibility</p:attrName>
+                                        </p:attrNameLst>
+                                      </p:cBhvr>
+                                      <p:to>
+                                        <p:strVal val="visible"/>
+                                      </p:to>
+                                    </p:set>
+                                  </p:childTnLst>
+                                </p:cTn>
+                              </p:par>
+                              <p:par>
+                                <p:cTn id="21" presetID="1" presetClass="entr" presetSubtype="0" fill="hold" nodeType="withEffect">
+                                  <p:stCondLst>
+                                    <p:cond delay="0"/>
+                                  </p:stCondLst>
+                                  <p:childTnLst>
+                                    <p:set>
+                                      <p:cBhvr>
+                                        <p:cTn id="22" dur="1" fill="hold">
+                                          <p:stCondLst>
+                                            <p:cond delay="0"/>
+                                          </p:stCondLst>
+                                        </p:cTn>
+                                        <p:tgtEl>
+                                          <p:spTgt spid="15"/>
+                                        </p:tgtEl>
+                                        <p:attrNameLst>
+                                          <p:attrName>style.visibility</p:attrName>
+                                        </p:attrNameLst>
+                                      </p:cBhvr>
+                                      <p:to>
+                                        <p:strVal val="visible"/>
+                                      </p:to>
+                                    </p:set>
+                                  </p:childTnLst>
+                                </p:cTn>
+                              </p:par>
+                            </p:childTnLst>
+                          </p:cTn>
+                        </p:par>
+                      </p:childTnLst>
+                    </p:cTn>
+                  </p:par>
+                  <p:par>
+                    <p:cTn id="23" fill="hold">
+                      <p:stCondLst>
+                        <p:cond delay="indefinite"/>
+                      </p:stCondLst>
+                      <p:childTnLst>
+                        <p:par>
+                          <p:cTn id="24" fill="hold">
+                            <p:stCondLst>
+                              <p:cond delay="0"/>
+                            </p:stCondLst>
+                            <p:childTnLst>
+                              <p:par>
+                                <p:cTn id="25" presetID="1" presetClass="entr" presetSubtype="0" fill="hold" nodeType="clickEffect">
+                                  <p:stCondLst>
+                                    <p:cond delay="0"/>
+                                  </p:stCondLst>
+                                  <p:childTnLst>
+                                    <p:set>
+                                      <p:cBhvr>
+                                        <p:cTn id="26" dur="1" fill="hold">
+                                          <p:stCondLst>
+                                            <p:cond delay="0"/>
+                                          </p:stCondLst>
+                                        </p:cTn>
+                                        <p:tgtEl>
+                                          <p:spTgt spid="16"/>
+                                        </p:tgtEl>
+                                        <p:attrNameLst>
+                                          <p:attrName>style.visibility</p:attrName>
+                                        </p:attrNameLst>
+                                      </p:cBhvr>
+                                      <p:to>
+                                        <p:strVal val="visible"/>
+                                      </p:to>
+                                    </p:set>
+                                  </p:childTnLst>
+                                </p:cTn>
+                              </p:par>
+                              <p:par>
+                                <p:cTn id="27" presetID="1" presetClass="entr" presetSubtype="0" fill="hold" nodeType="withEffect">
+                                  <p:stCondLst>
+                                    <p:cond delay="0"/>
+                                  </p:stCondLst>
+                                  <p:childTnLst>
+                                    <p:set>
+                                      <p:cBhvr>
+                                        <p:cTn id="28" dur="1" fill="hold">
+                                          <p:stCondLst>
+                                            <p:cond delay="0"/>
+                                          </p:stCondLst>
+                                        </p:cTn>
+                                        <p:tgtEl>
+                                          <p:spTgt spid="17"/>
+                                        </p:tgtEl>
+                                        <p:attrNameLst>
+                                          <p:attrName>style.visibility</p:attrName>
+                                        </p:attrNameLst>
+                                      </p:cBhvr>
+                                      <p:to>
+                                        <p:strVal val="visible"/>
+                                      </p:to>
+                                    </p:set>
+                                  </p:childTnLst>
+                                </p:cTn>
+                              </p:par>
+                              <p:par>
+                                <p:cTn id="29" presetID="1" presetClass="entr" presetSubtype="0" fill="hold" nodeType="withEffect">
+                                  <p:stCondLst>
+                                    <p:cond delay="0"/>
+                                  </p:stCondLst>
+                                  <p:childTnLst>
+                                    <p:set>
+                                      <p:cBhvr>
+                                        <p:cTn id="30" dur="1" fill="hold">
+                                          <p:stCondLst>
+                                            <p:cond delay="0"/>
+                                          </p:stCondLst>
+                                        </p:cTn>
+                                        <p:tgtEl>
+                                          <p:spTgt spid="18"/>
+                                        </p:tgtEl>
+                                        <p:attrNameLst>
+                                          <p:attrName>style.visibility</p:attrName>
+                                        </p:attrNameLst>
+                                      </p:cBhvr>
+                                      <p:to>
+                                        <p:strVal val="visible"/>
+                                      </p:to>
+                                    </p:set>
+                                  </p:childTnLst>
+                                </p:cTn>
+                              </p:par>
+                              <p:par>
+                                <p:cTn id="31" presetID="1" presetClass="entr" presetSubtype="0" fill="hold" nodeType="withEffect">
+                                  <p:stCondLst>
+                                    <p:cond delay="0"/>
+                                  </p:stCondLst>
+                                  <p:childTnLst>
+                                    <p:set>
+                                      <p:cBhvr>
+                                        <p:cTn id="32" dur="1" fill="hold">
+                                          <p:stCondLst>
+                                            <p:cond delay="0"/>
+                                          </p:stCondLst>
+                                        </p:cTn>
+                                        <p:tgtEl>
+                                          <p:spTgt spid="19"/>
+                                        </p:tgtEl>
+                                        <p:attrNameLst>
+                                          <p:attrName>style.visibility</p:attrName>
+                                        </p:attrNameLst>
+                                      </p:cBhvr>
+                                      <p:to>
+                                        <p:strVal val="visible"/>
+                                      </p:to>
+                                    </p:set>
+                                  </p:childTnLst>
+                                </p:cTn>
+                              </p:par>
+                            </p:childTnLst>
+                          </p:cTn>
+                        </p:par>
+                      </p:childTnLst>
+                    </p:cTn>
+                  </p:par>
+                  <p:par>
+                    <p:cTn id="33" fill="hold">
+                      <p:stCondLst>
+                        <p:cond delay="indefinite"/>
+                      </p:stCondLst>
+                      <p:childTnLst>
+                        <p:par>
+                          <p:cTn id="34" fill="hold">
+                            <p:stCondLst>
+                              <p:cond delay="0"/>
+                            </p:stCondLst>
+                            <p:childTnLst>
+                              <p:par>
+                                <p:cTn id="35" presetID="1" presetClass="entr" presetSubtype="0" fill="hold" nodeType="clickEffect">
+                                  <p:stCondLst>
+                                    <p:cond delay="0"/>
+                                  </p:stCondLst>
+                                  <p:childTnLst>
+                                    <p:set>
+                                      <p:cBhvr>
+                                        <p:cTn id="36" dur="1" fill="hold">
+                                          <p:stCondLst>
+                                            <p:cond delay="0"/>
+                                          </p:stCondLst>
+                                        </p:cTn>
+                                        <p:tgtEl>
+                                          <p:spTgt spid="20"/>
+                                        </p:tgtEl>
+                                        <p:attrNameLst>
+                                          <p:attrName>style.visibility</p:attrName>
+                                        </p:attrNameLst>
+                                      </p:cBhvr>
+                                      <p:to>
+                                        <p:strVal val="visible"/>
+                                      </p:to>
+                                    </p:set>
+                                  </p:childTnLst>
+                                </p:cTn>
+                              </p:par>
+                              <p:par>
+                                <p:cTn id="37" presetID="1" presetClass="entr" presetSubtype="0" fill="hold" nodeType="withEffect">
+                                  <p:stCondLst>
+                                    <p:cond delay="0"/>
+                                  </p:stCondLst>
+                                  <p:childTnLst>
+                                    <p:set>
+                                      <p:cBhvr>
+                                        <p:cTn id="38" dur="1" fill="hold">
+                                          <p:stCondLst>
+                                            <p:cond delay="0"/>
+                                          </p:stCondLst>
+                                        </p:cTn>
+                                        <p:tgtEl>
+                                          <p:spTgt spid="21"/>
+                                        </p:tgtEl>
+                                        <p:attrNameLst>
+                                          <p:attrName>style.visibility</p:attrName>
+                                        </p:attrNameLst>
+                                      </p:cBhvr>
+                                      <p:to>
+                                        <p:strVal val="visible"/>
+                                      </p:to>
+                                    </p:set>
+                                  </p:childTnLst>
+                                </p:cTn>
+                              </p:par>
+                            </p:childTnLst>
+                          </p:cTn>
+                        </p:par>
+                      </p:childTnLst>
+                    </p:cTn>
+                  </p:par>
+                </p:childTnLst>
+              </p:cTn>
+              <p:prevCondLst>
+                <p:cond evt="onPrev" delay="0">
+                  <p:tgtEl>
+                    <p:sldTgt/>
+                  </p:tgtEl>
+                </p:cond>
+              </p:prevCondLst>
+              <p:nextCondLst>
+                <p:cond evt="onNext" delay="0">
+                  <p:tgtEl>
+                    <p:sldTgt/>
+                  </p:tgtEl>
+                </p:cond>
+              </p:nextCondLst>
+            </p:seq>
+          </p:childTnLst>
+        </p:cTn>
+      </p:par>
+    </p:tnLst>
+  </p:timing>
 </p:sld>
 </file>
 
@@ -4758,6 +5741,513 @@
       </p:ext>
     </p:extLst>
   </p:cSld>
+  <p:timing>
+    <p:tnLst>
+      <p:par>
+        <p:cTn id="1" dur="indefinite" restart="never" nodeType="tmRoot">
+          <p:childTnLst>
+            <p:seq concurrent="1" nextAc="seek">
+              <p:cTn id="2" dur="indefinite" nodeType="mainSeq">
+                <p:childTnLst>
+                  <p:par>
+                    <p:cTn id="3" fill="hold">
+                      <p:stCondLst>
+                        <p:cond delay="indefinite"/>
+                      </p:stCondLst>
+                      <p:childTnLst>
+                        <p:par>
+                          <p:cTn id="4" fill="hold">
+                            <p:stCondLst>
+                              <p:cond delay="0"/>
+                            </p:stCondLst>
+                            <p:childTnLst>
+                              <p:par>
+                                <p:cTn id="5" presetID="1" presetClass="entr" presetSubtype="0" fill="hold" nodeType="clickEffect">
+                                  <p:stCondLst>
+                                    <p:cond delay="0"/>
+                                  </p:stCondLst>
+                                  <p:childTnLst>
+                                    <p:set>
+                                      <p:cBhvr>
+                                        <p:cTn id="6" dur="1" fill="hold">
+                                          <p:stCondLst>
+                                            <p:cond delay="0"/>
+                                          </p:stCondLst>
+                                        </p:cTn>
+                                        <p:tgtEl>
+                                          <p:spTgt spid="8"/>
+                                        </p:tgtEl>
+                                        <p:attrNameLst>
+                                          <p:attrName>style.visibility</p:attrName>
+                                        </p:attrNameLst>
+                                      </p:cBhvr>
+                                      <p:to>
+                                        <p:strVal val="visible"/>
+                                      </p:to>
+                                    </p:set>
+                                  </p:childTnLst>
+                                </p:cTn>
+                              </p:par>
+                              <p:par>
+                                <p:cTn id="7" presetID="1" presetClass="entr" presetSubtype="0" fill="hold" nodeType="withEffect">
+                                  <p:stCondLst>
+                                    <p:cond delay="0"/>
+                                  </p:stCondLst>
+                                  <p:childTnLst>
+                                    <p:set>
+                                      <p:cBhvr>
+                                        <p:cTn id="8" dur="1" fill="hold">
+                                          <p:stCondLst>
+                                            <p:cond delay="0"/>
+                                          </p:stCondLst>
+                                        </p:cTn>
+                                        <p:tgtEl>
+                                          <p:spTgt spid="9"/>
+                                        </p:tgtEl>
+                                        <p:attrNameLst>
+                                          <p:attrName>style.visibility</p:attrName>
+                                        </p:attrNameLst>
+                                      </p:cBhvr>
+                                      <p:to>
+                                        <p:strVal val="visible"/>
+                                      </p:to>
+                                    </p:set>
+                                  </p:childTnLst>
+                                </p:cTn>
+                              </p:par>
+                              <p:par>
+                                <p:cTn id="9" presetID="1" presetClass="entr" presetSubtype="0" fill="hold" nodeType="withEffect">
+                                  <p:stCondLst>
+                                    <p:cond delay="0"/>
+                                  </p:stCondLst>
+                                  <p:childTnLst>
+                                    <p:set>
+                                      <p:cBhvr>
+                                        <p:cTn id="10" dur="1" fill="hold">
+                                          <p:stCondLst>
+                                            <p:cond delay="0"/>
+                                          </p:stCondLst>
+                                        </p:cTn>
+                                        <p:tgtEl>
+                                          <p:spTgt spid="10"/>
+                                        </p:tgtEl>
+                                        <p:attrNameLst>
+                                          <p:attrName>style.visibility</p:attrName>
+                                        </p:attrNameLst>
+                                      </p:cBhvr>
+                                      <p:to>
+                                        <p:strVal val="visible"/>
+                                      </p:to>
+                                    </p:set>
+                                  </p:childTnLst>
+                                </p:cTn>
+                              </p:par>
+                              <p:par>
+                                <p:cTn id="11" presetID="1" presetClass="entr" presetSubtype="0" fill="hold" nodeType="withEffect">
+                                  <p:stCondLst>
+                                    <p:cond delay="0"/>
+                                  </p:stCondLst>
+                                  <p:childTnLst>
+                                    <p:set>
+                                      <p:cBhvr>
+                                        <p:cTn id="12" dur="1" fill="hold">
+                                          <p:stCondLst>
+                                            <p:cond delay="0"/>
+                                          </p:stCondLst>
+                                        </p:cTn>
+                                        <p:tgtEl>
+                                          <p:spTgt spid="11"/>
+                                        </p:tgtEl>
+                                        <p:attrNameLst>
+                                          <p:attrName>style.visibility</p:attrName>
+                                        </p:attrNameLst>
+                                      </p:cBhvr>
+                                      <p:to>
+                                        <p:strVal val="visible"/>
+                                      </p:to>
+                                    </p:set>
+                                  </p:childTnLst>
+                                </p:cTn>
+                              </p:par>
+                            </p:childTnLst>
+                          </p:cTn>
+                        </p:par>
+                      </p:childTnLst>
+                    </p:cTn>
+                  </p:par>
+                  <p:par>
+                    <p:cTn id="13" fill="hold">
+                      <p:stCondLst>
+                        <p:cond delay="indefinite"/>
+                      </p:stCondLst>
+                      <p:childTnLst>
+                        <p:par>
+                          <p:cTn id="14" fill="hold">
+                            <p:stCondLst>
+                              <p:cond delay="0"/>
+                            </p:stCondLst>
+                            <p:childTnLst>
+                              <p:par>
+                                <p:cTn id="15" presetID="1" presetClass="entr" presetSubtype="0" fill="hold" nodeType="clickEffect">
+                                  <p:stCondLst>
+                                    <p:cond delay="0"/>
+                                  </p:stCondLst>
+                                  <p:childTnLst>
+                                    <p:set>
+                                      <p:cBhvr>
+                                        <p:cTn id="16" dur="1" fill="hold">
+                                          <p:stCondLst>
+                                            <p:cond delay="0"/>
+                                          </p:stCondLst>
+                                        </p:cTn>
+                                        <p:tgtEl>
+                                          <p:spTgt spid="12"/>
+                                        </p:tgtEl>
+                                        <p:attrNameLst>
+                                          <p:attrName>style.visibility</p:attrName>
+                                        </p:attrNameLst>
+                                      </p:cBhvr>
+                                      <p:to>
+                                        <p:strVal val="visible"/>
+                                      </p:to>
+                                    </p:set>
+                                  </p:childTnLst>
+                                </p:cTn>
+                              </p:par>
+                              <p:par>
+                                <p:cTn id="17" presetID="1" presetClass="entr" presetSubtype="0" fill="hold" nodeType="withEffect">
+                                  <p:stCondLst>
+                                    <p:cond delay="0"/>
+                                  </p:stCondLst>
+                                  <p:childTnLst>
+                                    <p:set>
+                                      <p:cBhvr>
+                                        <p:cTn id="18" dur="1" fill="hold">
+                                          <p:stCondLst>
+                                            <p:cond delay="0"/>
+                                          </p:stCondLst>
+                                        </p:cTn>
+                                        <p:tgtEl>
+                                          <p:spTgt spid="13"/>
+                                        </p:tgtEl>
+                                        <p:attrNameLst>
+                                          <p:attrName>style.visibility</p:attrName>
+                                        </p:attrNameLst>
+                                      </p:cBhvr>
+                                      <p:to>
+                                        <p:strVal val="visible"/>
+                                      </p:to>
+                                    </p:set>
+                                  </p:childTnLst>
+                                </p:cTn>
+                              </p:par>
+                              <p:par>
+                                <p:cTn id="19" presetID="1" presetClass="entr" presetSubtype="0" fill="hold" nodeType="withEffect">
+                                  <p:stCondLst>
+                                    <p:cond delay="0"/>
+                                  </p:stCondLst>
+                                  <p:childTnLst>
+                                    <p:set>
+                                      <p:cBhvr>
+                                        <p:cTn id="20" dur="1" fill="hold">
+                                          <p:stCondLst>
+                                            <p:cond delay="0"/>
+                                          </p:stCondLst>
+                                        </p:cTn>
+                                        <p:tgtEl>
+                                          <p:spTgt spid="14"/>
+                                        </p:tgtEl>
+                                        <p:attrNameLst>
+                                          <p:attrName>style.visibility</p:attrName>
+                                        </p:attrNameLst>
+                                      </p:cBhvr>
+                                      <p:to>
+                                        <p:strVal val="visible"/>
+                                      </p:to>
+                                    </p:set>
+                                  </p:childTnLst>
+                                </p:cTn>
+                              </p:par>
+                              <p:par>
+                                <p:cTn id="21" presetID="1" presetClass="entr" presetSubtype="0" fill="hold" nodeType="withEffect">
+                                  <p:stCondLst>
+                                    <p:cond delay="0"/>
+                                  </p:stCondLst>
+                                  <p:childTnLst>
+                                    <p:set>
+                                      <p:cBhvr>
+                                        <p:cTn id="22" dur="1" fill="hold">
+                                          <p:stCondLst>
+                                            <p:cond delay="0"/>
+                                          </p:stCondLst>
+                                        </p:cTn>
+                                        <p:tgtEl>
+                                          <p:spTgt spid="15"/>
+                                        </p:tgtEl>
+                                        <p:attrNameLst>
+                                          <p:attrName>style.visibility</p:attrName>
+                                        </p:attrNameLst>
+                                      </p:cBhvr>
+                                      <p:to>
+                                        <p:strVal val="visible"/>
+                                      </p:to>
+                                    </p:set>
+                                  </p:childTnLst>
+                                </p:cTn>
+                              </p:par>
+                            </p:childTnLst>
+                          </p:cTn>
+                        </p:par>
+                      </p:childTnLst>
+                    </p:cTn>
+                  </p:par>
+                  <p:par>
+                    <p:cTn id="23" fill="hold">
+                      <p:stCondLst>
+                        <p:cond delay="indefinite"/>
+                      </p:stCondLst>
+                      <p:childTnLst>
+                        <p:par>
+                          <p:cTn id="24" fill="hold">
+                            <p:stCondLst>
+                              <p:cond delay="0"/>
+                            </p:stCondLst>
+                            <p:childTnLst>
+                              <p:par>
+                                <p:cTn id="25" presetID="1" presetClass="entr" presetSubtype="0" fill="hold" nodeType="clickEffect">
+                                  <p:stCondLst>
+                                    <p:cond delay="0"/>
+                                  </p:stCondLst>
+                                  <p:childTnLst>
+                                    <p:set>
+                                      <p:cBhvr>
+                                        <p:cTn id="26" dur="1" fill="hold">
+                                          <p:stCondLst>
+                                            <p:cond delay="0"/>
+                                          </p:stCondLst>
+                                        </p:cTn>
+                                        <p:tgtEl>
+                                          <p:spTgt spid="16"/>
+                                        </p:tgtEl>
+                                        <p:attrNameLst>
+                                          <p:attrName>style.visibility</p:attrName>
+                                        </p:attrNameLst>
+                                      </p:cBhvr>
+                                      <p:to>
+                                        <p:strVal val="visible"/>
+                                      </p:to>
+                                    </p:set>
+                                  </p:childTnLst>
+                                </p:cTn>
+                              </p:par>
+                              <p:par>
+                                <p:cTn id="27" presetID="1" presetClass="entr" presetSubtype="0" fill="hold" nodeType="withEffect">
+                                  <p:stCondLst>
+                                    <p:cond delay="0"/>
+                                  </p:stCondLst>
+                                  <p:childTnLst>
+                                    <p:set>
+                                      <p:cBhvr>
+                                        <p:cTn id="28" dur="1" fill="hold">
+                                          <p:stCondLst>
+                                            <p:cond delay="0"/>
+                                          </p:stCondLst>
+                                        </p:cTn>
+                                        <p:tgtEl>
+                                          <p:spTgt spid="17"/>
+                                        </p:tgtEl>
+                                        <p:attrNameLst>
+                                          <p:attrName>style.visibility</p:attrName>
+                                        </p:attrNameLst>
+                                      </p:cBhvr>
+                                      <p:to>
+                                        <p:strVal val="visible"/>
+                                      </p:to>
+                                    </p:set>
+                                  </p:childTnLst>
+                                </p:cTn>
+                              </p:par>
+                              <p:par>
+                                <p:cTn id="29" presetID="1" presetClass="entr" presetSubtype="0" fill="hold" nodeType="withEffect">
+                                  <p:stCondLst>
+                                    <p:cond delay="0"/>
+                                  </p:stCondLst>
+                                  <p:childTnLst>
+                                    <p:set>
+                                      <p:cBhvr>
+                                        <p:cTn id="30" dur="1" fill="hold">
+                                          <p:stCondLst>
+                                            <p:cond delay="0"/>
+                                          </p:stCondLst>
+                                        </p:cTn>
+                                        <p:tgtEl>
+                                          <p:spTgt spid="18"/>
+                                        </p:tgtEl>
+                                        <p:attrNameLst>
+                                          <p:attrName>style.visibility</p:attrName>
+                                        </p:attrNameLst>
+                                      </p:cBhvr>
+                                      <p:to>
+                                        <p:strVal val="visible"/>
+                                      </p:to>
+                                    </p:set>
+                                  </p:childTnLst>
+                                </p:cTn>
+                              </p:par>
+                              <p:par>
+                                <p:cTn id="31" presetID="1" presetClass="entr" presetSubtype="0" fill="hold" nodeType="withEffect">
+                                  <p:stCondLst>
+                                    <p:cond delay="0"/>
+                                  </p:stCondLst>
+                                  <p:childTnLst>
+                                    <p:set>
+                                      <p:cBhvr>
+                                        <p:cTn id="32" dur="1" fill="hold">
+                                          <p:stCondLst>
+                                            <p:cond delay="0"/>
+                                          </p:stCondLst>
+                                        </p:cTn>
+                                        <p:tgtEl>
+                                          <p:spTgt spid="19"/>
+                                        </p:tgtEl>
+                                        <p:attrNameLst>
+                                          <p:attrName>style.visibility</p:attrName>
+                                        </p:attrNameLst>
+                                      </p:cBhvr>
+                                      <p:to>
+                                        <p:strVal val="visible"/>
+                                      </p:to>
+                                    </p:set>
+                                  </p:childTnLst>
+                                </p:cTn>
+                              </p:par>
+                            </p:childTnLst>
+                          </p:cTn>
+                        </p:par>
+                      </p:childTnLst>
+                    </p:cTn>
+                  </p:par>
+                  <p:par>
+                    <p:cTn id="33" fill="hold">
+                      <p:stCondLst>
+                        <p:cond delay="indefinite"/>
+                      </p:stCondLst>
+                      <p:childTnLst>
+                        <p:par>
+                          <p:cTn id="34" fill="hold">
+                            <p:stCondLst>
+                              <p:cond delay="0"/>
+                            </p:stCondLst>
+                            <p:childTnLst>
+                              <p:par>
+                                <p:cTn id="35" presetID="1" presetClass="entr" presetSubtype="0" fill="hold" nodeType="clickEffect">
+                                  <p:stCondLst>
+                                    <p:cond delay="0"/>
+                                  </p:stCondLst>
+                                  <p:childTnLst>
+                                    <p:set>
+                                      <p:cBhvr>
+                                        <p:cTn id="36" dur="1" fill="hold">
+                                          <p:stCondLst>
+                                            <p:cond delay="0"/>
+                                          </p:stCondLst>
+                                        </p:cTn>
+                                        <p:tgtEl>
+                                          <p:spTgt spid="20"/>
+                                        </p:tgtEl>
+                                        <p:attrNameLst>
+                                          <p:attrName>style.visibility</p:attrName>
+                                        </p:attrNameLst>
+                                      </p:cBhvr>
+                                      <p:to>
+                                        <p:strVal val="visible"/>
+                                      </p:to>
+                                    </p:set>
+                                  </p:childTnLst>
+                                </p:cTn>
+                              </p:par>
+                              <p:par>
+                                <p:cTn id="37" presetID="1" presetClass="entr" presetSubtype="0" fill="hold" nodeType="withEffect">
+                                  <p:stCondLst>
+                                    <p:cond delay="0"/>
+                                  </p:stCondLst>
+                                  <p:childTnLst>
+                                    <p:set>
+                                      <p:cBhvr>
+                                        <p:cTn id="38" dur="1" fill="hold">
+                                          <p:stCondLst>
+                                            <p:cond delay="0"/>
+                                          </p:stCondLst>
+                                        </p:cTn>
+                                        <p:tgtEl>
+                                          <p:spTgt spid="21"/>
+                                        </p:tgtEl>
+                                        <p:attrNameLst>
+                                          <p:attrName>style.visibility</p:attrName>
+                                        </p:attrNameLst>
+                                      </p:cBhvr>
+                                      <p:to>
+                                        <p:strVal val="visible"/>
+                                      </p:to>
+                                    </p:set>
+                                  </p:childTnLst>
+                                </p:cTn>
+                              </p:par>
+                              <p:par>
+                                <p:cTn id="39" presetID="1" presetClass="entr" presetSubtype="0" fill="hold" nodeType="withEffect">
+                                  <p:stCondLst>
+                                    <p:cond delay="0"/>
+                                  </p:stCondLst>
+                                  <p:childTnLst>
+                                    <p:set>
+                                      <p:cBhvr>
+                                        <p:cTn id="40" dur="1" fill="hold">
+                                          <p:stCondLst>
+                                            <p:cond delay="0"/>
+                                          </p:stCondLst>
+                                        </p:cTn>
+                                        <p:tgtEl>
+                                          <p:spTgt spid="22"/>
+                                        </p:tgtEl>
+                                        <p:attrNameLst>
+                                          <p:attrName>style.visibility</p:attrName>
+                                        </p:attrNameLst>
+                                      </p:cBhvr>
+                                      <p:to>
+                                        <p:strVal val="visible"/>
+                                      </p:to>
+                                    </p:set>
+                                  </p:childTnLst>
+                                </p:cTn>
+                              </p:par>
+                            </p:childTnLst>
+                          </p:cTn>
+                        </p:par>
+                      </p:childTnLst>
+                    </p:cTn>
+                  </p:par>
+                </p:childTnLst>
+              </p:cTn>
+              <p:prevCondLst>
+                <p:cond evt="onPrev" delay="0">
+                  <p:tgtEl>
+                    <p:sldTgt/>
+                  </p:tgtEl>
+                </p:cond>
+              </p:prevCondLst>
+              <p:nextCondLst>
+                <p:cond evt="onNext" delay="0">
+                  <p:tgtEl>
+                    <p:sldTgt/>
+                  </p:tgtEl>
+                </p:cond>
+              </p:nextCondLst>
+            </p:seq>
+          </p:childTnLst>
+        </p:cTn>
+      </p:par>
+    </p:tnLst>
+  </p:timing>
 </p:sld>
 </file>
 

</xml_diff>

<commit_message>
Replace Friday letter codes with visual full-word flow
</commit_message>
<xml_diff>
--- a/second-placement/planning/2026-09-18-Friday-Icebreaker-Goods-Services-Ideas-Revised-v2.pptx
+++ b/second-placement/planning/2026-09-18-Friday-Icebreaker-Goods-Services-Ideas-Revised-v2.pptx
@@ -530,7 +530,7 @@
           <a:lstStyle xmlns:a="http://schemas.openxmlformats.org/drawingml/2006/main"/>
           <a:p xmlns:a="http://schemas.openxmlformats.org/drawingml/2006/main">
             <a:r>
-              <a:t>0:15–1:05 | Give 15 silent seconds. Then say: ‘Place G, S, and I under pictures 1, 2, and 3.’ Students may point, write, or say the three-letter order.</a:t>
+              <a:t>0:15–1:05 | Give 15 silent seconds. Then say: ‘I will show one picture at a time. Show 1, 2, or 3 when I name good, service, or idea.’ Students may point, write, or say the number.</a:t>
             </a:r>
           </a:p>
           <a:p xmlns:a="http://schemas.openxmlformats.org/drawingml/2006/main">
@@ -545,7 +545,7 @@
           </a:p>
           <a:p xmlns:a="http://schemas.openxmlformats.org/drawingml/2006/main">
             <a:r>
-              <a:t>CLICK CUES: Six clicks: picture 1, number 1, replace with picture 2, number 2, replace with picture 3, number 3. Ask for a G/S/I response while each picture is visible. Read the definition clues aloud as needed. Students can say, point to a clue, or write the category. Back revisits the previous picture. Advance only after all three responses.</a:t>
+              <a:t>CLICK CUES: Six clicks: picture 1, number 1, replace with picture 2, number 2, replace with picture 3, number 3. Ask for a good, service, or idea response while each picture is visible. Read the definition clues aloud as needed. Students can say, point to a clue, or write the category. Back revisits the previous picture. Advance only after all three responses.</a:t>
             </a:r>
           </a:p>
         </p:txBody>
@@ -615,7 +615,7 @@
           <a:lstStyle xmlns:a="http://schemas.openxmlformats.org/drawingml/2006/main"/>
           <a:p xmlns:a="http://schemas.openxmlformats.org/drawingml/2006/main">
             <a:r>
-              <a:t>1:05–1:50 | Reveal the order. Say: ‘Picture 1 is an item. Picture 2 is a task. Picture 3 shares an idea.’ Ask one student to name the clue that proves one answer.</a:t>
+              <a:t>1:05–1:50 | Reveal the order. Say: ‘Picture 1 is a good. Picture 2 is a service. Picture 3 shares an idea.’ Ask one student to name the clue that proves one answer.</a:t>
             </a:r>
           </a:p>
           <a:p xmlns:a="http://schemas.openxmlformats.org/drawingml/2006/main">
@@ -630,7 +630,7 @@
           </a:p>
           <a:p xmlns:a="http://schemas.openxmlformats.org/drawingml/2006/main">
             <a:r>
-              <a:t>CLICK CUES: Click once per answer row, then once for the full matching key. Keep the previously revealed rows visible for reference.</a:t>
+              <a:t>CLICK CUES: Click for each picture, then its full-word explanation. The final click shows the numbered key. Keep the previously revealed rows visible for reference.</a:t>
             </a:r>
           </a:p>
         </p:txBody>
@@ -715,7 +715,7 @@
           </a:p>
           <a:p xmlns:a="http://schemas.openxmlformats.org/drawingml/2006/main">
             <a:r>
-              <a:t>CLICK CUES: Click once per definition, then once for the closing connection and next step. Keep earlier definitions visible.</a:t>
+              <a:t>CLICK CUES: Click first for the picture, then for business, marketing, product, and the closing connection. Keep earlier definitions visible.</a:t>
             </a:r>
           </a:p>
         </p:txBody>
@@ -1525,7 +1525,7 @@
                 <a:ea typeface="Helvetica Neue"/>
                 <a:cs typeface="Helvetica Neue"/>
               </a:rPr>
-              <a:t>Look for an item, a task, and an idea being shared.</a:t>
+              <a:t>Look for a good, a service, and an idea.</a:t>
             </a:r>
           </a:p>
         </p:txBody>
@@ -2035,7 +2035,7 @@
                 <a:ea typeface="Helvetica Neue"/>
                 <a:cs typeface="Helvetica Neue"/>
               </a:rPr>
-              <a:t>Where do G, S, and I belong?</a:t>
+              <a:t>Which picture shows a GOOD?</a:t>
             </a:r>
           </a:p>
         </p:txBody>
@@ -2092,7 +2092,7 @@
                 <a:ea typeface="Helvetica Neue"/>
                 <a:cs typeface="Helvetica Neue"/>
               </a:rPr>
-              <a:t>Use each clue once. Place one letter under each picture.</a:t>
+              <a:t>Show its number. Then listen for the next category.</a:t>
             </a:r>
           </a:p>
         </p:txBody>
@@ -2295,7 +2295,7 @@
                 <a:ea typeface="Helvetica Neue"/>
                 <a:cs typeface="Helvetica Neue"/>
               </a:rPr>
-              <a:t>G = an item     S = a task done for someone     I = a thought or opinion</a:t>
+              <a:t>GOOD = item to buy     SERVICE = task done for someone     IDEA = thought or opinion</a:t>
             </a:r>
           </a:p>
         </p:txBody>
@@ -2636,7 +2636,7 @@
                 <a:ea typeface="Helvetica Neue"/>
                 <a:cs typeface="Helvetica Neue"/>
               </a:rPr>
-              <a:t>POINT, WRITE, OR SAY:    1 = ?    2 = ?    3 = ?</a:t>
+              <a:t>POINT, WRITE, OR SAY:    1, 2, OR 3</a:t>
             </a:r>
           </a:p>
         </p:txBody>
@@ -3217,7 +3217,7 @@
                 <a:ea typeface="Helvetica Neue"/>
                 <a:cs typeface="Helvetica Neue"/>
               </a:rPr>
-              <a:t>Check the three pictures</a:t>
+              <a:t>Check each picture</a:t>
             </a:r>
           </a:p>
         </p:txBody>
@@ -3274,7 +3274,7 @@
                 <a:ea typeface="Helvetica Neue"/>
                 <a:cs typeface="Helvetica Neue"/>
               </a:rPr>
-              <a:t>Use the visual clue to explain each match.</a:t>
+              <a:t>Name the offering, then explain the visual clue.</a:t>
             </a:r>
           </a:p>
         </p:txBody>
@@ -3441,8 +3441,8 @@
         </p:nvSpPr>
         <p:spPr>
           <a:xfrm xmlns:a="http://schemas.openxmlformats.org/drawingml/2006/main">
-            <a:off x="685800" y="1790700"/>
-            <a:ext cx="10820400" cy="819150"/>
+            <a:off x="685800" y="4057650"/>
+            <a:ext cx="3200400" cy="1257300"/>
           </a:xfrm>
           <a:prstGeom xmlns:a="http://schemas.openxmlformats.org/drawingml/2006/main" prst="roundRect">
             <a:avLst>
@@ -3473,8 +3473,8 @@
         </p:nvSpPr>
         <p:spPr>
           <a:xfrm xmlns:a="http://schemas.openxmlformats.org/drawingml/2006/main">
-            <a:off x="857250" y="1905000"/>
-            <a:ext cx="514350" cy="419100"/>
+            <a:off x="838200" y="4171950"/>
+            <a:ext cx="381000" cy="400050"/>
           </a:xfrm>
           <a:prstGeom xmlns:a="http://schemas.openxmlformats.org/drawingml/2006/main" prst="rect">
             <a:avLst/>
@@ -3530,8 +3530,8 @@
         </p:nvSpPr>
         <p:spPr>
           <a:xfrm xmlns:a="http://schemas.openxmlformats.org/drawingml/2006/main">
-            <a:off x="1466850" y="1866900"/>
-            <a:ext cx="9867900" cy="457200"/>
+            <a:off x="1276350" y="4133850"/>
+            <a:ext cx="2457450" cy="419100"/>
           </a:xfrm>
           <a:prstGeom xmlns:a="http://schemas.openxmlformats.org/drawingml/2006/main" prst="rect">
             <a:avLst/>
@@ -3587,8 +3587,8 @@
         </p:nvSpPr>
         <p:spPr>
           <a:xfrm xmlns:a="http://schemas.openxmlformats.org/drawingml/2006/main">
-            <a:off x="1466850" y="2286000"/>
-            <a:ext cx="9867900" cy="228600"/>
+            <a:off x="838200" y="4591050"/>
+            <a:ext cx="2895600" cy="552450"/>
           </a:xfrm>
           <a:prstGeom xmlns:a="http://schemas.openxmlformats.org/drawingml/2006/main" prst="rect">
             <a:avLst/>
@@ -3605,7 +3605,7 @@
           <a:lstStyle xmlns:a="http://schemas.openxmlformats.org/drawingml/2006/main"/>
           <a:p xmlns:a="http://schemas.openxmlformats.org/drawingml/2006/main">
             <a:pPr>
-              <a:defRPr sz="1350" b="0">
+              <a:defRPr sz="1500" b="0">
                 <a:solidFill>
                   <a:srgbClr val="22313F"/>
                 </a:solidFill>
@@ -3615,7 +3615,7 @@
               </a:defRPr>
             </a:pPr>
             <a:r>
-              <a:rPr sz="1350" b="0">
+              <a:rPr sz="1500" b="0">
                 <a:solidFill>
                   <a:srgbClr val="22313F"/>
                 </a:solidFill>
@@ -3623,7 +3623,7 @@
                 <a:ea typeface="Helvetica Neue"/>
                 <a:cs typeface="Helvetica Neue"/>
               </a:rPr>
-              <a:t>Sneakers are a tangible item that a customer can buy</a:t>
+              <a:t>Sneakers are an item a customer can buy</a:t>
             </a:r>
           </a:p>
         </p:txBody>
@@ -3644,8 +3644,8 @@
         </p:nvSpPr>
         <p:spPr>
           <a:xfrm xmlns:a="http://schemas.openxmlformats.org/drawingml/2006/main">
-            <a:off x="685800" y="2800350"/>
-            <a:ext cx="10820400" cy="819150"/>
+            <a:off x="4495800" y="4057650"/>
+            <a:ext cx="3200400" cy="1257300"/>
           </a:xfrm>
           <a:prstGeom xmlns:a="http://schemas.openxmlformats.org/drawingml/2006/main" prst="roundRect">
             <a:avLst>
@@ -3676,8 +3676,8 @@
         </p:nvSpPr>
         <p:spPr>
           <a:xfrm xmlns:a="http://schemas.openxmlformats.org/drawingml/2006/main">
-            <a:off x="857250" y="2914650"/>
-            <a:ext cx="514350" cy="419100"/>
+            <a:off x="4648200" y="4171950"/>
+            <a:ext cx="381000" cy="400050"/>
           </a:xfrm>
           <a:prstGeom xmlns:a="http://schemas.openxmlformats.org/drawingml/2006/main" prst="rect">
             <a:avLst/>
@@ -3733,8 +3733,8 @@
         </p:nvSpPr>
         <p:spPr>
           <a:xfrm xmlns:a="http://schemas.openxmlformats.org/drawingml/2006/main">
-            <a:off x="1466850" y="2876550"/>
-            <a:ext cx="9867900" cy="457200"/>
+            <a:off x="5086350" y="4133850"/>
+            <a:ext cx="2457450" cy="419100"/>
           </a:xfrm>
           <a:prstGeom xmlns:a="http://schemas.openxmlformats.org/drawingml/2006/main" prst="rect">
             <a:avLst/>
@@ -3790,8 +3790,8 @@
         </p:nvSpPr>
         <p:spPr>
           <a:xfrm xmlns:a="http://schemas.openxmlformats.org/drawingml/2006/main">
-            <a:off x="1466850" y="3295650"/>
-            <a:ext cx="9867900" cy="228600"/>
+            <a:off x="4648200" y="4591050"/>
+            <a:ext cx="2895600" cy="552450"/>
           </a:xfrm>
           <a:prstGeom xmlns:a="http://schemas.openxmlformats.org/drawingml/2006/main" prst="rect">
             <a:avLst/>
@@ -3808,7 +3808,7 @@
           <a:lstStyle xmlns:a="http://schemas.openxmlformats.org/drawingml/2006/main"/>
           <a:p xmlns:a="http://schemas.openxmlformats.org/drawingml/2006/main">
             <a:pPr>
-              <a:defRPr sz="1350" b="0">
+              <a:defRPr sz="1500" b="0">
                 <a:solidFill>
                   <a:srgbClr val="22313F"/>
                 </a:solidFill>
@@ -3818,7 +3818,7 @@
               </a:defRPr>
             </a:pPr>
             <a:r>
-              <a:rPr sz="1350" b="0">
+              <a:rPr sz="1500" b="0">
                 <a:solidFill>
                   <a:srgbClr val="22313F"/>
                 </a:solidFill>
@@ -3826,7 +3826,7 @@
                 <a:ea typeface="Helvetica Neue"/>
                 <a:cs typeface="Helvetica Neue"/>
               </a:rPr>
-              <a:t>The car wash is a task performed for someone</a:t>
+              <a:t>A haircut is a task done for a customer</a:t>
             </a:r>
           </a:p>
         </p:txBody>
@@ -3847,8 +3847,8 @@
         </p:nvSpPr>
         <p:spPr>
           <a:xfrm xmlns:a="http://schemas.openxmlformats.org/drawingml/2006/main">
-            <a:off x="685800" y="3810000"/>
-            <a:ext cx="10820400" cy="819150"/>
+            <a:off x="8305800" y="4057650"/>
+            <a:ext cx="3200400" cy="1257300"/>
           </a:xfrm>
           <a:prstGeom xmlns:a="http://schemas.openxmlformats.org/drawingml/2006/main" prst="roundRect">
             <a:avLst>
@@ -3879,8 +3879,8 @@
         </p:nvSpPr>
         <p:spPr>
           <a:xfrm xmlns:a="http://schemas.openxmlformats.org/drawingml/2006/main">
-            <a:off x="857250" y="3924300"/>
-            <a:ext cx="514350" cy="419100"/>
+            <a:off x="8458200" y="4171950"/>
+            <a:ext cx="381000" cy="400050"/>
           </a:xfrm>
           <a:prstGeom xmlns:a="http://schemas.openxmlformats.org/drawingml/2006/main" prst="rect">
             <a:avLst/>
@@ -3936,8 +3936,8 @@
         </p:nvSpPr>
         <p:spPr>
           <a:xfrm xmlns:a="http://schemas.openxmlformats.org/drawingml/2006/main">
-            <a:off x="1466850" y="3886200"/>
-            <a:ext cx="9867900" cy="457200"/>
+            <a:off x="8896350" y="4133850"/>
+            <a:ext cx="2457450" cy="419100"/>
           </a:xfrm>
           <a:prstGeom xmlns:a="http://schemas.openxmlformats.org/drawingml/2006/main" prst="rect">
             <a:avLst/>
@@ -3993,8 +3993,8 @@
         </p:nvSpPr>
         <p:spPr>
           <a:xfrm xmlns:a="http://schemas.openxmlformats.org/drawingml/2006/main">
-            <a:off x="1466850" y="4305300"/>
-            <a:ext cx="9867900" cy="228600"/>
+            <a:off x="8458200" y="4591050"/>
+            <a:ext cx="2895600" cy="552450"/>
           </a:xfrm>
           <a:prstGeom xmlns:a="http://schemas.openxmlformats.org/drawingml/2006/main" prst="rect">
             <a:avLst/>
@@ -4011,7 +4011,7 @@
           <a:lstStyle xmlns:a="http://schemas.openxmlformats.org/drawingml/2006/main"/>
           <a:p xmlns:a="http://schemas.openxmlformats.org/drawingml/2006/main">
             <a:pPr>
-              <a:defRPr sz="1350" b="0">
+              <a:defRPr sz="1500" b="0">
                 <a:solidFill>
                   <a:srgbClr val="22313F"/>
                 </a:solidFill>
@@ -4021,7 +4021,7 @@
               </a:defRPr>
             </a:pPr>
             <a:r>
-              <a:rPr sz="1350" b="0">
+              <a:rPr sz="1500" b="0">
                 <a:solidFill>
                   <a:srgbClr val="22313F"/>
                 </a:solidFill>
@@ -4029,7 +4029,7 @@
                 <a:ea typeface="Helvetica Neue"/>
                 <a:cs typeface="Helvetica Neue"/>
               </a:rPr>
-              <a:t>The recycling campaign shares a thought or opinion</a:t>
+              <a:t>The poster shares a message or opinion</a:t>
             </a:r>
           </a:p>
         </p:txBody>
@@ -4051,7 +4051,7 @@
         <p:spPr>
           <a:xfrm xmlns:a="http://schemas.openxmlformats.org/drawingml/2006/main">
             <a:off x="685800" y="5619750"/>
-            <a:ext cx="10820400" cy="552450"/>
+            <a:ext cx="10820400" cy="476250"/>
           </a:xfrm>
           <a:prstGeom xmlns:a="http://schemas.openxmlformats.org/drawingml/2006/main" prst="roundRect">
             <a:avLst>
@@ -4118,11 +4118,92 @@
                 <a:ea typeface="Helvetica Neue"/>
                 <a:cs typeface="Helvetica Neue"/>
               </a:rPr>
-              <a:t>1 = G    2 = S    3 = I</a:t>
+              <a:t>1  GOOD        2  SERVICE        3  IDEA</a:t>
             </a:r>
           </a:p>
         </p:txBody>
       </p:sp>
+      <p:pic>
+        <p:nvPicPr>
+          <p:cNvPr id="30" name=""/>
+          <p:cNvPicPr>
+            <a:picLocks xmlns:a="http://schemas.openxmlformats.org/drawingml/2006/main" noChangeAspect="1"/>
+          </p:cNvPicPr>
+          <p:nvPr/>
+        </p:nvPicPr>
+        <p:blipFill>
+          <a:blip xmlns:r="http://schemas.openxmlformats.org/officeDocument/2006/relationships" xmlns:a="http://schemas.openxmlformats.org/drawingml/2006/main" r:embed="RimgGood"/>
+          <a:srcRect xmlns:a="http://schemas.openxmlformats.org/drawingml/2006/main" l="0" t="1233" r="0" b="1233"/>
+          <a:stretch xmlns:a="http://schemas.openxmlformats.org/drawingml/2006/main">
+            <a:fillRect l="0" t="0" r="0" b="0"/>
+          </a:stretch>
+        </p:blipFill>
+        <p:spPr>
+          <a:xfrm xmlns:a="http://schemas.openxmlformats.org/drawingml/2006/main">
+            <a:off x="685800" y="1790700"/>
+            <a:ext cx="3200400" cy="2095500"/>
+          </a:xfrm>
+          <a:prstGeom xmlns:a="http://schemas.openxmlformats.org/drawingml/2006/main" prst="roundRect">
+            <a:avLst>
+              <a:gd name="adj" fmla="val 8871"/>
+            </a:avLst>
+          </a:prstGeom>
+        </p:spPr>
+      </p:pic>
+      <p:pic>
+        <p:nvPicPr>
+          <p:cNvPr id="31" name=""/>
+          <p:cNvPicPr>
+            <a:picLocks xmlns:a="http://schemas.openxmlformats.org/drawingml/2006/main" noChangeAspect="1"/>
+          </p:cNvPicPr>
+          <p:nvPr/>
+        </p:nvPicPr>
+        <p:blipFill>
+          <a:blip xmlns:r="http://schemas.openxmlformats.org/officeDocument/2006/relationships" xmlns:a="http://schemas.openxmlformats.org/drawingml/2006/main" r:embed="RimgService"/>
+          <a:srcRect xmlns:a="http://schemas.openxmlformats.org/drawingml/2006/main" l="0" t="1233" r="0" b="1233"/>
+          <a:stretch xmlns:a="http://schemas.openxmlformats.org/drawingml/2006/main">
+            <a:fillRect l="0" t="0" r="0" b="0"/>
+          </a:stretch>
+        </p:blipFill>
+        <p:spPr>
+          <a:xfrm xmlns:a="http://schemas.openxmlformats.org/drawingml/2006/main">
+            <a:off x="4495800" y="1790700"/>
+            <a:ext cx="3200400" cy="2095500"/>
+          </a:xfrm>
+          <a:prstGeom xmlns:a="http://schemas.openxmlformats.org/drawingml/2006/main" prst="roundRect">
+            <a:avLst>
+              <a:gd name="adj" fmla="val 8871"/>
+            </a:avLst>
+          </a:prstGeom>
+        </p:spPr>
+      </p:pic>
+      <p:pic>
+        <p:nvPicPr>
+          <p:cNvPr id="32" name=""/>
+          <p:cNvPicPr>
+            <a:picLocks xmlns:a="http://schemas.openxmlformats.org/drawingml/2006/main" noChangeAspect="1"/>
+          </p:cNvPicPr>
+          <p:nvPr/>
+        </p:nvPicPr>
+        <p:blipFill>
+          <a:blip xmlns:r="http://schemas.openxmlformats.org/officeDocument/2006/relationships" xmlns:a="http://schemas.openxmlformats.org/drawingml/2006/main" r:embed="RimgIdea"/>
+          <a:srcRect xmlns:a="http://schemas.openxmlformats.org/drawingml/2006/main" l="0" t="1233" r="0" b="1233"/>
+          <a:stretch xmlns:a="http://schemas.openxmlformats.org/drawingml/2006/main">
+            <a:fillRect l="0" t="0" r="0" b="0"/>
+          </a:stretch>
+        </p:blipFill>
+        <p:spPr>
+          <a:xfrm xmlns:a="http://schemas.openxmlformats.org/drawingml/2006/main">
+            <a:off x="8305800" y="1790700"/>
+            <a:ext cx="3200400" cy="2095500"/>
+          </a:xfrm>
+          <a:prstGeom xmlns:a="http://schemas.openxmlformats.org/drawingml/2006/main" prst="roundRect">
+            <a:avLst>
+              <a:gd name="adj" fmla="val 8871"/>
+            </a:avLst>
+          </a:prstGeom>
+        </p:spPr>
+      </p:pic>
     </p:spTree>
     <p:extLst>
       <p:ext uri="{BB962C8B-B14F-4D97-AF65-F5344CB8AC3E}">
@@ -4164,7 +4245,7 @@
                                           </p:stCondLst>
                                         </p:cTn>
                                         <p:tgtEl>
-                                          <p:spTgt spid="8"/>
+                                          <p:spTgt spid="30"/>
                                         </p:tgtEl>
                                         <p:attrNameLst>
                                           <p:attrName>style.visibility</p:attrName>
@@ -4177,35 +4258,26 @@
                                   </p:childTnLst>
                                 </p:cTn>
                               </p:par>
+                            </p:childTnLst>
+                          </p:cTn>
+                        </p:par>
+                      </p:childTnLst>
+                    </p:cTn>
+                  </p:par>
+                  <p:par>
+                    <p:cTn id="7" fill="hold">
+                      <p:stCondLst>
+                        <p:cond delay="indefinite"/>
+                      </p:stCondLst>
+                      <p:childTnLst>
+                        <p:par>
+                          <p:cTn id="8" fill="hold">
+                            <p:stCondLst>
+                              <p:cond delay="0"/>
+                            </p:stCondLst>
+                            <p:childTnLst>
                               <p:par>
-                                <p:cTn id="7" presetID="1" presetClass="entr" presetSubtype="0" fill="hold" nodeType="withEffect">
-                                  <p:stCondLst>
-                                    <p:cond delay="0"/>
-                                  </p:stCondLst>
-                                  <p:childTnLst>
-                                    <p:set>
-                                      <p:cBhvr>
-                                        <p:cTn id="8" dur="1" fill="hold">
-                                          <p:stCondLst>
-                                            <p:cond delay="0"/>
-                                          </p:stCondLst>
-                                        </p:cTn>
-                                        <p:tgtEl>
-                                          <p:spTgt spid="9"/>
-                                        </p:tgtEl>
-                                        <p:attrNameLst>
-                                          <p:attrName>style.visibility</p:attrName>
-                                        </p:attrNameLst>
-                                      </p:cBhvr>
-                                      <p:to>
-                                        <p:strVal val="visible"/>
-                                      </p:to>
-                                    </p:set>
-                                  </p:childTnLst>
-                                </p:cTn>
-                              </p:par>
-                              <p:par>
-                                <p:cTn id="9" presetID="1" presetClass="entr" presetSubtype="0" fill="hold" nodeType="withEffect">
+                                <p:cTn id="9" presetID="1" presetClass="entr" presetSubtype="0" fill="hold" nodeType="clickEffect">
                                   <p:stCondLst>
                                     <p:cond delay="0"/>
                                   </p:stCondLst>
@@ -4218,7 +4290,7 @@
                                           </p:stCondLst>
                                         </p:cTn>
                                         <p:tgtEl>
-                                          <p:spTgt spid="10"/>
+                                          <p:spTgt spid="8"/>
                                         </p:tgtEl>
                                         <p:attrNameLst>
                                           <p:attrName>style.visibility</p:attrName>
@@ -4245,6 +4317,60 @@
                                           </p:stCondLst>
                                         </p:cTn>
                                         <p:tgtEl>
+                                          <p:spTgt spid="9"/>
+                                        </p:tgtEl>
+                                        <p:attrNameLst>
+                                          <p:attrName>style.visibility</p:attrName>
+                                        </p:attrNameLst>
+                                      </p:cBhvr>
+                                      <p:to>
+                                        <p:strVal val="visible"/>
+                                      </p:to>
+                                    </p:set>
+                                  </p:childTnLst>
+                                </p:cTn>
+                              </p:par>
+                              <p:par>
+                                <p:cTn id="13" presetID="1" presetClass="entr" presetSubtype="0" fill="hold" nodeType="withEffect">
+                                  <p:stCondLst>
+                                    <p:cond delay="0"/>
+                                  </p:stCondLst>
+                                  <p:childTnLst>
+                                    <p:set>
+                                      <p:cBhvr>
+                                        <p:cTn id="14" dur="1" fill="hold">
+                                          <p:stCondLst>
+                                            <p:cond delay="0"/>
+                                          </p:stCondLst>
+                                        </p:cTn>
+                                        <p:tgtEl>
+                                          <p:spTgt spid="10"/>
+                                        </p:tgtEl>
+                                        <p:attrNameLst>
+                                          <p:attrName>style.visibility</p:attrName>
+                                        </p:attrNameLst>
+                                      </p:cBhvr>
+                                      <p:to>
+                                        <p:strVal val="visible"/>
+                                      </p:to>
+                                    </p:set>
+                                  </p:childTnLst>
+                                </p:cTn>
+                              </p:par>
+                              <p:par>
+                                <p:cTn id="15" presetID="1" presetClass="entr" presetSubtype="0" fill="hold" nodeType="withEffect">
+                                  <p:stCondLst>
+                                    <p:cond delay="0"/>
+                                  </p:stCondLst>
+                                  <p:childTnLst>
+                                    <p:set>
+                                      <p:cBhvr>
+                                        <p:cTn id="16" dur="1" fill="hold">
+                                          <p:stCondLst>
+                                            <p:cond delay="0"/>
+                                          </p:stCondLst>
+                                        </p:cTn>
+                                        <p:tgtEl>
                                           <p:spTgt spid="11"/>
                                         </p:tgtEl>
                                         <p:attrNameLst>
@@ -4265,26 +4391,71 @@
                     </p:cTn>
                   </p:par>
                   <p:par>
-                    <p:cTn id="13" fill="hold">
+                    <p:cTn id="17" fill="hold">
                       <p:stCondLst>
                         <p:cond delay="indefinite"/>
                       </p:stCondLst>
                       <p:childTnLst>
                         <p:par>
-                          <p:cTn id="14" fill="hold">
+                          <p:cTn id="18" fill="hold">
                             <p:stCondLst>
                               <p:cond delay="0"/>
                             </p:stCondLst>
                             <p:childTnLst>
                               <p:par>
-                                <p:cTn id="15" presetID="1" presetClass="entr" presetSubtype="0" fill="hold" nodeType="clickEffect">
+                                <p:cTn id="19" presetID="1" presetClass="entr" presetSubtype="0" fill="hold" nodeType="clickEffect">
                                   <p:stCondLst>
                                     <p:cond delay="0"/>
                                   </p:stCondLst>
                                   <p:childTnLst>
                                     <p:set>
                                       <p:cBhvr>
-                                        <p:cTn id="16" dur="1" fill="hold">
+                                        <p:cTn id="20" dur="1" fill="hold">
+                                          <p:stCondLst>
+                                            <p:cond delay="0"/>
+                                          </p:stCondLst>
+                                        </p:cTn>
+                                        <p:tgtEl>
+                                          <p:spTgt spid="31"/>
+                                        </p:tgtEl>
+                                        <p:attrNameLst>
+                                          <p:attrName>style.visibility</p:attrName>
+                                        </p:attrNameLst>
+                                      </p:cBhvr>
+                                      <p:to>
+                                        <p:strVal val="visible"/>
+                                      </p:to>
+                                    </p:set>
+                                  </p:childTnLst>
+                                </p:cTn>
+                              </p:par>
+                            </p:childTnLst>
+                          </p:cTn>
+                        </p:par>
+                      </p:childTnLst>
+                    </p:cTn>
+                  </p:par>
+                  <p:par>
+                    <p:cTn id="21" fill="hold">
+                      <p:stCondLst>
+                        <p:cond delay="indefinite"/>
+                      </p:stCondLst>
+                      <p:childTnLst>
+                        <p:par>
+                          <p:cTn id="22" fill="hold">
+                            <p:stCondLst>
+                              <p:cond delay="0"/>
+                            </p:stCondLst>
+                            <p:childTnLst>
+                              <p:par>
+                                <p:cTn id="23" presetID="1" presetClass="entr" presetSubtype="0" fill="hold" nodeType="clickEffect">
+                                  <p:stCondLst>
+                                    <p:cond delay="0"/>
+                                  </p:stCondLst>
+                                  <p:childTnLst>
+                                    <p:set>
+                                      <p:cBhvr>
+                                        <p:cTn id="24" dur="1" fill="hold">
                                           <p:stCondLst>
                                             <p:cond delay="0"/>
                                           </p:stCondLst>
@@ -4304,7 +4475,1681 @@
                                 </p:cTn>
                               </p:par>
                               <p:par>
-                                <p:cTn id="17" presetID="1" presetClass="entr" presetSubtype="0" fill="hold" nodeType="withEffect">
+                                <p:cTn id="25" presetID="1" presetClass="entr" presetSubtype="0" fill="hold" nodeType="withEffect">
+                                  <p:stCondLst>
+                                    <p:cond delay="0"/>
+                                  </p:stCondLst>
+                                  <p:childTnLst>
+                                    <p:set>
+                                      <p:cBhvr>
+                                        <p:cTn id="26" dur="1" fill="hold">
+                                          <p:stCondLst>
+                                            <p:cond delay="0"/>
+                                          </p:stCondLst>
+                                        </p:cTn>
+                                        <p:tgtEl>
+                                          <p:spTgt spid="13"/>
+                                        </p:tgtEl>
+                                        <p:attrNameLst>
+                                          <p:attrName>style.visibility</p:attrName>
+                                        </p:attrNameLst>
+                                      </p:cBhvr>
+                                      <p:to>
+                                        <p:strVal val="visible"/>
+                                      </p:to>
+                                    </p:set>
+                                  </p:childTnLst>
+                                </p:cTn>
+                              </p:par>
+                              <p:par>
+                                <p:cTn id="27" presetID="1" presetClass="entr" presetSubtype="0" fill="hold" nodeType="withEffect">
+                                  <p:stCondLst>
+                                    <p:cond delay="0"/>
+                                  </p:stCondLst>
+                                  <p:childTnLst>
+                                    <p:set>
+                                      <p:cBhvr>
+                                        <p:cTn id="28" dur="1" fill="hold">
+                                          <p:stCondLst>
+                                            <p:cond delay="0"/>
+                                          </p:stCondLst>
+                                        </p:cTn>
+                                        <p:tgtEl>
+                                          <p:spTgt spid="14"/>
+                                        </p:tgtEl>
+                                        <p:attrNameLst>
+                                          <p:attrName>style.visibility</p:attrName>
+                                        </p:attrNameLst>
+                                      </p:cBhvr>
+                                      <p:to>
+                                        <p:strVal val="visible"/>
+                                      </p:to>
+                                    </p:set>
+                                  </p:childTnLst>
+                                </p:cTn>
+                              </p:par>
+                              <p:par>
+                                <p:cTn id="29" presetID="1" presetClass="entr" presetSubtype="0" fill="hold" nodeType="withEffect">
+                                  <p:stCondLst>
+                                    <p:cond delay="0"/>
+                                  </p:stCondLst>
+                                  <p:childTnLst>
+                                    <p:set>
+                                      <p:cBhvr>
+                                        <p:cTn id="30" dur="1" fill="hold">
+                                          <p:stCondLst>
+                                            <p:cond delay="0"/>
+                                          </p:stCondLst>
+                                        </p:cTn>
+                                        <p:tgtEl>
+                                          <p:spTgt spid="15"/>
+                                        </p:tgtEl>
+                                        <p:attrNameLst>
+                                          <p:attrName>style.visibility</p:attrName>
+                                        </p:attrNameLst>
+                                      </p:cBhvr>
+                                      <p:to>
+                                        <p:strVal val="visible"/>
+                                      </p:to>
+                                    </p:set>
+                                  </p:childTnLst>
+                                </p:cTn>
+                              </p:par>
+                            </p:childTnLst>
+                          </p:cTn>
+                        </p:par>
+                      </p:childTnLst>
+                    </p:cTn>
+                  </p:par>
+                  <p:par>
+                    <p:cTn id="31" fill="hold">
+                      <p:stCondLst>
+                        <p:cond delay="indefinite"/>
+                      </p:stCondLst>
+                      <p:childTnLst>
+                        <p:par>
+                          <p:cTn id="32" fill="hold">
+                            <p:stCondLst>
+                              <p:cond delay="0"/>
+                            </p:stCondLst>
+                            <p:childTnLst>
+                              <p:par>
+                                <p:cTn id="33" presetID="1" presetClass="entr" presetSubtype="0" fill="hold" nodeType="clickEffect">
+                                  <p:stCondLst>
+                                    <p:cond delay="0"/>
+                                  </p:stCondLst>
+                                  <p:childTnLst>
+                                    <p:set>
+                                      <p:cBhvr>
+                                        <p:cTn id="34" dur="1" fill="hold">
+                                          <p:stCondLst>
+                                            <p:cond delay="0"/>
+                                          </p:stCondLst>
+                                        </p:cTn>
+                                        <p:tgtEl>
+                                          <p:spTgt spid="32"/>
+                                        </p:tgtEl>
+                                        <p:attrNameLst>
+                                          <p:attrName>style.visibility</p:attrName>
+                                        </p:attrNameLst>
+                                      </p:cBhvr>
+                                      <p:to>
+                                        <p:strVal val="visible"/>
+                                      </p:to>
+                                    </p:set>
+                                  </p:childTnLst>
+                                </p:cTn>
+                              </p:par>
+                            </p:childTnLst>
+                          </p:cTn>
+                        </p:par>
+                      </p:childTnLst>
+                    </p:cTn>
+                  </p:par>
+                  <p:par>
+                    <p:cTn id="35" fill="hold">
+                      <p:stCondLst>
+                        <p:cond delay="indefinite"/>
+                      </p:stCondLst>
+                      <p:childTnLst>
+                        <p:par>
+                          <p:cTn id="36" fill="hold">
+                            <p:stCondLst>
+                              <p:cond delay="0"/>
+                            </p:stCondLst>
+                            <p:childTnLst>
+                              <p:par>
+                                <p:cTn id="37" presetID="1" presetClass="entr" presetSubtype="0" fill="hold" nodeType="clickEffect">
+                                  <p:stCondLst>
+                                    <p:cond delay="0"/>
+                                  </p:stCondLst>
+                                  <p:childTnLst>
+                                    <p:set>
+                                      <p:cBhvr>
+                                        <p:cTn id="38" dur="1" fill="hold">
+                                          <p:stCondLst>
+                                            <p:cond delay="0"/>
+                                          </p:stCondLst>
+                                        </p:cTn>
+                                        <p:tgtEl>
+                                          <p:spTgt spid="16"/>
+                                        </p:tgtEl>
+                                        <p:attrNameLst>
+                                          <p:attrName>style.visibility</p:attrName>
+                                        </p:attrNameLst>
+                                      </p:cBhvr>
+                                      <p:to>
+                                        <p:strVal val="visible"/>
+                                      </p:to>
+                                    </p:set>
+                                  </p:childTnLst>
+                                </p:cTn>
+                              </p:par>
+                              <p:par>
+                                <p:cTn id="39" presetID="1" presetClass="entr" presetSubtype="0" fill="hold" nodeType="withEffect">
+                                  <p:stCondLst>
+                                    <p:cond delay="0"/>
+                                  </p:stCondLst>
+                                  <p:childTnLst>
+                                    <p:set>
+                                      <p:cBhvr>
+                                        <p:cTn id="40" dur="1" fill="hold">
+                                          <p:stCondLst>
+                                            <p:cond delay="0"/>
+                                          </p:stCondLst>
+                                        </p:cTn>
+                                        <p:tgtEl>
+                                          <p:spTgt spid="17"/>
+                                        </p:tgtEl>
+                                        <p:attrNameLst>
+                                          <p:attrName>style.visibility</p:attrName>
+                                        </p:attrNameLst>
+                                      </p:cBhvr>
+                                      <p:to>
+                                        <p:strVal val="visible"/>
+                                      </p:to>
+                                    </p:set>
+                                  </p:childTnLst>
+                                </p:cTn>
+                              </p:par>
+                              <p:par>
+                                <p:cTn id="41" presetID="1" presetClass="entr" presetSubtype="0" fill="hold" nodeType="withEffect">
+                                  <p:stCondLst>
+                                    <p:cond delay="0"/>
+                                  </p:stCondLst>
+                                  <p:childTnLst>
+                                    <p:set>
+                                      <p:cBhvr>
+                                        <p:cTn id="42" dur="1" fill="hold">
+                                          <p:stCondLst>
+                                            <p:cond delay="0"/>
+                                          </p:stCondLst>
+                                        </p:cTn>
+                                        <p:tgtEl>
+                                          <p:spTgt spid="18"/>
+                                        </p:tgtEl>
+                                        <p:attrNameLst>
+                                          <p:attrName>style.visibility</p:attrName>
+                                        </p:attrNameLst>
+                                      </p:cBhvr>
+                                      <p:to>
+                                        <p:strVal val="visible"/>
+                                      </p:to>
+                                    </p:set>
+                                  </p:childTnLst>
+                                </p:cTn>
+                              </p:par>
+                              <p:par>
+                                <p:cTn id="43" presetID="1" presetClass="entr" presetSubtype="0" fill="hold" nodeType="withEffect">
+                                  <p:stCondLst>
+                                    <p:cond delay="0"/>
+                                  </p:stCondLst>
+                                  <p:childTnLst>
+                                    <p:set>
+                                      <p:cBhvr>
+                                        <p:cTn id="44" dur="1" fill="hold">
+                                          <p:stCondLst>
+                                            <p:cond delay="0"/>
+                                          </p:stCondLst>
+                                        </p:cTn>
+                                        <p:tgtEl>
+                                          <p:spTgt spid="19"/>
+                                        </p:tgtEl>
+                                        <p:attrNameLst>
+                                          <p:attrName>style.visibility</p:attrName>
+                                        </p:attrNameLst>
+                                      </p:cBhvr>
+                                      <p:to>
+                                        <p:strVal val="visible"/>
+                                      </p:to>
+                                    </p:set>
+                                  </p:childTnLst>
+                                </p:cTn>
+                              </p:par>
+                            </p:childTnLst>
+                          </p:cTn>
+                        </p:par>
+                      </p:childTnLst>
+                    </p:cTn>
+                  </p:par>
+                  <p:par>
+                    <p:cTn id="45" fill="hold">
+                      <p:stCondLst>
+                        <p:cond delay="indefinite"/>
+                      </p:stCondLst>
+                      <p:childTnLst>
+                        <p:par>
+                          <p:cTn id="46" fill="hold">
+                            <p:stCondLst>
+                              <p:cond delay="0"/>
+                            </p:stCondLst>
+                            <p:childTnLst>
+                              <p:par>
+                                <p:cTn id="47" presetID="1" presetClass="entr" presetSubtype="0" fill="hold" nodeType="clickEffect">
+                                  <p:stCondLst>
+                                    <p:cond delay="0"/>
+                                  </p:stCondLst>
+                                  <p:childTnLst>
+                                    <p:set>
+                                      <p:cBhvr>
+                                        <p:cTn id="48" dur="1" fill="hold">
+                                          <p:stCondLst>
+                                            <p:cond delay="0"/>
+                                          </p:stCondLst>
+                                        </p:cTn>
+                                        <p:tgtEl>
+                                          <p:spTgt spid="20"/>
+                                        </p:tgtEl>
+                                        <p:attrNameLst>
+                                          <p:attrName>style.visibility</p:attrName>
+                                        </p:attrNameLst>
+                                      </p:cBhvr>
+                                      <p:to>
+                                        <p:strVal val="visible"/>
+                                      </p:to>
+                                    </p:set>
+                                  </p:childTnLst>
+                                </p:cTn>
+                              </p:par>
+                              <p:par>
+                                <p:cTn id="49" presetID="1" presetClass="entr" presetSubtype="0" fill="hold" nodeType="withEffect">
+                                  <p:stCondLst>
+                                    <p:cond delay="0"/>
+                                  </p:stCondLst>
+                                  <p:childTnLst>
+                                    <p:set>
+                                      <p:cBhvr>
+                                        <p:cTn id="50" dur="1" fill="hold">
+                                          <p:stCondLst>
+                                            <p:cond delay="0"/>
+                                          </p:stCondLst>
+                                        </p:cTn>
+                                        <p:tgtEl>
+                                          <p:spTgt spid="21"/>
+                                        </p:tgtEl>
+                                        <p:attrNameLst>
+                                          <p:attrName>style.visibility</p:attrName>
+                                        </p:attrNameLst>
+                                      </p:cBhvr>
+                                      <p:to>
+                                        <p:strVal val="visible"/>
+                                      </p:to>
+                                    </p:set>
+                                  </p:childTnLst>
+                                </p:cTn>
+                              </p:par>
+                            </p:childTnLst>
+                          </p:cTn>
+                        </p:par>
+                      </p:childTnLst>
+                    </p:cTn>
+                  </p:par>
+                </p:childTnLst>
+              </p:cTn>
+              <p:prevCondLst>
+                <p:cond evt="onPrev" delay="0">
+                  <p:tgtEl>
+                    <p:sldTgt/>
+                  </p:tgtEl>
+                </p:cond>
+              </p:prevCondLst>
+              <p:nextCondLst>
+                <p:cond evt="onNext" delay="0">
+                  <p:tgtEl>
+                    <p:sldTgt/>
+                  </p:tgtEl>
+                </p:cond>
+              </p:nextCondLst>
+            </p:seq>
+          </p:childTnLst>
+        </p:cTn>
+      </p:par>
+    </p:tnLst>
+  </p:timing>
+</p:sld>
+</file>
+
+<file path=ppt/slides/slide4.xml><?xml version="1.0" encoding="utf-8"?>
+<p:sld xmlns:p="http://schemas.openxmlformats.org/presentationml/2006/main">
+  <p:cSld>
+    <p:bg>
+      <p:bgPr>
+        <a:solidFill xmlns:a="http://schemas.openxmlformats.org/drawingml/2006/main">
+          <a:srgbClr val="FBF4E8"/>
+        </a:solidFill>
+      </p:bgPr>
+    </p:bg>
+    <p:spTree>
+      <p:nvGrpSpPr>
+        <p:cNvPr id="1" name=""/>
+        <p:cNvGrpSpPr/>
+        <p:nvPr/>
+      </p:nvGrpSpPr>
+      <p:grpSpPr>
+        <a:xfrm xmlns:a="http://schemas.openxmlformats.org/drawingml/2006/main"/>
+      </p:grpSpPr>
+      <p:sp>
+        <p:nvSpPr>
+          <p:cNvPr id="23" name="">
+            <a:extLst xmlns:a="http://schemas.openxmlformats.org/drawingml/2006/main">
+              <a:ext uri="{FF2B5EF4-FFF2-40B4-BE49-F238E27FC236}">
+                <a16:creationId xmlns:a16="http://schemas.microsoft.com/office/drawing/2014/main" id="{6908996D-D0BA-4BCC-B379-DC7C4E52B11C}"/>
+              </a:ext>
+            </a:extLst>
+          </p:cNvPr>
+          <p:cNvSpPr>
+            <a:spLocks xmlns:a="http://schemas.openxmlformats.org/drawingml/2006/main" noGrp="1"/>
+          </p:cNvSpPr>
+          <p:nvPr/>
+        </p:nvSpPr>
+        <p:spPr>
+          <a:xfrm xmlns:a="http://schemas.openxmlformats.org/drawingml/2006/main">
+            <a:off x="0" y="0"/>
+            <a:ext cx="12192000" cy="152400"/>
+          </a:xfrm>
+          <a:prstGeom xmlns:a="http://schemas.openxmlformats.org/drawingml/2006/main" prst="rect">
+            <a:avLst/>
+          </a:prstGeom>
+          <a:solidFill xmlns:a="http://schemas.openxmlformats.org/drawingml/2006/main">
+            <a:srgbClr val="F28C28"/>
+          </a:solidFill>
+          <a:ln xmlns:a="http://schemas.openxmlformats.org/drawingml/2006/main" w="0">
+            <a:noFill/>
+          </a:ln>
+        </p:spPr>
+      </p:sp>
+      <p:sp>
+        <p:nvSpPr>
+          <p:cNvPr id="2" name="">
+            <a:extLst xmlns:a="http://schemas.openxmlformats.org/drawingml/2006/main">
+              <a:ext uri="{FF2B5EF4-FFF2-40B4-BE49-F238E27FC236}">
+                <a16:creationId xmlns:a16="http://schemas.microsoft.com/office/drawing/2014/main" id="{43736EB2-3BA9-4CD9-AC10-A5E59EECF0D1}"/>
+              </a:ext>
+            </a:extLst>
+          </p:cNvPr>
+          <p:cNvSpPr>
+            <a:spLocks xmlns:a="http://schemas.openxmlformats.org/drawingml/2006/main" noGrp="1"/>
+          </p:cNvSpPr>
+          <p:nvPr/>
+        </p:nvSpPr>
+        <p:spPr>
+          <a:xfrm xmlns:a="http://schemas.openxmlformats.org/drawingml/2006/main">
+            <a:off x="685800" y="323850"/>
+            <a:ext cx="3048000" cy="285750"/>
+          </a:xfrm>
+          <a:prstGeom xmlns:a="http://schemas.openxmlformats.org/drawingml/2006/main" prst="rect">
+            <a:avLst/>
+          </a:prstGeom>
+          <a:noFill xmlns:a="http://schemas.openxmlformats.org/drawingml/2006/main"/>
+          <a:ln xmlns:a="http://schemas.openxmlformats.org/drawingml/2006/main" w="0">
+            <a:noFill/>
+          </a:ln>
+        </p:spPr>
+        <p:txBody>
+          <a:bodyPr xmlns:a="http://schemas.openxmlformats.org/drawingml/2006/main" anchor="ctr">
+            <a:normAutofit fontScale="94444"/>
+          </a:bodyPr>
+          <a:lstStyle xmlns:a="http://schemas.openxmlformats.org/drawingml/2006/main"/>
+          <a:p xmlns:a="http://schemas.openxmlformats.org/drawingml/2006/main">
+            <a:pPr>
+              <a:defRPr sz="1350" b="1">
+                <a:solidFill>
+                  <a:srgbClr val="188A86"/>
+                </a:solidFill>
+                <a:latin typeface="Helvetica Neue"/>
+                <a:ea typeface="Helvetica Neue"/>
+                <a:cs typeface="Helvetica Neue"/>
+              </a:defRPr>
+            </a:pPr>
+            <a:r>
+              <a:rPr sz="1350" b="1">
+                <a:solidFill>
+                  <a:srgbClr val="188A86"/>
+                </a:solidFill>
+                <a:latin typeface="Helvetica Neue"/>
+                <a:ea typeface="Helvetica Neue"/>
+                <a:cs typeface="Helvetica Neue"/>
+              </a:rPr>
+              <a:t>ICEBREAKER  4/4</a:t>
+            </a:r>
+          </a:p>
+        </p:txBody>
+      </p:sp>
+      <p:sp>
+        <p:nvSpPr>
+          <p:cNvPr id="3" name="">
+            <a:extLst xmlns:a="http://schemas.openxmlformats.org/drawingml/2006/main">
+              <a:ext uri="{FF2B5EF4-FFF2-40B4-BE49-F238E27FC236}">
+                <a16:creationId xmlns:a16="http://schemas.microsoft.com/office/drawing/2014/main" id="{AB5B6A36-2079-4A8F-BF17-B70A82C6F3DD}"/>
+              </a:ext>
+            </a:extLst>
+          </p:cNvPr>
+          <p:cNvSpPr>
+            <a:spLocks xmlns:a="http://schemas.openxmlformats.org/drawingml/2006/main" noGrp="1"/>
+          </p:cNvSpPr>
+          <p:nvPr/>
+        </p:nvSpPr>
+        <p:spPr>
+          <a:xfrm xmlns:a="http://schemas.openxmlformats.org/drawingml/2006/main">
+            <a:off x="685800" y="666750"/>
+            <a:ext cx="10820400" cy="628650"/>
+          </a:xfrm>
+          <a:prstGeom xmlns:a="http://schemas.openxmlformats.org/drawingml/2006/main" prst="rect">
+            <a:avLst/>
+          </a:prstGeom>
+          <a:noFill xmlns:a="http://schemas.openxmlformats.org/drawingml/2006/main"/>
+          <a:ln xmlns:a="http://schemas.openxmlformats.org/drawingml/2006/main" w="0">
+            <a:noFill/>
+          </a:ln>
+        </p:spPr>
+        <p:txBody>
+          <a:bodyPr xmlns:a="http://schemas.openxmlformats.org/drawingml/2006/main" anchor="ctr">
+            <a:normAutofit fontScale="100000"/>
+          </a:bodyPr>
+          <a:lstStyle xmlns:a="http://schemas.openxmlformats.org/drawingml/2006/main"/>
+          <a:p xmlns:a="http://schemas.openxmlformats.org/drawingml/2006/main">
+            <a:pPr>
+              <a:defRPr sz="3150" b="1">
+                <a:solidFill>
+                  <a:srgbClr val="17324D"/>
+                </a:solidFill>
+                <a:latin typeface="Helvetica Neue"/>
+                <a:ea typeface="Helvetica Neue"/>
+                <a:cs typeface="Helvetica Neue"/>
+              </a:defRPr>
+            </a:pPr>
+            <a:r>
+              <a:rPr sz="3150" b="1">
+                <a:solidFill>
+                  <a:srgbClr val="17324D"/>
+                </a:solidFill>
+                <a:latin typeface="Helvetica Neue"/>
+                <a:ea typeface="Helvetica Neue"/>
+                <a:cs typeface="Helvetica Neue"/>
+              </a:rPr>
+              <a:t>One scene, three business words</a:t>
+            </a:r>
+          </a:p>
+        </p:txBody>
+      </p:sp>
+      <p:sp>
+        <p:nvSpPr>
+          <p:cNvPr id="4" name="">
+            <a:extLst xmlns:a="http://schemas.openxmlformats.org/drawingml/2006/main">
+              <a:ext uri="{FF2B5EF4-FFF2-40B4-BE49-F238E27FC236}">
+                <a16:creationId xmlns:a16="http://schemas.microsoft.com/office/drawing/2014/main" id="{FF146C32-61CE-4E5C-B83C-08C8ECA9568A}"/>
+              </a:ext>
+            </a:extLst>
+          </p:cNvPr>
+          <p:cNvSpPr>
+            <a:spLocks xmlns:a="http://schemas.openxmlformats.org/drawingml/2006/main" noGrp="1"/>
+          </p:cNvSpPr>
+          <p:nvPr/>
+        </p:nvSpPr>
+        <p:spPr>
+          <a:xfrm xmlns:a="http://schemas.openxmlformats.org/drawingml/2006/main">
+            <a:off x="685800" y="1257300"/>
+            <a:ext cx="10820400" cy="342900"/>
+          </a:xfrm>
+          <a:prstGeom xmlns:a="http://schemas.openxmlformats.org/drawingml/2006/main" prst="rect">
+            <a:avLst/>
+          </a:prstGeom>
+          <a:noFill xmlns:a="http://schemas.openxmlformats.org/drawingml/2006/main"/>
+          <a:ln xmlns:a="http://schemas.openxmlformats.org/drawingml/2006/main" w="0">
+            <a:noFill/>
+          </a:ln>
+        </p:spPr>
+        <p:txBody>
+          <a:bodyPr xmlns:a="http://schemas.openxmlformats.org/drawingml/2006/main" anchor="ctr">
+            <a:normAutofit fontScale="100000"/>
+          </a:bodyPr>
+          <a:lstStyle xmlns:a="http://schemas.openxmlformats.org/drawingml/2006/main"/>
+          <a:p xmlns:a="http://schemas.openxmlformats.org/drawingml/2006/main">
+            <a:pPr>
+              <a:defRPr sz="1575" b="0">
+                <a:solidFill>
+                  <a:srgbClr val="22313F"/>
+                </a:solidFill>
+                <a:latin typeface="Helvetica Neue"/>
+                <a:ea typeface="Helvetica Neue"/>
+                <a:cs typeface="Helvetica Neue"/>
+              </a:defRPr>
+            </a:pPr>
+            <a:r>
+              <a:rPr sz="1575" b="0">
+                <a:solidFill>
+                  <a:srgbClr val="22313F"/>
+                </a:solidFill>
+                <a:latin typeface="Helvetica Neue"/>
+                <a:ea typeface="Helvetica Neue"/>
+                <a:cs typeface="Helvetica Neue"/>
+              </a:rPr>
+              <a:t>Use the picture to connect business, marketing, and product.</a:t>
+            </a:r>
+          </a:p>
+        </p:txBody>
+      </p:sp>
+      <p:sp>
+        <p:nvSpPr>
+          <p:cNvPr id="5" name="">
+            <a:extLst xmlns:a="http://schemas.openxmlformats.org/drawingml/2006/main">
+              <a:ext uri="{FF2B5EF4-FFF2-40B4-BE49-F238E27FC236}">
+                <a16:creationId xmlns:a16="http://schemas.microsoft.com/office/drawing/2014/main" id="{26BE87A8-5863-4F62-A0B4-5D016A8E089C}"/>
+              </a:ext>
+            </a:extLst>
+          </p:cNvPr>
+          <p:cNvSpPr>
+            <a:spLocks xmlns:a="http://schemas.openxmlformats.org/drawingml/2006/main" noGrp="1"/>
+          </p:cNvSpPr>
+          <p:nvPr/>
+        </p:nvSpPr>
+        <p:spPr>
+          <a:xfrm xmlns:a="http://schemas.openxmlformats.org/drawingml/2006/main">
+            <a:off x="9601200" y="361950"/>
+            <a:ext cx="1905000" cy="361950"/>
+          </a:xfrm>
+          <a:prstGeom xmlns:a="http://schemas.openxmlformats.org/drawingml/2006/main" prst="roundRect">
+            <a:avLst>
+              <a:gd name="adj" fmla="val 47368"/>
+            </a:avLst>
+          </a:prstGeom>
+          <a:solidFill xmlns:a="http://schemas.openxmlformats.org/drawingml/2006/main">
+            <a:srgbClr val="17324D"/>
+          </a:solidFill>
+          <a:ln xmlns:a="http://schemas.openxmlformats.org/drawingml/2006/main" w="0">
+            <a:noFill/>
+          </a:ln>
+        </p:spPr>
+      </p:sp>
+      <p:sp>
+        <p:nvSpPr>
+          <p:cNvPr id="6" name="">
+            <a:extLst xmlns:a="http://schemas.openxmlformats.org/drawingml/2006/main">
+              <a:ext uri="{FF2B5EF4-FFF2-40B4-BE49-F238E27FC236}">
+                <a16:creationId xmlns:a16="http://schemas.microsoft.com/office/drawing/2014/main" id="{45E82CC4-E212-4BF6-B166-69A52F4179F0}"/>
+              </a:ext>
+            </a:extLst>
+          </p:cNvPr>
+          <p:cNvSpPr>
+            <a:spLocks xmlns:a="http://schemas.openxmlformats.org/drawingml/2006/main" noGrp="1"/>
+          </p:cNvSpPr>
+          <p:nvPr/>
+        </p:nvSpPr>
+        <p:spPr>
+          <a:xfrm xmlns:a="http://schemas.openxmlformats.org/drawingml/2006/main">
+            <a:off x="9753600" y="400050"/>
+            <a:ext cx="1600200" cy="266700"/>
+          </a:xfrm>
+          <a:prstGeom xmlns:a="http://schemas.openxmlformats.org/drawingml/2006/main" prst="rect">
+            <a:avLst/>
+          </a:prstGeom>
+          <a:noFill xmlns:a="http://schemas.openxmlformats.org/drawingml/2006/main"/>
+          <a:ln xmlns:a="http://schemas.openxmlformats.org/drawingml/2006/main" w="0">
+            <a:noFill/>
+          </a:ln>
+        </p:spPr>
+        <p:txBody>
+          <a:bodyPr xmlns:a="http://schemas.openxmlformats.org/drawingml/2006/main" anchor="ctr">
+            <a:normAutofit fontScale="95833"/>
+          </a:bodyPr>
+          <a:lstStyle xmlns:a="http://schemas.openxmlformats.org/drawingml/2006/main"/>
+          <a:p xmlns:a="http://schemas.openxmlformats.org/drawingml/2006/main">
+            <a:pPr>
+              <a:defRPr sz="1200" b="1">
+                <a:solidFill>
+                  <a:srgbClr val="FFFFFF"/>
+                </a:solidFill>
+                <a:latin typeface="Helvetica Neue"/>
+                <a:ea typeface="Helvetica Neue"/>
+                <a:cs typeface="Helvetica Neue"/>
+              </a:defRPr>
+            </a:pPr>
+            <a:r>
+              <a:rPr sz="1200" b="1">
+                <a:solidFill>
+                  <a:srgbClr val="FFFFFF"/>
+                </a:solidFill>
+                <a:latin typeface="Helvetica Neue"/>
+                <a:ea typeface="Helvetica Neue"/>
+                <a:cs typeface="Helvetica Neue"/>
+              </a:rPr>
+              <a:t>⏱  3 MIN MAX</a:t>
+            </a:r>
+          </a:p>
+        </p:txBody>
+      </p:sp>
+      <p:sp>
+        <p:nvSpPr>
+          <p:cNvPr id="7" name="">
+            <a:extLst xmlns:a="http://schemas.openxmlformats.org/drawingml/2006/main">
+              <a:ext uri="{FF2B5EF4-FFF2-40B4-BE49-F238E27FC236}">
+                <a16:creationId xmlns:a16="http://schemas.microsoft.com/office/drawing/2014/main" id="{21F716E1-E227-4988-B7B0-1E837D661C96}"/>
+              </a:ext>
+            </a:extLst>
+          </p:cNvPr>
+          <p:cNvSpPr>
+            <a:spLocks xmlns:a="http://schemas.openxmlformats.org/drawingml/2006/main" noGrp="1"/>
+          </p:cNvSpPr>
+          <p:nvPr/>
+        </p:nvSpPr>
+        <p:spPr>
+          <a:xfrm xmlns:a="http://schemas.openxmlformats.org/drawingml/2006/main">
+            <a:off x="10763250" y="6400800"/>
+            <a:ext cx="742950" cy="228600"/>
+          </a:xfrm>
+          <a:prstGeom xmlns:a="http://schemas.openxmlformats.org/drawingml/2006/main" prst="rect">
+            <a:avLst/>
+          </a:prstGeom>
+          <a:noFill xmlns:a="http://schemas.openxmlformats.org/drawingml/2006/main"/>
+          <a:ln xmlns:a="http://schemas.openxmlformats.org/drawingml/2006/main" w="0">
+            <a:noFill/>
+          </a:ln>
+        </p:spPr>
+        <p:txBody>
+          <a:bodyPr xmlns:a="http://schemas.openxmlformats.org/drawingml/2006/main" anchor="ctr">
+            <a:normAutofit fontScale="80000"/>
+          </a:bodyPr>
+          <a:lstStyle xmlns:a="http://schemas.openxmlformats.org/drawingml/2006/main"/>
+          <a:p xmlns:a="http://schemas.openxmlformats.org/drawingml/2006/main">
+            <a:pPr>
+              <a:defRPr sz="1125" b="1">
+                <a:solidFill>
+                  <a:srgbClr val="188A86"/>
+                </a:solidFill>
+                <a:latin typeface="Helvetica Neue"/>
+                <a:ea typeface="Helvetica Neue"/>
+                <a:cs typeface="Helvetica Neue"/>
+              </a:defRPr>
+            </a:pPr>
+            <a:r>
+              <a:rPr sz="1125" b="1">
+                <a:solidFill>
+                  <a:srgbClr val="188A86"/>
+                </a:solidFill>
+                <a:latin typeface="Helvetica Neue"/>
+                <a:ea typeface="Helvetica Neue"/>
+                <a:cs typeface="Helvetica Neue"/>
+              </a:rPr>
+              <a:t>4/4</a:t>
+            </a:r>
+          </a:p>
+        </p:txBody>
+      </p:sp>
+      <p:sp>
+        <p:nvSpPr>
+          <p:cNvPr id="8" name="">
+            <a:extLst xmlns:a="http://schemas.openxmlformats.org/drawingml/2006/main">
+              <a:ext uri="{FF2B5EF4-FFF2-40B4-BE49-F238E27FC236}">
+                <a16:creationId xmlns:a16="http://schemas.microsoft.com/office/drawing/2014/main" id="{2FD952B5-E235-459F-8276-19C04C469766}"/>
+              </a:ext>
+            </a:extLst>
+          </p:cNvPr>
+          <p:cNvSpPr>
+            <a:spLocks xmlns:a="http://schemas.openxmlformats.org/drawingml/2006/main" noGrp="1"/>
+          </p:cNvSpPr>
+          <p:nvPr/>
+        </p:nvSpPr>
+        <p:spPr>
+          <a:xfrm xmlns:a="http://schemas.openxmlformats.org/drawingml/2006/main">
+            <a:off x="5905500" y="1809750"/>
+            <a:ext cx="5410200" cy="952500"/>
+          </a:xfrm>
+          <a:prstGeom xmlns:a="http://schemas.openxmlformats.org/drawingml/2006/main" prst="roundRect">
+            <a:avLst>
+              <a:gd name="adj" fmla="val 20000"/>
+            </a:avLst>
+          </a:prstGeom>
+          <a:solidFill xmlns:a="http://schemas.openxmlformats.org/drawingml/2006/main">
+            <a:srgbClr val="DDEEDB"/>
+          </a:solidFill>
+          <a:ln xmlns:a="http://schemas.openxmlformats.org/drawingml/2006/main" w="0">
+            <a:noFill/>
+          </a:ln>
+        </p:spPr>
+      </p:sp>
+      <p:sp>
+        <p:nvSpPr>
+          <p:cNvPr id="9" name="">
+            <a:extLst xmlns:a="http://schemas.openxmlformats.org/drawingml/2006/main">
+              <a:ext uri="{FF2B5EF4-FFF2-40B4-BE49-F238E27FC236}">
+                <a16:creationId xmlns:a16="http://schemas.microsoft.com/office/drawing/2014/main" id="{DAD80966-B316-426A-9F4A-8A56E3601380}"/>
+              </a:ext>
+            </a:extLst>
+          </p:cNvPr>
+          <p:cNvSpPr>
+            <a:spLocks xmlns:a="http://schemas.openxmlformats.org/drawingml/2006/main" noGrp="1"/>
+          </p:cNvSpPr>
+          <p:nvPr/>
+        </p:nvSpPr>
+        <p:spPr>
+          <a:xfrm xmlns:a="http://schemas.openxmlformats.org/drawingml/2006/main">
+            <a:off x="857250" y="1866900"/>
+            <a:ext cx="514350" cy="419100"/>
+          </a:xfrm>
+          <a:prstGeom xmlns:a="http://schemas.openxmlformats.org/drawingml/2006/main" prst="rect">
+            <a:avLst/>
+          </a:prstGeom>
+          <a:noFill xmlns:a="http://schemas.openxmlformats.org/drawingml/2006/main"/>
+          <a:ln xmlns:a="http://schemas.openxmlformats.org/drawingml/2006/main" w="0">
+            <a:noFill/>
+          </a:ln>
+        </p:spPr>
+        <p:txBody>
+          <a:bodyPr xmlns:a="http://schemas.openxmlformats.org/drawingml/2006/main" anchor="ctr">
+            <a:normAutofit fontScale="100000"/>
+          </a:bodyPr>
+          <a:lstStyle xmlns:a="http://schemas.openxmlformats.org/drawingml/2006/main"/>
+          <a:p xmlns:a="http://schemas.openxmlformats.org/drawingml/2006/main">
+            <a:pPr>
+              <a:defRPr sz="1800" b="1">
+                <a:solidFill>
+                  <a:srgbClr val="188A86"/>
+                </a:solidFill>
+                <a:latin typeface="Helvetica Neue"/>
+                <a:ea typeface="Helvetica Neue"/>
+                <a:cs typeface="Helvetica Neue"/>
+              </a:defRPr>
+            </a:pPr>
+            <a:r>
+              <a:rPr sz="1800" b="1">
+                <a:solidFill>
+                  <a:srgbClr val="188A86"/>
+                </a:solidFill>
+                <a:latin typeface="Helvetica Neue"/>
+                <a:ea typeface="Helvetica Neue"/>
+                <a:cs typeface="Helvetica Neue"/>
+              </a:rPr>
+              <a:t/>
+            </a:r>
+          </a:p>
+        </p:txBody>
+      </p:sp>
+      <p:sp>
+        <p:nvSpPr>
+          <p:cNvPr id="10" name="">
+            <a:extLst xmlns:a="http://schemas.openxmlformats.org/drawingml/2006/main">
+              <a:ext uri="{FF2B5EF4-FFF2-40B4-BE49-F238E27FC236}">
+                <a16:creationId xmlns:a16="http://schemas.microsoft.com/office/drawing/2014/main" id="{28CB8FB7-4FAA-4DEE-ADF5-CB96C29A852C}"/>
+              </a:ext>
+            </a:extLst>
+          </p:cNvPr>
+          <p:cNvSpPr>
+            <a:spLocks xmlns:a="http://schemas.openxmlformats.org/drawingml/2006/main" noGrp="1"/>
+          </p:cNvSpPr>
+          <p:nvPr/>
+        </p:nvSpPr>
+        <p:spPr>
+          <a:xfrm xmlns:a="http://schemas.openxmlformats.org/drawingml/2006/main">
+            <a:off x="6115050" y="1885950"/>
+            <a:ext cx="4953000" cy="361950"/>
+          </a:xfrm>
+          <a:prstGeom xmlns:a="http://schemas.openxmlformats.org/drawingml/2006/main" prst="rect">
+            <a:avLst/>
+          </a:prstGeom>
+          <a:noFill xmlns:a="http://schemas.openxmlformats.org/drawingml/2006/main"/>
+          <a:ln xmlns:a="http://schemas.openxmlformats.org/drawingml/2006/main" w="0">
+            <a:noFill/>
+          </a:ln>
+        </p:spPr>
+        <p:txBody>
+          <a:bodyPr xmlns:a="http://schemas.openxmlformats.org/drawingml/2006/main" anchor="ctr">
+            <a:normAutofit fontScale="100000"/>
+          </a:bodyPr>
+          <a:lstStyle xmlns:a="http://schemas.openxmlformats.org/drawingml/2006/main"/>
+          <a:p xmlns:a="http://schemas.openxmlformats.org/drawingml/2006/main">
+            <a:pPr>
+              <a:defRPr sz="1800" b="1">
+                <a:solidFill>
+                  <a:srgbClr val="17324D"/>
+                </a:solidFill>
+                <a:latin typeface="Helvetica Neue"/>
+                <a:ea typeface="Helvetica Neue"/>
+                <a:cs typeface="Helvetica Neue"/>
+              </a:defRPr>
+            </a:pPr>
+            <a:r>
+              <a:rPr sz="1800" b="1">
+                <a:solidFill>
+                  <a:srgbClr val="17324D"/>
+                </a:solidFill>
+                <a:latin typeface="Helvetica Neue"/>
+                <a:ea typeface="Helvetica Neue"/>
+                <a:cs typeface="Helvetica Neue"/>
+              </a:rPr>
+              <a:t>BUSINESS</a:t>
+            </a:r>
+          </a:p>
+        </p:txBody>
+      </p:sp>
+      <p:sp>
+        <p:nvSpPr>
+          <p:cNvPr id="11" name="">
+            <a:extLst xmlns:a="http://schemas.openxmlformats.org/drawingml/2006/main">
+              <a:ext uri="{FF2B5EF4-FFF2-40B4-BE49-F238E27FC236}">
+                <a16:creationId xmlns:a16="http://schemas.microsoft.com/office/drawing/2014/main" id="{EB3DF6BE-1146-49D8-881E-B574D5512177}"/>
+              </a:ext>
+            </a:extLst>
+          </p:cNvPr>
+          <p:cNvSpPr>
+            <a:spLocks xmlns:a="http://schemas.openxmlformats.org/drawingml/2006/main" noGrp="1"/>
+          </p:cNvSpPr>
+          <p:nvPr/>
+        </p:nvSpPr>
+        <p:spPr>
+          <a:xfrm xmlns:a="http://schemas.openxmlformats.org/drawingml/2006/main">
+            <a:off x="6115050" y="2266950"/>
+            <a:ext cx="4953000" cy="400050"/>
+          </a:xfrm>
+          <a:prstGeom xmlns:a="http://schemas.openxmlformats.org/drawingml/2006/main" prst="rect">
+            <a:avLst/>
+          </a:prstGeom>
+          <a:noFill xmlns:a="http://schemas.openxmlformats.org/drawingml/2006/main"/>
+          <a:ln xmlns:a="http://schemas.openxmlformats.org/drawingml/2006/main" w="0">
+            <a:noFill/>
+          </a:ln>
+        </p:spPr>
+        <p:txBody>
+          <a:bodyPr xmlns:a="http://schemas.openxmlformats.org/drawingml/2006/main" anchor="ctr">
+            <a:normAutofit fontScale="85185"/>
+          </a:bodyPr>
+          <a:lstStyle xmlns:a="http://schemas.openxmlformats.org/drawingml/2006/main"/>
+          <a:p xmlns:a="http://schemas.openxmlformats.org/drawingml/2006/main">
+            <a:pPr>
+              <a:defRPr sz="1500" b="0">
+                <a:solidFill>
+                  <a:srgbClr val="22313F"/>
+                </a:solidFill>
+                <a:latin typeface="Helvetica Neue"/>
+                <a:ea typeface="Helvetica Neue"/>
+                <a:cs typeface="Helvetica Neue"/>
+              </a:defRPr>
+            </a:pPr>
+            <a:r>
+              <a:rPr sz="1500" b="0">
+                <a:solidFill>
+                  <a:srgbClr val="22313F"/>
+                </a:solidFill>
+                <a:latin typeface="Helvetica Neue"/>
+                <a:ea typeface="Helvetica Neue"/>
+                <a:cs typeface="Helvetica Neue"/>
+              </a:rPr>
+              <a:t>The shoe seller offers products for money.</a:t>
+            </a:r>
+          </a:p>
+        </p:txBody>
+      </p:sp>
+      <p:sp>
+        <p:nvSpPr>
+          <p:cNvPr id="12" name="">
+            <a:extLst xmlns:a="http://schemas.openxmlformats.org/drawingml/2006/main">
+              <a:ext uri="{FF2B5EF4-FFF2-40B4-BE49-F238E27FC236}">
+                <a16:creationId xmlns:a16="http://schemas.microsoft.com/office/drawing/2014/main" id="{E3999E8D-CCD4-4199-9D1C-A262CA08D8E0}"/>
+              </a:ext>
+            </a:extLst>
+          </p:cNvPr>
+          <p:cNvSpPr>
+            <a:spLocks xmlns:a="http://schemas.openxmlformats.org/drawingml/2006/main" noGrp="1"/>
+          </p:cNvSpPr>
+          <p:nvPr/>
+        </p:nvSpPr>
+        <p:spPr>
+          <a:xfrm xmlns:a="http://schemas.openxmlformats.org/drawingml/2006/main">
+            <a:off x="5905500" y="2952750"/>
+            <a:ext cx="5410200" cy="952500"/>
+          </a:xfrm>
+          <a:prstGeom xmlns:a="http://schemas.openxmlformats.org/drawingml/2006/main" prst="roundRect">
+            <a:avLst>
+              <a:gd name="adj" fmla="val 20000"/>
+            </a:avLst>
+          </a:prstGeom>
+          <a:solidFill xmlns:a="http://schemas.openxmlformats.org/drawingml/2006/main">
+            <a:srgbClr val="DCEEF4"/>
+          </a:solidFill>
+          <a:ln xmlns:a="http://schemas.openxmlformats.org/drawingml/2006/main" w="0">
+            <a:noFill/>
+          </a:ln>
+        </p:spPr>
+      </p:sp>
+      <p:sp>
+        <p:nvSpPr>
+          <p:cNvPr id="13" name="">
+            <a:extLst xmlns:a="http://schemas.openxmlformats.org/drawingml/2006/main">
+              <a:ext uri="{FF2B5EF4-FFF2-40B4-BE49-F238E27FC236}">
+                <a16:creationId xmlns:a16="http://schemas.microsoft.com/office/drawing/2014/main" id="{4FD1A511-A824-4276-97C3-49F680D1E862}"/>
+              </a:ext>
+            </a:extLst>
+          </p:cNvPr>
+          <p:cNvSpPr>
+            <a:spLocks xmlns:a="http://schemas.openxmlformats.org/drawingml/2006/main" noGrp="1"/>
+          </p:cNvSpPr>
+          <p:nvPr/>
+        </p:nvSpPr>
+        <p:spPr>
+          <a:xfrm xmlns:a="http://schemas.openxmlformats.org/drawingml/2006/main">
+            <a:off x="857250" y="2914650"/>
+            <a:ext cx="514350" cy="419100"/>
+          </a:xfrm>
+          <a:prstGeom xmlns:a="http://schemas.openxmlformats.org/drawingml/2006/main" prst="rect">
+            <a:avLst/>
+          </a:prstGeom>
+          <a:noFill xmlns:a="http://schemas.openxmlformats.org/drawingml/2006/main"/>
+          <a:ln xmlns:a="http://schemas.openxmlformats.org/drawingml/2006/main" w="0">
+            <a:noFill/>
+          </a:ln>
+        </p:spPr>
+        <p:txBody>
+          <a:bodyPr xmlns:a="http://schemas.openxmlformats.org/drawingml/2006/main" anchor="ctr">
+            <a:normAutofit fontScale="100000"/>
+          </a:bodyPr>
+          <a:lstStyle xmlns:a="http://schemas.openxmlformats.org/drawingml/2006/main"/>
+          <a:p xmlns:a="http://schemas.openxmlformats.org/drawingml/2006/main">
+            <a:pPr>
+              <a:defRPr sz="1800" b="1">
+                <a:solidFill>
+                  <a:srgbClr val="188A86"/>
+                </a:solidFill>
+                <a:latin typeface="Helvetica Neue"/>
+                <a:ea typeface="Helvetica Neue"/>
+                <a:cs typeface="Helvetica Neue"/>
+              </a:defRPr>
+            </a:pPr>
+            <a:r>
+              <a:rPr sz="1800" b="1">
+                <a:solidFill>
+                  <a:srgbClr val="188A86"/>
+                </a:solidFill>
+                <a:latin typeface="Helvetica Neue"/>
+                <a:ea typeface="Helvetica Neue"/>
+                <a:cs typeface="Helvetica Neue"/>
+              </a:rPr>
+              <a:t/>
+            </a:r>
+          </a:p>
+        </p:txBody>
+      </p:sp>
+      <p:sp>
+        <p:nvSpPr>
+          <p:cNvPr id="14" name="">
+            <a:extLst xmlns:a="http://schemas.openxmlformats.org/drawingml/2006/main">
+              <a:ext uri="{FF2B5EF4-FFF2-40B4-BE49-F238E27FC236}">
+                <a16:creationId xmlns:a16="http://schemas.microsoft.com/office/drawing/2014/main" id="{8894C891-12D3-45A1-B3F4-5E534EA354F2}"/>
+              </a:ext>
+            </a:extLst>
+          </p:cNvPr>
+          <p:cNvSpPr>
+            <a:spLocks xmlns:a="http://schemas.openxmlformats.org/drawingml/2006/main" noGrp="1"/>
+          </p:cNvSpPr>
+          <p:nvPr/>
+        </p:nvSpPr>
+        <p:spPr>
+          <a:xfrm xmlns:a="http://schemas.openxmlformats.org/drawingml/2006/main">
+            <a:off x="6115050" y="3028950"/>
+            <a:ext cx="4953000" cy="361950"/>
+          </a:xfrm>
+          <a:prstGeom xmlns:a="http://schemas.openxmlformats.org/drawingml/2006/main" prst="rect">
+            <a:avLst/>
+          </a:prstGeom>
+          <a:noFill xmlns:a="http://schemas.openxmlformats.org/drawingml/2006/main"/>
+          <a:ln xmlns:a="http://schemas.openxmlformats.org/drawingml/2006/main" w="0">
+            <a:noFill/>
+          </a:ln>
+        </p:spPr>
+        <p:txBody>
+          <a:bodyPr xmlns:a="http://schemas.openxmlformats.org/drawingml/2006/main" anchor="ctr">
+            <a:normAutofit fontScale="100000"/>
+          </a:bodyPr>
+          <a:lstStyle xmlns:a="http://schemas.openxmlformats.org/drawingml/2006/main"/>
+          <a:p xmlns:a="http://schemas.openxmlformats.org/drawingml/2006/main">
+            <a:pPr>
+              <a:defRPr sz="1800" b="1">
+                <a:solidFill>
+                  <a:srgbClr val="17324D"/>
+                </a:solidFill>
+                <a:latin typeface="Helvetica Neue"/>
+                <a:ea typeface="Helvetica Neue"/>
+                <a:cs typeface="Helvetica Neue"/>
+              </a:defRPr>
+            </a:pPr>
+            <a:r>
+              <a:rPr sz="1800" b="1">
+                <a:solidFill>
+                  <a:srgbClr val="17324D"/>
+                </a:solidFill>
+                <a:latin typeface="Helvetica Neue"/>
+                <a:ea typeface="Helvetica Neue"/>
+                <a:cs typeface="Helvetica Neue"/>
+              </a:rPr>
+              <a:t>MARKETING</a:t>
+            </a:r>
+          </a:p>
+        </p:txBody>
+      </p:sp>
+      <p:sp>
+        <p:nvSpPr>
+          <p:cNvPr id="15" name="">
+            <a:extLst xmlns:a="http://schemas.openxmlformats.org/drawingml/2006/main">
+              <a:ext uri="{FF2B5EF4-FFF2-40B4-BE49-F238E27FC236}">
+                <a16:creationId xmlns:a16="http://schemas.microsoft.com/office/drawing/2014/main" id="{DE66F23B-2E54-45DD-B66E-C36CF9EAC95E}"/>
+              </a:ext>
+            </a:extLst>
+          </p:cNvPr>
+          <p:cNvSpPr>
+            <a:spLocks xmlns:a="http://schemas.openxmlformats.org/drawingml/2006/main" noGrp="1"/>
+          </p:cNvSpPr>
+          <p:nvPr/>
+        </p:nvSpPr>
+        <p:spPr>
+          <a:xfrm xmlns:a="http://schemas.openxmlformats.org/drawingml/2006/main">
+            <a:off x="6115050" y="3409950"/>
+            <a:ext cx="4953000" cy="400050"/>
+          </a:xfrm>
+          <a:prstGeom xmlns:a="http://schemas.openxmlformats.org/drawingml/2006/main" prst="rect">
+            <a:avLst/>
+          </a:prstGeom>
+          <a:noFill xmlns:a="http://schemas.openxmlformats.org/drawingml/2006/main"/>
+          <a:ln xmlns:a="http://schemas.openxmlformats.org/drawingml/2006/main" w="0">
+            <a:noFill/>
+          </a:ln>
+        </p:spPr>
+        <p:txBody>
+          <a:bodyPr xmlns:a="http://schemas.openxmlformats.org/drawingml/2006/main" anchor="ctr">
+            <a:normAutofit fontScale="85185"/>
+          </a:bodyPr>
+          <a:lstStyle xmlns:a="http://schemas.openxmlformats.org/drawingml/2006/main"/>
+          <a:p xmlns:a="http://schemas.openxmlformats.org/drawingml/2006/main">
+            <a:pPr>
+              <a:defRPr sz="1500" b="0">
+                <a:solidFill>
+                  <a:srgbClr val="22313F"/>
+                </a:solidFill>
+                <a:latin typeface="Helvetica Neue"/>
+                <a:ea typeface="Helvetica Neue"/>
+                <a:cs typeface="Helvetica Neue"/>
+              </a:defRPr>
+            </a:pPr>
+            <a:r>
+              <a:rPr sz="1500" b="0">
+                <a:solidFill>
+                  <a:srgbClr val="22313F"/>
+                </a:solidFill>
+                <a:latin typeface="Helvetica Neue"/>
+                <a:ea typeface="Helvetica Neue"/>
+                <a:cs typeface="Helvetica Neue"/>
+              </a:rPr>
+              <a:t>The seller promotes and sells what customers may want.</a:t>
+            </a:r>
+          </a:p>
+        </p:txBody>
+      </p:sp>
+      <p:sp>
+        <p:nvSpPr>
+          <p:cNvPr id="16" name="">
+            <a:extLst xmlns:a="http://schemas.openxmlformats.org/drawingml/2006/main">
+              <a:ext uri="{FF2B5EF4-FFF2-40B4-BE49-F238E27FC236}">
+                <a16:creationId xmlns:a16="http://schemas.microsoft.com/office/drawing/2014/main" id="{B712951A-1031-4483-93D8-3E963AE83D2B}"/>
+              </a:ext>
+            </a:extLst>
+          </p:cNvPr>
+          <p:cNvSpPr>
+            <a:spLocks xmlns:a="http://schemas.openxmlformats.org/drawingml/2006/main" noGrp="1"/>
+          </p:cNvSpPr>
+          <p:nvPr/>
+        </p:nvSpPr>
+        <p:spPr>
+          <a:xfrm xmlns:a="http://schemas.openxmlformats.org/drawingml/2006/main">
+            <a:off x="5905500" y="4095750"/>
+            <a:ext cx="5410200" cy="952500"/>
+          </a:xfrm>
+          <a:prstGeom xmlns:a="http://schemas.openxmlformats.org/drawingml/2006/main" prst="roundRect">
+            <a:avLst>
+              <a:gd name="adj" fmla="val 20000"/>
+            </a:avLst>
+          </a:prstGeom>
+          <a:solidFill xmlns:a="http://schemas.openxmlformats.org/drawingml/2006/main">
+            <a:srgbClr val="F8E2A8"/>
+          </a:solidFill>
+          <a:ln xmlns:a="http://schemas.openxmlformats.org/drawingml/2006/main" w="0">
+            <a:noFill/>
+          </a:ln>
+        </p:spPr>
+      </p:sp>
+      <p:sp>
+        <p:nvSpPr>
+          <p:cNvPr id="17" name="">
+            <a:extLst xmlns:a="http://schemas.openxmlformats.org/drawingml/2006/main">
+              <a:ext uri="{FF2B5EF4-FFF2-40B4-BE49-F238E27FC236}">
+                <a16:creationId xmlns:a16="http://schemas.microsoft.com/office/drawing/2014/main" id="{CB4E42B6-3939-4FC5-8F69-DF7E88C6FDBB}"/>
+              </a:ext>
+            </a:extLst>
+          </p:cNvPr>
+          <p:cNvSpPr>
+            <a:spLocks xmlns:a="http://schemas.openxmlformats.org/drawingml/2006/main" noGrp="1"/>
+          </p:cNvSpPr>
+          <p:nvPr/>
+        </p:nvSpPr>
+        <p:spPr>
+          <a:xfrm xmlns:a="http://schemas.openxmlformats.org/drawingml/2006/main">
+            <a:off x="857250" y="3962400"/>
+            <a:ext cx="514350" cy="419100"/>
+          </a:xfrm>
+          <a:prstGeom xmlns:a="http://schemas.openxmlformats.org/drawingml/2006/main" prst="rect">
+            <a:avLst/>
+          </a:prstGeom>
+          <a:noFill xmlns:a="http://schemas.openxmlformats.org/drawingml/2006/main"/>
+          <a:ln xmlns:a="http://schemas.openxmlformats.org/drawingml/2006/main" w="0">
+            <a:noFill/>
+          </a:ln>
+        </p:spPr>
+        <p:txBody>
+          <a:bodyPr xmlns:a="http://schemas.openxmlformats.org/drawingml/2006/main" anchor="ctr">
+            <a:normAutofit fontScale="100000"/>
+          </a:bodyPr>
+          <a:lstStyle xmlns:a="http://schemas.openxmlformats.org/drawingml/2006/main"/>
+          <a:p xmlns:a="http://schemas.openxmlformats.org/drawingml/2006/main">
+            <a:pPr>
+              <a:defRPr sz="1800" b="1">
+                <a:solidFill>
+                  <a:srgbClr val="188A86"/>
+                </a:solidFill>
+                <a:latin typeface="Helvetica Neue"/>
+                <a:ea typeface="Helvetica Neue"/>
+                <a:cs typeface="Helvetica Neue"/>
+              </a:defRPr>
+            </a:pPr>
+            <a:r>
+              <a:rPr sz="1800" b="1">
+                <a:solidFill>
+                  <a:srgbClr val="188A86"/>
+                </a:solidFill>
+                <a:latin typeface="Helvetica Neue"/>
+                <a:ea typeface="Helvetica Neue"/>
+                <a:cs typeface="Helvetica Neue"/>
+              </a:rPr>
+              <a:t/>
+            </a:r>
+          </a:p>
+        </p:txBody>
+      </p:sp>
+      <p:sp>
+        <p:nvSpPr>
+          <p:cNvPr id="18" name="">
+            <a:extLst xmlns:a="http://schemas.openxmlformats.org/drawingml/2006/main">
+              <a:ext uri="{FF2B5EF4-FFF2-40B4-BE49-F238E27FC236}">
+                <a16:creationId xmlns:a16="http://schemas.microsoft.com/office/drawing/2014/main" id="{1550986A-FB48-436C-80CD-DB7A9F484837}"/>
+              </a:ext>
+            </a:extLst>
+          </p:cNvPr>
+          <p:cNvSpPr>
+            <a:spLocks xmlns:a="http://schemas.openxmlformats.org/drawingml/2006/main" noGrp="1"/>
+          </p:cNvSpPr>
+          <p:nvPr/>
+        </p:nvSpPr>
+        <p:spPr>
+          <a:xfrm xmlns:a="http://schemas.openxmlformats.org/drawingml/2006/main">
+            <a:off x="6115050" y="4171950"/>
+            <a:ext cx="4953000" cy="361950"/>
+          </a:xfrm>
+          <a:prstGeom xmlns:a="http://schemas.openxmlformats.org/drawingml/2006/main" prst="rect">
+            <a:avLst/>
+          </a:prstGeom>
+          <a:noFill xmlns:a="http://schemas.openxmlformats.org/drawingml/2006/main"/>
+          <a:ln xmlns:a="http://schemas.openxmlformats.org/drawingml/2006/main" w="0">
+            <a:noFill/>
+          </a:ln>
+        </p:spPr>
+        <p:txBody>
+          <a:bodyPr xmlns:a="http://schemas.openxmlformats.org/drawingml/2006/main" anchor="ctr">
+            <a:normAutofit fontScale="100000"/>
+          </a:bodyPr>
+          <a:lstStyle xmlns:a="http://schemas.openxmlformats.org/drawingml/2006/main"/>
+          <a:p xmlns:a="http://schemas.openxmlformats.org/drawingml/2006/main">
+            <a:pPr>
+              <a:defRPr sz="1800" b="1">
+                <a:solidFill>
+                  <a:srgbClr val="17324D"/>
+                </a:solidFill>
+                <a:latin typeface="Helvetica Neue"/>
+                <a:ea typeface="Helvetica Neue"/>
+                <a:cs typeface="Helvetica Neue"/>
+              </a:defRPr>
+            </a:pPr>
+            <a:r>
+              <a:rPr sz="1800" b="1">
+                <a:solidFill>
+                  <a:srgbClr val="17324D"/>
+                </a:solidFill>
+                <a:latin typeface="Helvetica Neue"/>
+                <a:ea typeface="Helvetica Neue"/>
+                <a:cs typeface="Helvetica Neue"/>
+              </a:rPr>
+              <a:t>PRODUCT</a:t>
+            </a:r>
+          </a:p>
+        </p:txBody>
+      </p:sp>
+      <p:sp>
+        <p:nvSpPr>
+          <p:cNvPr id="19" name="">
+            <a:extLst xmlns:a="http://schemas.openxmlformats.org/drawingml/2006/main">
+              <a:ext uri="{FF2B5EF4-FFF2-40B4-BE49-F238E27FC236}">
+                <a16:creationId xmlns:a16="http://schemas.microsoft.com/office/drawing/2014/main" id="{77C2586A-46F6-4676-BE06-9E80D279A69B}"/>
+              </a:ext>
+            </a:extLst>
+          </p:cNvPr>
+          <p:cNvSpPr>
+            <a:spLocks xmlns:a="http://schemas.openxmlformats.org/drawingml/2006/main" noGrp="1"/>
+          </p:cNvSpPr>
+          <p:nvPr/>
+        </p:nvSpPr>
+        <p:spPr>
+          <a:xfrm xmlns:a="http://schemas.openxmlformats.org/drawingml/2006/main">
+            <a:off x="6115050" y="4552950"/>
+            <a:ext cx="4953000" cy="400050"/>
+          </a:xfrm>
+          <a:prstGeom xmlns:a="http://schemas.openxmlformats.org/drawingml/2006/main" prst="rect">
+            <a:avLst/>
+          </a:prstGeom>
+          <a:noFill xmlns:a="http://schemas.openxmlformats.org/drawingml/2006/main"/>
+          <a:ln xmlns:a="http://schemas.openxmlformats.org/drawingml/2006/main" w="0">
+            <a:noFill/>
+          </a:ln>
+        </p:spPr>
+        <p:txBody>
+          <a:bodyPr xmlns:a="http://schemas.openxmlformats.org/drawingml/2006/main" anchor="ctr">
+            <a:normAutofit fontScale="85185"/>
+          </a:bodyPr>
+          <a:lstStyle xmlns:a="http://schemas.openxmlformats.org/drawingml/2006/main"/>
+          <a:p xmlns:a="http://schemas.openxmlformats.org/drawingml/2006/main">
+            <a:pPr>
+              <a:defRPr sz="1500" b="0">
+                <a:solidFill>
+                  <a:srgbClr val="22313F"/>
+                </a:solidFill>
+                <a:latin typeface="Helvetica Neue"/>
+                <a:ea typeface="Helvetica Neue"/>
+                <a:cs typeface="Helvetica Neue"/>
+              </a:defRPr>
+            </a:pPr>
+            <a:r>
+              <a:rPr sz="1500" b="0">
+                <a:solidFill>
+                  <a:srgbClr val="22313F"/>
+                </a:solidFill>
+                <a:latin typeface="Helvetica Neue"/>
+                <a:ea typeface="Helvetica Neue"/>
+                <a:cs typeface="Helvetica Neue"/>
+              </a:rPr>
+              <a:t>The sneakers are goods offered to customers.</a:t>
+            </a:r>
+          </a:p>
+        </p:txBody>
+      </p:sp>
+      <p:sp>
+        <p:nvSpPr>
+          <p:cNvPr id="20" name="">
+            <a:extLst xmlns:a="http://schemas.openxmlformats.org/drawingml/2006/main">
+              <a:ext uri="{FF2B5EF4-FFF2-40B4-BE49-F238E27FC236}">
+                <a16:creationId xmlns:a16="http://schemas.microsoft.com/office/drawing/2014/main" id="{B46D6A6A-C547-47B7-A131-C1F74396DE12}"/>
+              </a:ext>
+            </a:extLst>
+          </p:cNvPr>
+          <p:cNvSpPr>
+            <a:spLocks xmlns:a="http://schemas.openxmlformats.org/drawingml/2006/main" noGrp="1"/>
+          </p:cNvSpPr>
+          <p:nvPr/>
+        </p:nvSpPr>
+        <p:spPr>
+          <a:xfrm xmlns:a="http://schemas.openxmlformats.org/drawingml/2006/main">
+            <a:off x="685800" y="5191125"/>
+            <a:ext cx="10820400" cy="952500"/>
+          </a:xfrm>
+          <a:prstGeom xmlns:a="http://schemas.openxmlformats.org/drawingml/2006/main" prst="roundRect">
+            <a:avLst>
+              <a:gd name="adj" fmla="val 15517"/>
+            </a:avLst>
+          </a:prstGeom>
+          <a:solidFill xmlns:a="http://schemas.openxmlformats.org/drawingml/2006/main">
+            <a:srgbClr val="17324D"/>
+          </a:solidFill>
+          <a:ln xmlns:a="http://schemas.openxmlformats.org/drawingml/2006/main" w="0">
+            <a:noFill/>
+          </a:ln>
+        </p:spPr>
+      </p:sp>
+      <p:sp>
+        <p:nvSpPr>
+          <p:cNvPr id="21" name="">
+            <a:extLst xmlns:a="http://schemas.openxmlformats.org/drawingml/2006/main">
+              <a:ext uri="{FF2B5EF4-FFF2-40B4-BE49-F238E27FC236}">
+                <a16:creationId xmlns:a16="http://schemas.microsoft.com/office/drawing/2014/main" id="{2B08615C-B493-43F3-928E-6BC71E099D5E}"/>
+              </a:ext>
+            </a:extLst>
+          </p:cNvPr>
+          <p:cNvSpPr>
+            <a:spLocks xmlns:a="http://schemas.openxmlformats.org/drawingml/2006/main" noGrp="1"/>
+          </p:cNvSpPr>
+          <p:nvPr/>
+        </p:nvSpPr>
+        <p:spPr>
+          <a:xfrm xmlns:a="http://schemas.openxmlformats.org/drawingml/2006/main">
+            <a:off x="876300" y="5286375"/>
+            <a:ext cx="10439400" cy="457200"/>
+          </a:xfrm>
+          <a:prstGeom xmlns:a="http://schemas.openxmlformats.org/drawingml/2006/main" prst="rect">
+            <a:avLst/>
+          </a:prstGeom>
+          <a:noFill xmlns:a="http://schemas.openxmlformats.org/drawingml/2006/main"/>
+          <a:ln xmlns:a="http://schemas.openxmlformats.org/drawingml/2006/main" w="0">
+            <a:noFill/>
+          </a:ln>
+        </p:spPr>
+        <p:txBody>
+          <a:bodyPr xmlns:a="http://schemas.openxmlformats.org/drawingml/2006/main" anchor="ctr">
+            <a:normAutofit fontScale="100000"/>
+          </a:bodyPr>
+          <a:lstStyle xmlns:a="http://schemas.openxmlformats.org/drawingml/2006/main"/>
+          <a:p xmlns:a="http://schemas.openxmlformats.org/drawingml/2006/main">
+            <a:pPr>
+              <a:defRPr sz="1650" b="1">
+                <a:solidFill>
+                  <a:srgbClr val="FFFFFF"/>
+                </a:solidFill>
+                <a:latin typeface="Helvetica Neue"/>
+                <a:ea typeface="Helvetica Neue"/>
+                <a:cs typeface="Helvetica Neue"/>
+              </a:defRPr>
+            </a:pPr>
+            <a:r>
+              <a:rPr sz="1650" b="1">
+                <a:solidFill>
+                  <a:srgbClr val="FFFFFF"/>
+                </a:solidFill>
+                <a:latin typeface="Helvetica Neue"/>
+                <a:ea typeface="Helvetica Neue"/>
+                <a:cs typeface="Helvetica Neue"/>
+              </a:rPr>
+              <a:t>One picture can show a business, marketing, and a product.</a:t>
+            </a:r>
+          </a:p>
+        </p:txBody>
+      </p:sp>
+      <p:sp>
+        <p:nvSpPr>
+          <p:cNvPr id="22" name="">
+            <a:extLst xmlns:a="http://schemas.openxmlformats.org/drawingml/2006/main">
+              <a:ext uri="{FF2B5EF4-FFF2-40B4-BE49-F238E27FC236}">
+                <a16:creationId xmlns:a16="http://schemas.microsoft.com/office/drawing/2014/main" id="{51A6E292-D856-4002-A94E-EAE76AEFB4EC}"/>
+              </a:ext>
+            </a:extLst>
+          </p:cNvPr>
+          <p:cNvSpPr>
+            <a:spLocks xmlns:a="http://schemas.openxmlformats.org/drawingml/2006/main" noGrp="1"/>
+          </p:cNvSpPr>
+          <p:nvPr/>
+        </p:nvSpPr>
+        <p:spPr>
+          <a:xfrm xmlns:a="http://schemas.openxmlformats.org/drawingml/2006/main">
+            <a:off x="990600" y="5762625"/>
+            <a:ext cx="10287000" cy="266700"/>
+          </a:xfrm>
+          <a:prstGeom xmlns:a="http://schemas.openxmlformats.org/drawingml/2006/main" prst="rect">
+            <a:avLst/>
+          </a:prstGeom>
+          <a:noFill xmlns:a="http://schemas.openxmlformats.org/drawingml/2006/main"/>
+          <a:ln xmlns:a="http://schemas.openxmlformats.org/drawingml/2006/main" w="0">
+            <a:noFill/>
+          </a:ln>
+        </p:spPr>
+        <p:txBody>
+          <a:bodyPr xmlns:a="http://schemas.openxmlformats.org/drawingml/2006/main" anchor="ctr">
+            <a:normAutofit fontScale="80000"/>
+          </a:bodyPr>
+          <a:lstStyle xmlns:a="http://schemas.openxmlformats.org/drawingml/2006/main"/>
+          <a:p xmlns:a="http://schemas.openxmlformats.org/drawingml/2006/main">
+            <a:pPr>
+              <a:defRPr sz="1300" b="1">
+                <a:solidFill>
+                  <a:srgbClr val="DCEEF4"/>
+                </a:solidFill>
+                <a:latin typeface="Helvetica Neue"/>
+                <a:ea typeface="Helvetica Neue"/>
+                <a:cs typeface="Helvetica Neue"/>
+              </a:defRPr>
+            </a:pPr>
+            <a:r>
+              <a:rPr sz="1300" b="1">
+                <a:solidFill>
+                  <a:srgbClr val="DCEEF4"/>
+                </a:solidFill>
+                <a:latin typeface="Helvetica Neue"/>
+                <a:ea typeface="Helvetica Neue"/>
+                <a:cs typeface="Helvetica Neue"/>
+              </a:rPr>
+              <a:t>NEXT: Open page 4, then continue today’s Chapter 1 work.</a:t>
+            </a:r>
+          </a:p>
+        </p:txBody>
+      </p:sp>
+      <p:pic>
+        <p:nvPicPr>
+          <p:cNvPr id="30" name=""/>
+          <p:cNvPicPr>
+            <a:picLocks xmlns:a="http://schemas.openxmlformats.org/drawingml/2006/main" noChangeAspect="1"/>
+          </p:cNvPicPr>
+          <p:nvPr/>
+        </p:nvPicPr>
+        <p:blipFill>
+          <a:blip xmlns:r="http://schemas.openxmlformats.org/officeDocument/2006/relationships" xmlns:a="http://schemas.openxmlformats.org/drawingml/2006/main" r:embed="RimgScene"/>
+          <a:srcRect xmlns:a="http://schemas.openxmlformats.org/drawingml/2006/main" l="0" t="1233" r="0" b="1233"/>
+          <a:stretch xmlns:a="http://schemas.openxmlformats.org/drawingml/2006/main">
+            <a:fillRect l="0" t="0" r="0" b="0"/>
+          </a:stretch>
+        </p:blipFill>
+        <p:spPr>
+          <a:xfrm xmlns:a="http://schemas.openxmlformats.org/drawingml/2006/main">
+            <a:off x="685800" y="1809750"/>
+            <a:ext cx="4762500" cy="3238500"/>
+          </a:xfrm>
+          <a:prstGeom xmlns:a="http://schemas.openxmlformats.org/drawingml/2006/main" prst="roundRect">
+            <a:avLst>
+              <a:gd name="adj" fmla="val 8871"/>
+            </a:avLst>
+          </a:prstGeom>
+        </p:spPr>
+      </p:pic>
+    </p:spTree>
+    <p:extLst>
+      <p:ext uri="{BB962C8B-B14F-4D97-AF65-F5344CB8AC3E}">
+        <p14:creationId xmlns:p14="http://schemas.microsoft.com/office/powerpoint/2010/main" val="2046019007"/>
+      </p:ext>
+    </p:extLst>
+  </p:cSld>
+  <p:timing>
+    <p:tnLst>
+      <p:par>
+        <p:cTn id="1" dur="indefinite" restart="never" nodeType="tmRoot">
+          <p:childTnLst>
+            <p:seq concurrent="1" nextAc="seek">
+              <p:cTn id="2" dur="indefinite" nodeType="mainSeq">
+                <p:childTnLst>
+                  <p:par>
+                    <p:cTn id="3" fill="hold">
+                      <p:stCondLst>
+                        <p:cond delay="indefinite"/>
+                      </p:stCondLst>
+                      <p:childTnLst>
+                        <p:par>
+                          <p:cTn id="4" fill="hold">
+                            <p:stCondLst>
+                              <p:cond delay="0"/>
+                            </p:stCondLst>
+                            <p:childTnLst>
+                              <p:par>
+                                <p:cTn id="5" presetID="1" presetClass="entr" presetSubtype="0" fill="hold" nodeType="clickEffect">
+                                  <p:stCondLst>
+                                    <p:cond delay="0"/>
+                                  </p:stCondLst>
+                                  <p:childTnLst>
+                                    <p:set>
+                                      <p:cBhvr>
+                                        <p:cTn id="6" dur="1" fill="hold">
+                                          <p:stCondLst>
+                                            <p:cond delay="0"/>
+                                          </p:stCondLst>
+                                        </p:cTn>
+                                        <p:tgtEl>
+                                          <p:spTgt spid="30"/>
+                                        </p:tgtEl>
+                                        <p:attrNameLst>
+                                          <p:attrName>style.visibility</p:attrName>
+                                        </p:attrNameLst>
+                                      </p:cBhvr>
+                                      <p:to>
+                                        <p:strVal val="visible"/>
+                                      </p:to>
+                                    </p:set>
+                                  </p:childTnLst>
+                                </p:cTn>
+                              </p:par>
+                            </p:childTnLst>
+                          </p:cTn>
+                        </p:par>
+                      </p:childTnLst>
+                    </p:cTn>
+                  </p:par>
+                  <p:par>
+                    <p:cTn id="7" fill="hold">
+                      <p:stCondLst>
+                        <p:cond delay="indefinite"/>
+                      </p:stCondLst>
+                      <p:childTnLst>
+                        <p:par>
+                          <p:cTn id="8" fill="hold">
+                            <p:stCondLst>
+                              <p:cond delay="0"/>
+                            </p:stCondLst>
+                            <p:childTnLst>
+                              <p:par>
+                                <p:cTn id="9" presetID="1" presetClass="entr" presetSubtype="0" fill="hold" nodeType="clickEffect">
+                                  <p:stCondLst>
+                                    <p:cond delay="0"/>
+                                  </p:stCondLst>
+                                  <p:childTnLst>
+                                    <p:set>
+                                      <p:cBhvr>
+                                        <p:cTn id="10" dur="1" fill="hold">
+                                          <p:stCondLst>
+                                            <p:cond delay="0"/>
+                                          </p:stCondLst>
+                                        </p:cTn>
+                                        <p:tgtEl>
+                                          <p:spTgt spid="8"/>
+                                        </p:tgtEl>
+                                        <p:attrNameLst>
+                                          <p:attrName>style.visibility</p:attrName>
+                                        </p:attrNameLst>
+                                      </p:cBhvr>
+                                      <p:to>
+                                        <p:strVal val="visible"/>
+                                      </p:to>
+                                    </p:set>
+                                  </p:childTnLst>
+                                </p:cTn>
+                              </p:par>
+                              <p:par>
+                                <p:cTn id="11" presetID="1" presetClass="entr" presetSubtype="0" fill="hold" nodeType="withEffect">
+                                  <p:stCondLst>
+                                    <p:cond delay="0"/>
+                                  </p:stCondLst>
+                                  <p:childTnLst>
+                                    <p:set>
+                                      <p:cBhvr>
+                                        <p:cTn id="12" dur="1" fill="hold">
+                                          <p:stCondLst>
+                                            <p:cond delay="0"/>
+                                          </p:stCondLst>
+                                        </p:cTn>
+                                        <p:tgtEl>
+                                          <p:spTgt spid="10"/>
+                                        </p:tgtEl>
+                                        <p:attrNameLst>
+                                          <p:attrName>style.visibility</p:attrName>
+                                        </p:attrNameLst>
+                                      </p:cBhvr>
+                                      <p:to>
+                                        <p:strVal val="visible"/>
+                                      </p:to>
+                                    </p:set>
+                                  </p:childTnLst>
+                                </p:cTn>
+                              </p:par>
+                              <p:par>
+                                <p:cTn id="13" presetID="1" presetClass="entr" presetSubtype="0" fill="hold" nodeType="withEffect">
+                                  <p:stCondLst>
+                                    <p:cond delay="0"/>
+                                  </p:stCondLst>
+                                  <p:childTnLst>
+                                    <p:set>
+                                      <p:cBhvr>
+                                        <p:cTn id="14" dur="1" fill="hold">
+                                          <p:stCondLst>
+                                            <p:cond delay="0"/>
+                                          </p:stCondLst>
+                                        </p:cTn>
+                                        <p:tgtEl>
+                                          <p:spTgt spid="11"/>
+                                        </p:tgtEl>
+                                        <p:attrNameLst>
+                                          <p:attrName>style.visibility</p:attrName>
+                                        </p:attrNameLst>
+                                      </p:cBhvr>
+                                      <p:to>
+                                        <p:strVal val="visible"/>
+                                      </p:to>
+                                    </p:set>
+                                  </p:childTnLst>
+                                </p:cTn>
+                              </p:par>
+                            </p:childTnLst>
+                          </p:cTn>
+                        </p:par>
+                      </p:childTnLst>
+                    </p:cTn>
+                  </p:par>
+                  <p:par>
+                    <p:cTn id="15" fill="hold">
+                      <p:stCondLst>
+                        <p:cond delay="indefinite"/>
+                      </p:stCondLst>
+                      <p:childTnLst>
+                        <p:par>
+                          <p:cTn id="16" fill="hold">
+                            <p:stCondLst>
+                              <p:cond delay="0"/>
+                            </p:stCondLst>
+                            <p:childTnLst>
+                              <p:par>
+                                <p:cTn id="17" presetID="1" presetClass="entr" presetSubtype="0" fill="hold" nodeType="clickEffect">
                                   <p:stCondLst>
                                     <p:cond delay="0"/>
                                   </p:stCondLst>
@@ -4317,7 +6162,7 @@
                                           </p:stCondLst>
                                         </p:cTn>
                                         <p:tgtEl>
-                                          <p:spTgt spid="13"/>
+                                          <p:spTgt spid="12"/>
                                         </p:tgtEl>
                                         <p:attrNameLst>
                                           <p:attrName>style.visibility</p:attrName>
@@ -4443,7 +6288,7 @@
                                           </p:stCondLst>
                                         </p:cTn>
                                         <p:tgtEl>
-                                          <p:spTgt spid="17"/>
+                                          <p:spTgt spid="18"/>
                                         </p:tgtEl>
                                         <p:attrNameLst>
                                           <p:attrName>style.visibility</p:attrName>
@@ -4470,33 +6315,6 @@
                                           </p:stCondLst>
                                         </p:cTn>
                                         <p:tgtEl>
-                                          <p:spTgt spid="18"/>
-                                        </p:tgtEl>
-                                        <p:attrNameLst>
-                                          <p:attrName>style.visibility</p:attrName>
-                                        </p:attrNameLst>
-                                      </p:cBhvr>
-                                      <p:to>
-                                        <p:strVal val="visible"/>
-                                      </p:to>
-                                    </p:set>
-                                  </p:childTnLst>
-                                </p:cTn>
-                              </p:par>
-                              <p:par>
-                                <p:cTn id="31" presetID="1" presetClass="entr" presetSubtype="0" fill="hold" nodeType="withEffect">
-                                  <p:stCondLst>
-                                    <p:cond delay="0"/>
-                                  </p:stCondLst>
-                                  <p:childTnLst>
-                                    <p:set>
-                                      <p:cBhvr>
-                                        <p:cTn id="32" dur="1" fill="hold">
-                                          <p:stCondLst>
-                                            <p:cond delay="0"/>
-                                          </p:stCondLst>
-                                        </p:cTn>
-                                        <p:tgtEl>
                                           <p:spTgt spid="19"/>
                                         </p:tgtEl>
                                         <p:attrNameLst>
@@ -4517,19 +6335,46 @@
                     </p:cTn>
                   </p:par>
                   <p:par>
-                    <p:cTn id="33" fill="hold">
+                    <p:cTn id="31" fill="hold">
                       <p:stCondLst>
                         <p:cond delay="indefinite"/>
                       </p:stCondLst>
                       <p:childTnLst>
                         <p:par>
-                          <p:cTn id="34" fill="hold">
+                          <p:cTn id="32" fill="hold">
                             <p:stCondLst>
                               <p:cond delay="0"/>
                             </p:stCondLst>
                             <p:childTnLst>
                               <p:par>
-                                <p:cTn id="35" presetID="1" presetClass="entr" presetSubtype="0" fill="hold" nodeType="clickEffect">
+                                <p:cTn id="33" presetID="1" presetClass="entr" presetSubtype="0" fill="hold" nodeType="clickEffect">
+                                  <p:stCondLst>
+                                    <p:cond delay="0"/>
+                                  </p:stCondLst>
+                                  <p:childTnLst>
+                                    <p:set>
+                                      <p:cBhvr>
+                                        <p:cTn id="34" dur="1" fill="hold">
+                                          <p:stCondLst>
+                                            <p:cond delay="0"/>
+                                          </p:stCondLst>
+                                        </p:cTn>
+                                        <p:tgtEl>
+                                          <p:spTgt spid="20"/>
+                                        </p:tgtEl>
+                                        <p:attrNameLst>
+                                          <p:attrName>style.visibility</p:attrName>
+                                        </p:attrNameLst>
+                                      </p:cBhvr>
+                                      <p:to>
+                                        <p:strVal val="visible"/>
+                                      </p:to>
+                                    </p:set>
+                                  </p:childTnLst>
+                                </p:cTn>
+                              </p:par>
+                              <p:par>
+                                <p:cTn id="35" presetID="1" presetClass="entr" presetSubtype="0" fill="hold" nodeType="withEffect">
                                   <p:stCondLst>
                                     <p:cond delay="0"/>
                                   </p:stCondLst>
@@ -4542,7 +6387,7 @@
                                           </p:stCondLst>
                                         </p:cTn>
                                         <p:tgtEl>
-                                          <p:spTgt spid="20"/>
+                                          <p:spTgt spid="21"/>
                                         </p:tgtEl>
                                         <p:attrNameLst>
                                           <p:attrName>style.visibility</p:attrName>
@@ -4564,1644 +6409,6 @@
                                     <p:set>
                                       <p:cBhvr>
                                         <p:cTn id="38" dur="1" fill="hold">
-                                          <p:stCondLst>
-                                            <p:cond delay="0"/>
-                                          </p:stCondLst>
-                                        </p:cTn>
-                                        <p:tgtEl>
-                                          <p:spTgt spid="21"/>
-                                        </p:tgtEl>
-                                        <p:attrNameLst>
-                                          <p:attrName>style.visibility</p:attrName>
-                                        </p:attrNameLst>
-                                      </p:cBhvr>
-                                      <p:to>
-                                        <p:strVal val="visible"/>
-                                      </p:to>
-                                    </p:set>
-                                  </p:childTnLst>
-                                </p:cTn>
-                              </p:par>
-                            </p:childTnLst>
-                          </p:cTn>
-                        </p:par>
-                      </p:childTnLst>
-                    </p:cTn>
-                  </p:par>
-                </p:childTnLst>
-              </p:cTn>
-              <p:prevCondLst>
-                <p:cond evt="onPrev" delay="0">
-                  <p:tgtEl>
-                    <p:sldTgt/>
-                  </p:tgtEl>
-                </p:cond>
-              </p:prevCondLst>
-              <p:nextCondLst>
-                <p:cond evt="onNext" delay="0">
-                  <p:tgtEl>
-                    <p:sldTgt/>
-                  </p:tgtEl>
-                </p:cond>
-              </p:nextCondLst>
-            </p:seq>
-          </p:childTnLst>
-        </p:cTn>
-      </p:par>
-    </p:tnLst>
-  </p:timing>
-</p:sld>
-</file>
-
-<file path=ppt/slides/slide4.xml><?xml version="1.0" encoding="utf-8"?>
-<p:sld xmlns:p="http://schemas.openxmlformats.org/presentationml/2006/main">
-  <p:cSld>
-    <p:bg>
-      <p:bgPr>
-        <a:solidFill xmlns:a="http://schemas.openxmlformats.org/drawingml/2006/main">
-          <a:srgbClr val="FBF4E8"/>
-        </a:solidFill>
-      </p:bgPr>
-    </p:bg>
-    <p:spTree>
-      <p:nvGrpSpPr>
-        <p:cNvPr id="1" name=""/>
-        <p:cNvGrpSpPr/>
-        <p:nvPr/>
-      </p:nvGrpSpPr>
-      <p:grpSpPr>
-        <a:xfrm xmlns:a="http://schemas.openxmlformats.org/drawingml/2006/main"/>
-      </p:grpSpPr>
-      <p:sp>
-        <p:nvSpPr>
-          <p:cNvPr id="23" name="">
-            <a:extLst xmlns:a="http://schemas.openxmlformats.org/drawingml/2006/main">
-              <a:ext uri="{FF2B5EF4-FFF2-40B4-BE49-F238E27FC236}">
-                <a16:creationId xmlns:a16="http://schemas.microsoft.com/office/drawing/2014/main" id="{6908996D-D0BA-4BCC-B379-DC7C4E52B11C}"/>
-              </a:ext>
-            </a:extLst>
-          </p:cNvPr>
-          <p:cNvSpPr>
-            <a:spLocks xmlns:a="http://schemas.openxmlformats.org/drawingml/2006/main" noGrp="1"/>
-          </p:cNvSpPr>
-          <p:nvPr/>
-        </p:nvSpPr>
-        <p:spPr>
-          <a:xfrm xmlns:a="http://schemas.openxmlformats.org/drawingml/2006/main">
-            <a:off x="0" y="0"/>
-            <a:ext cx="12192000" cy="152400"/>
-          </a:xfrm>
-          <a:prstGeom xmlns:a="http://schemas.openxmlformats.org/drawingml/2006/main" prst="rect">
-            <a:avLst/>
-          </a:prstGeom>
-          <a:solidFill xmlns:a="http://schemas.openxmlformats.org/drawingml/2006/main">
-            <a:srgbClr val="F28C28"/>
-          </a:solidFill>
-          <a:ln xmlns:a="http://schemas.openxmlformats.org/drawingml/2006/main" w="0">
-            <a:noFill/>
-          </a:ln>
-        </p:spPr>
-      </p:sp>
-      <p:sp>
-        <p:nvSpPr>
-          <p:cNvPr id="2" name="">
-            <a:extLst xmlns:a="http://schemas.openxmlformats.org/drawingml/2006/main">
-              <a:ext uri="{FF2B5EF4-FFF2-40B4-BE49-F238E27FC236}">
-                <a16:creationId xmlns:a16="http://schemas.microsoft.com/office/drawing/2014/main" id="{43736EB2-3BA9-4CD9-AC10-A5E59EECF0D1}"/>
-              </a:ext>
-            </a:extLst>
-          </p:cNvPr>
-          <p:cNvSpPr>
-            <a:spLocks xmlns:a="http://schemas.openxmlformats.org/drawingml/2006/main" noGrp="1"/>
-          </p:cNvSpPr>
-          <p:nvPr/>
-        </p:nvSpPr>
-        <p:spPr>
-          <a:xfrm xmlns:a="http://schemas.openxmlformats.org/drawingml/2006/main">
-            <a:off x="685800" y="323850"/>
-            <a:ext cx="3048000" cy="285750"/>
-          </a:xfrm>
-          <a:prstGeom xmlns:a="http://schemas.openxmlformats.org/drawingml/2006/main" prst="rect">
-            <a:avLst/>
-          </a:prstGeom>
-          <a:noFill xmlns:a="http://schemas.openxmlformats.org/drawingml/2006/main"/>
-          <a:ln xmlns:a="http://schemas.openxmlformats.org/drawingml/2006/main" w="0">
-            <a:noFill/>
-          </a:ln>
-        </p:spPr>
-        <p:txBody>
-          <a:bodyPr xmlns:a="http://schemas.openxmlformats.org/drawingml/2006/main" anchor="ctr">
-            <a:normAutofit fontScale="94444"/>
-          </a:bodyPr>
-          <a:lstStyle xmlns:a="http://schemas.openxmlformats.org/drawingml/2006/main"/>
-          <a:p xmlns:a="http://schemas.openxmlformats.org/drawingml/2006/main">
-            <a:pPr>
-              <a:defRPr sz="1350" b="1">
-                <a:solidFill>
-                  <a:srgbClr val="188A86"/>
-                </a:solidFill>
-                <a:latin typeface="Helvetica Neue"/>
-                <a:ea typeface="Helvetica Neue"/>
-                <a:cs typeface="Helvetica Neue"/>
-              </a:defRPr>
-            </a:pPr>
-            <a:r>
-              <a:rPr sz="1350" b="1">
-                <a:solidFill>
-                  <a:srgbClr val="188A86"/>
-                </a:solidFill>
-                <a:latin typeface="Helvetica Neue"/>
-                <a:ea typeface="Helvetica Neue"/>
-                <a:cs typeface="Helvetica Neue"/>
-              </a:rPr>
-              <a:t>ICEBREAKER  4/4</a:t>
-            </a:r>
-          </a:p>
-        </p:txBody>
-      </p:sp>
-      <p:sp>
-        <p:nvSpPr>
-          <p:cNvPr id="3" name="">
-            <a:extLst xmlns:a="http://schemas.openxmlformats.org/drawingml/2006/main">
-              <a:ext uri="{FF2B5EF4-FFF2-40B4-BE49-F238E27FC236}">
-                <a16:creationId xmlns:a16="http://schemas.microsoft.com/office/drawing/2014/main" id="{AB5B6A36-2079-4A8F-BF17-B70A82C6F3DD}"/>
-              </a:ext>
-            </a:extLst>
-          </p:cNvPr>
-          <p:cNvSpPr>
-            <a:spLocks xmlns:a="http://schemas.openxmlformats.org/drawingml/2006/main" noGrp="1"/>
-          </p:cNvSpPr>
-          <p:nvPr/>
-        </p:nvSpPr>
-        <p:spPr>
-          <a:xfrm xmlns:a="http://schemas.openxmlformats.org/drawingml/2006/main">
-            <a:off x="685800" y="666750"/>
-            <a:ext cx="10820400" cy="628650"/>
-          </a:xfrm>
-          <a:prstGeom xmlns:a="http://schemas.openxmlformats.org/drawingml/2006/main" prst="rect">
-            <a:avLst/>
-          </a:prstGeom>
-          <a:noFill xmlns:a="http://schemas.openxmlformats.org/drawingml/2006/main"/>
-          <a:ln xmlns:a="http://schemas.openxmlformats.org/drawingml/2006/main" w="0">
-            <a:noFill/>
-          </a:ln>
-        </p:spPr>
-        <p:txBody>
-          <a:bodyPr xmlns:a="http://schemas.openxmlformats.org/drawingml/2006/main" anchor="ctr">
-            <a:normAutofit fontScale="100000"/>
-          </a:bodyPr>
-          <a:lstStyle xmlns:a="http://schemas.openxmlformats.org/drawingml/2006/main"/>
-          <a:p xmlns:a="http://schemas.openxmlformats.org/drawingml/2006/main">
-            <a:pPr>
-              <a:defRPr sz="3150" b="1">
-                <a:solidFill>
-                  <a:srgbClr val="17324D"/>
-                </a:solidFill>
-                <a:latin typeface="Helvetica Neue"/>
-                <a:ea typeface="Helvetica Neue"/>
-                <a:cs typeface="Helvetica Neue"/>
-              </a:defRPr>
-            </a:pPr>
-            <a:r>
-              <a:rPr sz="3150" b="1">
-                <a:solidFill>
-                  <a:srgbClr val="17324D"/>
-                </a:solidFill>
-                <a:latin typeface="Helvetica Neue"/>
-                <a:ea typeface="Helvetica Neue"/>
-                <a:cs typeface="Helvetica Neue"/>
-              </a:rPr>
-              <a:t>Connection to business and marketing</a:t>
-            </a:r>
-          </a:p>
-        </p:txBody>
-      </p:sp>
-      <p:sp>
-        <p:nvSpPr>
-          <p:cNvPr id="4" name="">
-            <a:extLst xmlns:a="http://schemas.openxmlformats.org/drawingml/2006/main">
-              <a:ext uri="{FF2B5EF4-FFF2-40B4-BE49-F238E27FC236}">
-                <a16:creationId xmlns:a16="http://schemas.microsoft.com/office/drawing/2014/main" id="{FF146C32-61CE-4E5C-B83C-08C8ECA9568A}"/>
-              </a:ext>
-            </a:extLst>
-          </p:cNvPr>
-          <p:cNvSpPr>
-            <a:spLocks xmlns:a="http://schemas.openxmlformats.org/drawingml/2006/main" noGrp="1"/>
-          </p:cNvSpPr>
-          <p:nvPr/>
-        </p:nvSpPr>
-        <p:spPr>
-          <a:xfrm xmlns:a="http://schemas.openxmlformats.org/drawingml/2006/main">
-            <a:off x="685800" y="1257300"/>
-            <a:ext cx="10820400" cy="342900"/>
-          </a:xfrm>
-          <a:prstGeom xmlns:a="http://schemas.openxmlformats.org/drawingml/2006/main" prst="rect">
-            <a:avLst/>
-          </a:prstGeom>
-          <a:noFill xmlns:a="http://schemas.openxmlformats.org/drawingml/2006/main"/>
-          <a:ln xmlns:a="http://schemas.openxmlformats.org/drawingml/2006/main" w="0">
-            <a:noFill/>
-          </a:ln>
-        </p:spPr>
-        <p:txBody>
-          <a:bodyPr xmlns:a="http://schemas.openxmlformats.org/drawingml/2006/main" anchor="ctr">
-            <a:normAutofit fontScale="100000"/>
-          </a:bodyPr>
-          <a:lstStyle xmlns:a="http://schemas.openxmlformats.org/drawingml/2006/main"/>
-          <a:p xmlns:a="http://schemas.openxmlformats.org/drawingml/2006/main">
-            <a:pPr>
-              <a:defRPr sz="1575" b="0">
-                <a:solidFill>
-                  <a:srgbClr val="22313F"/>
-                </a:solidFill>
-                <a:latin typeface="Helvetica Neue"/>
-                <a:ea typeface="Helvetica Neue"/>
-                <a:cs typeface="Helvetica Neue"/>
-              </a:defRPr>
-            </a:pPr>
-            <a:r>
-              <a:rPr sz="1575" b="0">
-                <a:solidFill>
-                  <a:srgbClr val="22313F"/>
-                </a:solidFill>
-                <a:latin typeface="Helvetica Neue"/>
-                <a:ea typeface="Helvetica Neue"/>
-                <a:cs typeface="Helvetica Neue"/>
-              </a:rPr>
-              <a:t>Page 4 explains how businesses offer and market products.</a:t>
-            </a:r>
-          </a:p>
-        </p:txBody>
-      </p:sp>
-      <p:sp>
-        <p:nvSpPr>
-          <p:cNvPr id="5" name="">
-            <a:extLst xmlns:a="http://schemas.openxmlformats.org/drawingml/2006/main">
-              <a:ext uri="{FF2B5EF4-FFF2-40B4-BE49-F238E27FC236}">
-                <a16:creationId xmlns:a16="http://schemas.microsoft.com/office/drawing/2014/main" id="{26BE87A8-5863-4F62-A0B4-5D016A8E089C}"/>
-              </a:ext>
-            </a:extLst>
-          </p:cNvPr>
-          <p:cNvSpPr>
-            <a:spLocks xmlns:a="http://schemas.openxmlformats.org/drawingml/2006/main" noGrp="1"/>
-          </p:cNvSpPr>
-          <p:nvPr/>
-        </p:nvSpPr>
-        <p:spPr>
-          <a:xfrm xmlns:a="http://schemas.openxmlformats.org/drawingml/2006/main">
-            <a:off x="9601200" y="361950"/>
-            <a:ext cx="1905000" cy="361950"/>
-          </a:xfrm>
-          <a:prstGeom xmlns:a="http://schemas.openxmlformats.org/drawingml/2006/main" prst="roundRect">
-            <a:avLst>
-              <a:gd name="adj" fmla="val 47368"/>
-            </a:avLst>
-          </a:prstGeom>
-          <a:solidFill xmlns:a="http://schemas.openxmlformats.org/drawingml/2006/main">
-            <a:srgbClr val="17324D"/>
-          </a:solidFill>
-          <a:ln xmlns:a="http://schemas.openxmlformats.org/drawingml/2006/main" w="0">
-            <a:noFill/>
-          </a:ln>
-        </p:spPr>
-      </p:sp>
-      <p:sp>
-        <p:nvSpPr>
-          <p:cNvPr id="6" name="">
-            <a:extLst xmlns:a="http://schemas.openxmlformats.org/drawingml/2006/main">
-              <a:ext uri="{FF2B5EF4-FFF2-40B4-BE49-F238E27FC236}">
-                <a16:creationId xmlns:a16="http://schemas.microsoft.com/office/drawing/2014/main" id="{45E82CC4-E212-4BF6-B166-69A52F4179F0}"/>
-              </a:ext>
-            </a:extLst>
-          </p:cNvPr>
-          <p:cNvSpPr>
-            <a:spLocks xmlns:a="http://schemas.openxmlformats.org/drawingml/2006/main" noGrp="1"/>
-          </p:cNvSpPr>
-          <p:nvPr/>
-        </p:nvSpPr>
-        <p:spPr>
-          <a:xfrm xmlns:a="http://schemas.openxmlformats.org/drawingml/2006/main">
-            <a:off x="9753600" y="400050"/>
-            <a:ext cx="1600200" cy="266700"/>
-          </a:xfrm>
-          <a:prstGeom xmlns:a="http://schemas.openxmlformats.org/drawingml/2006/main" prst="rect">
-            <a:avLst/>
-          </a:prstGeom>
-          <a:noFill xmlns:a="http://schemas.openxmlformats.org/drawingml/2006/main"/>
-          <a:ln xmlns:a="http://schemas.openxmlformats.org/drawingml/2006/main" w="0">
-            <a:noFill/>
-          </a:ln>
-        </p:spPr>
-        <p:txBody>
-          <a:bodyPr xmlns:a="http://schemas.openxmlformats.org/drawingml/2006/main" anchor="ctr">
-            <a:normAutofit fontScale="95833"/>
-          </a:bodyPr>
-          <a:lstStyle xmlns:a="http://schemas.openxmlformats.org/drawingml/2006/main"/>
-          <a:p xmlns:a="http://schemas.openxmlformats.org/drawingml/2006/main">
-            <a:pPr>
-              <a:defRPr sz="1200" b="1">
-                <a:solidFill>
-                  <a:srgbClr val="FFFFFF"/>
-                </a:solidFill>
-                <a:latin typeface="Helvetica Neue"/>
-                <a:ea typeface="Helvetica Neue"/>
-                <a:cs typeface="Helvetica Neue"/>
-              </a:defRPr>
-            </a:pPr>
-            <a:r>
-              <a:rPr sz="1200" b="1">
-                <a:solidFill>
-                  <a:srgbClr val="FFFFFF"/>
-                </a:solidFill>
-                <a:latin typeface="Helvetica Neue"/>
-                <a:ea typeface="Helvetica Neue"/>
-                <a:cs typeface="Helvetica Neue"/>
-              </a:rPr>
-              <a:t>⏱  3 MIN MAX</a:t>
-            </a:r>
-          </a:p>
-        </p:txBody>
-      </p:sp>
-      <p:sp>
-        <p:nvSpPr>
-          <p:cNvPr id="7" name="">
-            <a:extLst xmlns:a="http://schemas.openxmlformats.org/drawingml/2006/main">
-              <a:ext uri="{FF2B5EF4-FFF2-40B4-BE49-F238E27FC236}">
-                <a16:creationId xmlns:a16="http://schemas.microsoft.com/office/drawing/2014/main" id="{21F716E1-E227-4988-B7B0-1E837D661C96}"/>
-              </a:ext>
-            </a:extLst>
-          </p:cNvPr>
-          <p:cNvSpPr>
-            <a:spLocks xmlns:a="http://schemas.openxmlformats.org/drawingml/2006/main" noGrp="1"/>
-          </p:cNvSpPr>
-          <p:nvPr/>
-        </p:nvSpPr>
-        <p:spPr>
-          <a:xfrm xmlns:a="http://schemas.openxmlformats.org/drawingml/2006/main">
-            <a:off x="10763250" y="6400800"/>
-            <a:ext cx="742950" cy="228600"/>
-          </a:xfrm>
-          <a:prstGeom xmlns:a="http://schemas.openxmlformats.org/drawingml/2006/main" prst="rect">
-            <a:avLst/>
-          </a:prstGeom>
-          <a:noFill xmlns:a="http://schemas.openxmlformats.org/drawingml/2006/main"/>
-          <a:ln xmlns:a="http://schemas.openxmlformats.org/drawingml/2006/main" w="0">
-            <a:noFill/>
-          </a:ln>
-        </p:spPr>
-        <p:txBody>
-          <a:bodyPr xmlns:a="http://schemas.openxmlformats.org/drawingml/2006/main" anchor="ctr">
-            <a:normAutofit fontScale="80000"/>
-          </a:bodyPr>
-          <a:lstStyle xmlns:a="http://schemas.openxmlformats.org/drawingml/2006/main"/>
-          <a:p xmlns:a="http://schemas.openxmlformats.org/drawingml/2006/main">
-            <a:pPr>
-              <a:defRPr sz="1125" b="1">
-                <a:solidFill>
-                  <a:srgbClr val="188A86"/>
-                </a:solidFill>
-                <a:latin typeface="Helvetica Neue"/>
-                <a:ea typeface="Helvetica Neue"/>
-                <a:cs typeface="Helvetica Neue"/>
-              </a:defRPr>
-            </a:pPr>
-            <a:r>
-              <a:rPr sz="1125" b="1">
-                <a:solidFill>
-                  <a:srgbClr val="188A86"/>
-                </a:solidFill>
-                <a:latin typeface="Helvetica Neue"/>
-                <a:ea typeface="Helvetica Neue"/>
-                <a:cs typeface="Helvetica Neue"/>
-              </a:rPr>
-              <a:t>4/4</a:t>
-            </a:r>
-          </a:p>
-        </p:txBody>
-      </p:sp>
-      <p:sp>
-        <p:nvSpPr>
-          <p:cNvPr id="8" name="">
-            <a:extLst xmlns:a="http://schemas.openxmlformats.org/drawingml/2006/main">
-              <a:ext uri="{FF2B5EF4-FFF2-40B4-BE49-F238E27FC236}">
-                <a16:creationId xmlns:a16="http://schemas.microsoft.com/office/drawing/2014/main" id="{2FD952B5-E235-459F-8276-19C04C469766}"/>
-              </a:ext>
-            </a:extLst>
-          </p:cNvPr>
-          <p:cNvSpPr>
-            <a:spLocks xmlns:a="http://schemas.openxmlformats.org/drawingml/2006/main" noGrp="1"/>
-          </p:cNvSpPr>
-          <p:nvPr/>
-        </p:nvSpPr>
-        <p:spPr>
-          <a:xfrm xmlns:a="http://schemas.openxmlformats.org/drawingml/2006/main">
-            <a:off x="685800" y="1752600"/>
-            <a:ext cx="10820400" cy="857250"/>
-          </a:xfrm>
-          <a:prstGeom xmlns:a="http://schemas.openxmlformats.org/drawingml/2006/main" prst="roundRect">
-            <a:avLst>
-              <a:gd name="adj" fmla="val 20000"/>
-            </a:avLst>
-          </a:prstGeom>
-          <a:solidFill xmlns:a="http://schemas.openxmlformats.org/drawingml/2006/main">
-            <a:srgbClr val="DDEEDB"/>
-          </a:solidFill>
-          <a:ln xmlns:a="http://schemas.openxmlformats.org/drawingml/2006/main" w="0">
-            <a:noFill/>
-          </a:ln>
-        </p:spPr>
-      </p:sp>
-      <p:sp>
-        <p:nvSpPr>
-          <p:cNvPr id="9" name="">
-            <a:extLst xmlns:a="http://schemas.openxmlformats.org/drawingml/2006/main">
-              <a:ext uri="{FF2B5EF4-FFF2-40B4-BE49-F238E27FC236}">
-                <a16:creationId xmlns:a16="http://schemas.microsoft.com/office/drawing/2014/main" id="{DAD80966-B316-426A-9F4A-8A56E3601380}"/>
-              </a:ext>
-            </a:extLst>
-          </p:cNvPr>
-          <p:cNvSpPr>
-            <a:spLocks xmlns:a="http://schemas.openxmlformats.org/drawingml/2006/main" noGrp="1"/>
-          </p:cNvSpPr>
-          <p:nvPr/>
-        </p:nvSpPr>
-        <p:spPr>
-          <a:xfrm xmlns:a="http://schemas.openxmlformats.org/drawingml/2006/main">
-            <a:off x="857250" y="1866900"/>
-            <a:ext cx="514350" cy="419100"/>
-          </a:xfrm>
-          <a:prstGeom xmlns:a="http://schemas.openxmlformats.org/drawingml/2006/main" prst="rect">
-            <a:avLst/>
-          </a:prstGeom>
-          <a:noFill xmlns:a="http://schemas.openxmlformats.org/drawingml/2006/main"/>
-          <a:ln xmlns:a="http://schemas.openxmlformats.org/drawingml/2006/main" w="0">
-            <a:noFill/>
-          </a:ln>
-        </p:spPr>
-        <p:txBody>
-          <a:bodyPr xmlns:a="http://schemas.openxmlformats.org/drawingml/2006/main" anchor="ctr">
-            <a:normAutofit fontScale="100000"/>
-          </a:bodyPr>
-          <a:lstStyle xmlns:a="http://schemas.openxmlformats.org/drawingml/2006/main"/>
-          <a:p xmlns:a="http://schemas.openxmlformats.org/drawingml/2006/main">
-            <a:pPr>
-              <a:defRPr sz="1800" b="1">
-                <a:solidFill>
-                  <a:srgbClr val="188A86"/>
-                </a:solidFill>
-                <a:latin typeface="Helvetica Neue"/>
-                <a:ea typeface="Helvetica Neue"/>
-                <a:cs typeface="Helvetica Neue"/>
-              </a:defRPr>
-            </a:pPr>
-            <a:r>
-              <a:rPr sz="1800" b="1">
-                <a:solidFill>
-                  <a:srgbClr val="188A86"/>
-                </a:solidFill>
-                <a:latin typeface="Helvetica Neue"/>
-                <a:ea typeface="Helvetica Neue"/>
-                <a:cs typeface="Helvetica Neue"/>
-              </a:rPr>
-              <a:t>B</a:t>
-            </a:r>
-          </a:p>
-        </p:txBody>
-      </p:sp>
-      <p:sp>
-        <p:nvSpPr>
-          <p:cNvPr id="10" name="">
-            <a:extLst xmlns:a="http://schemas.openxmlformats.org/drawingml/2006/main">
-              <a:ext uri="{FF2B5EF4-FFF2-40B4-BE49-F238E27FC236}">
-                <a16:creationId xmlns:a16="http://schemas.microsoft.com/office/drawing/2014/main" id="{28CB8FB7-4FAA-4DEE-ADF5-CB96C29A852C}"/>
-              </a:ext>
-            </a:extLst>
-          </p:cNvPr>
-          <p:cNvSpPr>
-            <a:spLocks xmlns:a="http://schemas.openxmlformats.org/drawingml/2006/main" noGrp="1"/>
-          </p:cNvSpPr>
-          <p:nvPr/>
-        </p:nvSpPr>
-        <p:spPr>
-          <a:xfrm xmlns:a="http://schemas.openxmlformats.org/drawingml/2006/main">
-            <a:off x="1466850" y="1828800"/>
-            <a:ext cx="9867900" cy="457200"/>
-          </a:xfrm>
-          <a:prstGeom xmlns:a="http://schemas.openxmlformats.org/drawingml/2006/main" prst="rect">
-            <a:avLst/>
-          </a:prstGeom>
-          <a:noFill xmlns:a="http://schemas.openxmlformats.org/drawingml/2006/main"/>
-          <a:ln xmlns:a="http://schemas.openxmlformats.org/drawingml/2006/main" w="0">
-            <a:noFill/>
-          </a:ln>
-        </p:spPr>
-        <p:txBody>
-          <a:bodyPr xmlns:a="http://schemas.openxmlformats.org/drawingml/2006/main" anchor="ctr">
-            <a:normAutofit fontScale="100000"/>
-          </a:bodyPr>
-          <a:lstStyle xmlns:a="http://schemas.openxmlformats.org/drawingml/2006/main"/>
-          <a:p xmlns:a="http://schemas.openxmlformats.org/drawingml/2006/main">
-            <a:pPr>
-              <a:defRPr sz="1800" b="1">
-                <a:solidFill>
-                  <a:srgbClr val="17324D"/>
-                </a:solidFill>
-                <a:latin typeface="Helvetica Neue"/>
-                <a:ea typeface="Helvetica Neue"/>
-                <a:cs typeface="Helvetica Neue"/>
-              </a:defRPr>
-            </a:pPr>
-            <a:r>
-              <a:rPr sz="1800" b="1">
-                <a:solidFill>
-                  <a:srgbClr val="17324D"/>
-                </a:solidFill>
-                <a:latin typeface="Helvetica Neue"/>
-                <a:ea typeface="Helvetica Neue"/>
-                <a:cs typeface="Helvetica Neue"/>
-              </a:rPr>
-              <a:t>BUSINESS</a:t>
-            </a:r>
-          </a:p>
-        </p:txBody>
-      </p:sp>
-      <p:sp>
-        <p:nvSpPr>
-          <p:cNvPr id="11" name="">
-            <a:extLst xmlns:a="http://schemas.openxmlformats.org/drawingml/2006/main">
-              <a:ext uri="{FF2B5EF4-FFF2-40B4-BE49-F238E27FC236}">
-                <a16:creationId xmlns:a16="http://schemas.microsoft.com/office/drawing/2014/main" id="{EB3DF6BE-1146-49D8-881E-B574D5512177}"/>
-              </a:ext>
-            </a:extLst>
-          </p:cNvPr>
-          <p:cNvSpPr>
-            <a:spLocks xmlns:a="http://schemas.openxmlformats.org/drawingml/2006/main" noGrp="1"/>
-          </p:cNvSpPr>
-          <p:nvPr/>
-        </p:nvSpPr>
-        <p:spPr>
-          <a:xfrm xmlns:a="http://schemas.openxmlformats.org/drawingml/2006/main">
-            <a:off x="1466850" y="2247900"/>
-            <a:ext cx="9867900" cy="266700"/>
-          </a:xfrm>
-          <a:prstGeom xmlns:a="http://schemas.openxmlformats.org/drawingml/2006/main" prst="rect">
-            <a:avLst/>
-          </a:prstGeom>
-          <a:noFill xmlns:a="http://schemas.openxmlformats.org/drawingml/2006/main"/>
-          <a:ln xmlns:a="http://schemas.openxmlformats.org/drawingml/2006/main" w="0">
-            <a:noFill/>
-          </a:ln>
-        </p:spPr>
-        <p:txBody>
-          <a:bodyPr xmlns:a="http://schemas.openxmlformats.org/drawingml/2006/main" anchor="ctr">
-            <a:normAutofit fontScale="85185"/>
-          </a:bodyPr>
-          <a:lstStyle xmlns:a="http://schemas.openxmlformats.org/drawingml/2006/main"/>
-          <a:p xmlns:a="http://schemas.openxmlformats.org/drawingml/2006/main">
-            <a:pPr>
-              <a:defRPr sz="1350" b="0">
-                <a:solidFill>
-                  <a:srgbClr val="22313F"/>
-                </a:solidFill>
-                <a:latin typeface="Helvetica Neue"/>
-                <a:ea typeface="Helvetica Neue"/>
-                <a:cs typeface="Helvetica Neue"/>
-              </a:defRPr>
-            </a:pPr>
-            <a:r>
-              <a:rPr sz="1350" b="0">
-                <a:solidFill>
-                  <a:srgbClr val="22313F"/>
-                </a:solidFill>
-                <a:latin typeface="Helvetica Neue"/>
-                <a:ea typeface="Helvetica Neue"/>
-                <a:cs typeface="Helvetica Neue"/>
-              </a:rPr>
-              <a:t>Makes, sells, or provides products in exchange for money</a:t>
-            </a:r>
-          </a:p>
-        </p:txBody>
-      </p:sp>
-      <p:sp>
-        <p:nvSpPr>
-          <p:cNvPr id="12" name="">
-            <a:extLst xmlns:a="http://schemas.openxmlformats.org/drawingml/2006/main">
-              <a:ext uri="{FF2B5EF4-FFF2-40B4-BE49-F238E27FC236}">
-                <a16:creationId xmlns:a16="http://schemas.microsoft.com/office/drawing/2014/main" id="{E3999E8D-CCD4-4199-9D1C-A262CA08D8E0}"/>
-              </a:ext>
-            </a:extLst>
-          </p:cNvPr>
-          <p:cNvSpPr>
-            <a:spLocks xmlns:a="http://schemas.openxmlformats.org/drawingml/2006/main" noGrp="1"/>
-          </p:cNvSpPr>
-          <p:nvPr/>
-        </p:nvSpPr>
-        <p:spPr>
-          <a:xfrm xmlns:a="http://schemas.openxmlformats.org/drawingml/2006/main">
-            <a:off x="685800" y="2800350"/>
-            <a:ext cx="10820400" cy="857250"/>
-          </a:xfrm>
-          <a:prstGeom xmlns:a="http://schemas.openxmlformats.org/drawingml/2006/main" prst="roundRect">
-            <a:avLst>
-              <a:gd name="adj" fmla="val 20000"/>
-            </a:avLst>
-          </a:prstGeom>
-          <a:solidFill xmlns:a="http://schemas.openxmlformats.org/drawingml/2006/main">
-            <a:srgbClr val="DCEEF4"/>
-          </a:solidFill>
-          <a:ln xmlns:a="http://schemas.openxmlformats.org/drawingml/2006/main" w="0">
-            <a:noFill/>
-          </a:ln>
-        </p:spPr>
-      </p:sp>
-      <p:sp>
-        <p:nvSpPr>
-          <p:cNvPr id="13" name="">
-            <a:extLst xmlns:a="http://schemas.openxmlformats.org/drawingml/2006/main">
-              <a:ext uri="{FF2B5EF4-FFF2-40B4-BE49-F238E27FC236}">
-                <a16:creationId xmlns:a16="http://schemas.microsoft.com/office/drawing/2014/main" id="{4FD1A511-A824-4276-97C3-49F680D1E862}"/>
-              </a:ext>
-            </a:extLst>
-          </p:cNvPr>
-          <p:cNvSpPr>
-            <a:spLocks xmlns:a="http://schemas.openxmlformats.org/drawingml/2006/main" noGrp="1"/>
-          </p:cNvSpPr>
-          <p:nvPr/>
-        </p:nvSpPr>
-        <p:spPr>
-          <a:xfrm xmlns:a="http://schemas.openxmlformats.org/drawingml/2006/main">
-            <a:off x="857250" y="2914650"/>
-            <a:ext cx="514350" cy="419100"/>
-          </a:xfrm>
-          <a:prstGeom xmlns:a="http://schemas.openxmlformats.org/drawingml/2006/main" prst="rect">
-            <a:avLst/>
-          </a:prstGeom>
-          <a:noFill xmlns:a="http://schemas.openxmlformats.org/drawingml/2006/main"/>
-          <a:ln xmlns:a="http://schemas.openxmlformats.org/drawingml/2006/main" w="0">
-            <a:noFill/>
-          </a:ln>
-        </p:spPr>
-        <p:txBody>
-          <a:bodyPr xmlns:a="http://schemas.openxmlformats.org/drawingml/2006/main" anchor="ctr">
-            <a:normAutofit fontScale="100000"/>
-          </a:bodyPr>
-          <a:lstStyle xmlns:a="http://schemas.openxmlformats.org/drawingml/2006/main"/>
-          <a:p xmlns:a="http://schemas.openxmlformats.org/drawingml/2006/main">
-            <a:pPr>
-              <a:defRPr sz="1800" b="1">
-                <a:solidFill>
-                  <a:srgbClr val="188A86"/>
-                </a:solidFill>
-                <a:latin typeface="Helvetica Neue"/>
-                <a:ea typeface="Helvetica Neue"/>
-                <a:cs typeface="Helvetica Neue"/>
-              </a:defRPr>
-            </a:pPr>
-            <a:r>
-              <a:rPr sz="1800" b="1">
-                <a:solidFill>
-                  <a:srgbClr val="188A86"/>
-                </a:solidFill>
-                <a:latin typeface="Helvetica Neue"/>
-                <a:ea typeface="Helvetica Neue"/>
-                <a:cs typeface="Helvetica Neue"/>
-              </a:rPr>
-              <a:t>M</a:t>
-            </a:r>
-          </a:p>
-        </p:txBody>
-      </p:sp>
-      <p:sp>
-        <p:nvSpPr>
-          <p:cNvPr id="14" name="">
-            <a:extLst xmlns:a="http://schemas.openxmlformats.org/drawingml/2006/main">
-              <a:ext uri="{FF2B5EF4-FFF2-40B4-BE49-F238E27FC236}">
-                <a16:creationId xmlns:a16="http://schemas.microsoft.com/office/drawing/2014/main" id="{8894C891-12D3-45A1-B3F4-5E534EA354F2}"/>
-              </a:ext>
-            </a:extLst>
-          </p:cNvPr>
-          <p:cNvSpPr>
-            <a:spLocks xmlns:a="http://schemas.openxmlformats.org/drawingml/2006/main" noGrp="1"/>
-          </p:cNvSpPr>
-          <p:nvPr/>
-        </p:nvSpPr>
-        <p:spPr>
-          <a:xfrm xmlns:a="http://schemas.openxmlformats.org/drawingml/2006/main">
-            <a:off x="1466850" y="2876550"/>
-            <a:ext cx="9867900" cy="457200"/>
-          </a:xfrm>
-          <a:prstGeom xmlns:a="http://schemas.openxmlformats.org/drawingml/2006/main" prst="rect">
-            <a:avLst/>
-          </a:prstGeom>
-          <a:noFill xmlns:a="http://schemas.openxmlformats.org/drawingml/2006/main"/>
-          <a:ln xmlns:a="http://schemas.openxmlformats.org/drawingml/2006/main" w="0">
-            <a:noFill/>
-          </a:ln>
-        </p:spPr>
-        <p:txBody>
-          <a:bodyPr xmlns:a="http://schemas.openxmlformats.org/drawingml/2006/main" anchor="ctr">
-            <a:normAutofit fontScale="100000"/>
-          </a:bodyPr>
-          <a:lstStyle xmlns:a="http://schemas.openxmlformats.org/drawingml/2006/main"/>
-          <a:p xmlns:a="http://schemas.openxmlformats.org/drawingml/2006/main">
-            <a:pPr>
-              <a:defRPr sz="1800" b="1">
-                <a:solidFill>
-                  <a:srgbClr val="17324D"/>
-                </a:solidFill>
-                <a:latin typeface="Helvetica Neue"/>
-                <a:ea typeface="Helvetica Neue"/>
-                <a:cs typeface="Helvetica Neue"/>
-              </a:defRPr>
-            </a:pPr>
-            <a:r>
-              <a:rPr sz="1800" b="1">
-                <a:solidFill>
-                  <a:srgbClr val="17324D"/>
-                </a:solidFill>
-                <a:latin typeface="Helvetica Neue"/>
-                <a:ea typeface="Helvetica Neue"/>
-                <a:cs typeface="Helvetica Neue"/>
-              </a:rPr>
-              <a:t>MARKETING</a:t>
-            </a:r>
-          </a:p>
-        </p:txBody>
-      </p:sp>
-      <p:sp>
-        <p:nvSpPr>
-          <p:cNvPr id="15" name="">
-            <a:extLst xmlns:a="http://schemas.openxmlformats.org/drawingml/2006/main">
-              <a:ext uri="{FF2B5EF4-FFF2-40B4-BE49-F238E27FC236}">
-                <a16:creationId xmlns:a16="http://schemas.microsoft.com/office/drawing/2014/main" id="{DE66F23B-2E54-45DD-B66E-C36CF9EAC95E}"/>
-              </a:ext>
-            </a:extLst>
-          </p:cNvPr>
-          <p:cNvSpPr>
-            <a:spLocks xmlns:a="http://schemas.openxmlformats.org/drawingml/2006/main" noGrp="1"/>
-          </p:cNvSpPr>
-          <p:nvPr/>
-        </p:nvSpPr>
-        <p:spPr>
-          <a:xfrm xmlns:a="http://schemas.openxmlformats.org/drawingml/2006/main">
-            <a:off x="1466850" y="3295650"/>
-            <a:ext cx="9867900" cy="266700"/>
-          </a:xfrm>
-          <a:prstGeom xmlns:a="http://schemas.openxmlformats.org/drawingml/2006/main" prst="rect">
-            <a:avLst/>
-          </a:prstGeom>
-          <a:noFill xmlns:a="http://schemas.openxmlformats.org/drawingml/2006/main"/>
-          <a:ln xmlns:a="http://schemas.openxmlformats.org/drawingml/2006/main" w="0">
-            <a:noFill/>
-          </a:ln>
-        </p:spPr>
-        <p:txBody>
-          <a:bodyPr xmlns:a="http://schemas.openxmlformats.org/drawingml/2006/main" anchor="ctr">
-            <a:normAutofit fontScale="85185"/>
-          </a:bodyPr>
-          <a:lstStyle xmlns:a="http://schemas.openxmlformats.org/drawingml/2006/main"/>
-          <a:p xmlns:a="http://schemas.openxmlformats.org/drawingml/2006/main">
-            <a:pPr>
-              <a:defRPr sz="1350" b="0">
-                <a:solidFill>
-                  <a:srgbClr val="22313F"/>
-                </a:solidFill>
-                <a:latin typeface="Helvetica Neue"/>
-                <a:ea typeface="Helvetica Neue"/>
-                <a:cs typeface="Helvetica Neue"/>
-              </a:defRPr>
-            </a:pPr>
-            <a:r>
-              <a:rPr sz="1350" b="0">
-                <a:solidFill>
-                  <a:srgbClr val="22313F"/>
-                </a:solidFill>
-                <a:latin typeface="Helvetica Neue"/>
-                <a:ea typeface="Helvetica Neue"/>
-                <a:cs typeface="Helvetica Neue"/>
-              </a:rPr>
-              <a:t>Promotes, sells, and distributes a product or service</a:t>
-            </a:r>
-          </a:p>
-        </p:txBody>
-      </p:sp>
-      <p:sp>
-        <p:nvSpPr>
-          <p:cNvPr id="16" name="">
-            <a:extLst xmlns:a="http://schemas.openxmlformats.org/drawingml/2006/main">
-              <a:ext uri="{FF2B5EF4-FFF2-40B4-BE49-F238E27FC236}">
-                <a16:creationId xmlns:a16="http://schemas.microsoft.com/office/drawing/2014/main" id="{B712951A-1031-4483-93D8-3E963AE83D2B}"/>
-              </a:ext>
-            </a:extLst>
-          </p:cNvPr>
-          <p:cNvSpPr>
-            <a:spLocks xmlns:a="http://schemas.openxmlformats.org/drawingml/2006/main" noGrp="1"/>
-          </p:cNvSpPr>
-          <p:nvPr/>
-        </p:nvSpPr>
-        <p:spPr>
-          <a:xfrm xmlns:a="http://schemas.openxmlformats.org/drawingml/2006/main">
-            <a:off x="685800" y="3848100"/>
-            <a:ext cx="10820400" cy="857250"/>
-          </a:xfrm>
-          <a:prstGeom xmlns:a="http://schemas.openxmlformats.org/drawingml/2006/main" prst="roundRect">
-            <a:avLst>
-              <a:gd name="adj" fmla="val 20000"/>
-            </a:avLst>
-          </a:prstGeom>
-          <a:solidFill xmlns:a="http://schemas.openxmlformats.org/drawingml/2006/main">
-            <a:srgbClr val="F8E2A8"/>
-          </a:solidFill>
-          <a:ln xmlns:a="http://schemas.openxmlformats.org/drawingml/2006/main" w="0">
-            <a:noFill/>
-          </a:ln>
-        </p:spPr>
-      </p:sp>
-      <p:sp>
-        <p:nvSpPr>
-          <p:cNvPr id="17" name="">
-            <a:extLst xmlns:a="http://schemas.openxmlformats.org/drawingml/2006/main">
-              <a:ext uri="{FF2B5EF4-FFF2-40B4-BE49-F238E27FC236}">
-                <a16:creationId xmlns:a16="http://schemas.microsoft.com/office/drawing/2014/main" id="{CB4E42B6-3939-4FC5-8F69-DF7E88C6FDBB}"/>
-              </a:ext>
-            </a:extLst>
-          </p:cNvPr>
-          <p:cNvSpPr>
-            <a:spLocks xmlns:a="http://schemas.openxmlformats.org/drawingml/2006/main" noGrp="1"/>
-          </p:cNvSpPr>
-          <p:nvPr/>
-        </p:nvSpPr>
-        <p:spPr>
-          <a:xfrm xmlns:a="http://schemas.openxmlformats.org/drawingml/2006/main">
-            <a:off x="857250" y="3962400"/>
-            <a:ext cx="514350" cy="419100"/>
-          </a:xfrm>
-          <a:prstGeom xmlns:a="http://schemas.openxmlformats.org/drawingml/2006/main" prst="rect">
-            <a:avLst/>
-          </a:prstGeom>
-          <a:noFill xmlns:a="http://schemas.openxmlformats.org/drawingml/2006/main"/>
-          <a:ln xmlns:a="http://schemas.openxmlformats.org/drawingml/2006/main" w="0">
-            <a:noFill/>
-          </a:ln>
-        </p:spPr>
-        <p:txBody>
-          <a:bodyPr xmlns:a="http://schemas.openxmlformats.org/drawingml/2006/main" anchor="ctr">
-            <a:normAutofit fontScale="100000"/>
-          </a:bodyPr>
-          <a:lstStyle xmlns:a="http://schemas.openxmlformats.org/drawingml/2006/main"/>
-          <a:p xmlns:a="http://schemas.openxmlformats.org/drawingml/2006/main">
-            <a:pPr>
-              <a:defRPr sz="1800" b="1">
-                <a:solidFill>
-                  <a:srgbClr val="188A86"/>
-                </a:solidFill>
-                <a:latin typeface="Helvetica Neue"/>
-                <a:ea typeface="Helvetica Neue"/>
-                <a:cs typeface="Helvetica Neue"/>
-              </a:defRPr>
-            </a:pPr>
-            <a:r>
-              <a:rPr sz="1800" b="1">
-                <a:solidFill>
-                  <a:srgbClr val="188A86"/>
-                </a:solidFill>
-                <a:latin typeface="Helvetica Neue"/>
-                <a:ea typeface="Helvetica Neue"/>
-                <a:cs typeface="Helvetica Neue"/>
-              </a:rPr>
-              <a:t>P</a:t>
-            </a:r>
-          </a:p>
-        </p:txBody>
-      </p:sp>
-      <p:sp>
-        <p:nvSpPr>
-          <p:cNvPr id="18" name="">
-            <a:extLst xmlns:a="http://schemas.openxmlformats.org/drawingml/2006/main">
-              <a:ext uri="{FF2B5EF4-FFF2-40B4-BE49-F238E27FC236}">
-                <a16:creationId xmlns:a16="http://schemas.microsoft.com/office/drawing/2014/main" id="{1550986A-FB48-436C-80CD-DB7A9F484837}"/>
-              </a:ext>
-            </a:extLst>
-          </p:cNvPr>
-          <p:cNvSpPr>
-            <a:spLocks xmlns:a="http://schemas.openxmlformats.org/drawingml/2006/main" noGrp="1"/>
-          </p:cNvSpPr>
-          <p:nvPr/>
-        </p:nvSpPr>
-        <p:spPr>
-          <a:xfrm xmlns:a="http://schemas.openxmlformats.org/drawingml/2006/main">
-            <a:off x="1466850" y="3924300"/>
-            <a:ext cx="9867900" cy="457200"/>
-          </a:xfrm>
-          <a:prstGeom xmlns:a="http://schemas.openxmlformats.org/drawingml/2006/main" prst="rect">
-            <a:avLst/>
-          </a:prstGeom>
-          <a:noFill xmlns:a="http://schemas.openxmlformats.org/drawingml/2006/main"/>
-          <a:ln xmlns:a="http://schemas.openxmlformats.org/drawingml/2006/main" w="0">
-            <a:noFill/>
-          </a:ln>
-        </p:spPr>
-        <p:txBody>
-          <a:bodyPr xmlns:a="http://schemas.openxmlformats.org/drawingml/2006/main" anchor="ctr">
-            <a:normAutofit fontScale="100000"/>
-          </a:bodyPr>
-          <a:lstStyle xmlns:a="http://schemas.openxmlformats.org/drawingml/2006/main"/>
-          <a:p xmlns:a="http://schemas.openxmlformats.org/drawingml/2006/main">
-            <a:pPr>
-              <a:defRPr sz="1800" b="1">
-                <a:solidFill>
-                  <a:srgbClr val="17324D"/>
-                </a:solidFill>
-                <a:latin typeface="Helvetica Neue"/>
-                <a:ea typeface="Helvetica Neue"/>
-                <a:cs typeface="Helvetica Neue"/>
-              </a:defRPr>
-            </a:pPr>
-            <a:r>
-              <a:rPr sz="1800" b="1">
-                <a:solidFill>
-                  <a:srgbClr val="17324D"/>
-                </a:solidFill>
-                <a:latin typeface="Helvetica Neue"/>
-                <a:ea typeface="Helvetica Neue"/>
-                <a:cs typeface="Helvetica Neue"/>
-              </a:rPr>
-              <a:t>PRODUCT</a:t>
-            </a:r>
-          </a:p>
-        </p:txBody>
-      </p:sp>
-      <p:sp>
-        <p:nvSpPr>
-          <p:cNvPr id="19" name="">
-            <a:extLst xmlns:a="http://schemas.openxmlformats.org/drawingml/2006/main">
-              <a:ext uri="{FF2B5EF4-FFF2-40B4-BE49-F238E27FC236}">
-                <a16:creationId xmlns:a16="http://schemas.microsoft.com/office/drawing/2014/main" id="{77C2586A-46F6-4676-BE06-9E80D279A69B}"/>
-              </a:ext>
-            </a:extLst>
-          </p:cNvPr>
-          <p:cNvSpPr>
-            <a:spLocks xmlns:a="http://schemas.openxmlformats.org/drawingml/2006/main" noGrp="1"/>
-          </p:cNvSpPr>
-          <p:nvPr/>
-        </p:nvSpPr>
-        <p:spPr>
-          <a:xfrm xmlns:a="http://schemas.openxmlformats.org/drawingml/2006/main">
-            <a:off x="1466850" y="4343400"/>
-            <a:ext cx="9867900" cy="266700"/>
-          </a:xfrm>
-          <a:prstGeom xmlns:a="http://schemas.openxmlformats.org/drawingml/2006/main" prst="rect">
-            <a:avLst/>
-          </a:prstGeom>
-          <a:noFill xmlns:a="http://schemas.openxmlformats.org/drawingml/2006/main"/>
-          <a:ln xmlns:a="http://schemas.openxmlformats.org/drawingml/2006/main" w="0">
-            <a:noFill/>
-          </a:ln>
-        </p:spPr>
-        <p:txBody>
-          <a:bodyPr xmlns:a="http://schemas.openxmlformats.org/drawingml/2006/main" anchor="ctr">
-            <a:normAutofit fontScale="85185"/>
-          </a:bodyPr>
-          <a:lstStyle xmlns:a="http://schemas.openxmlformats.org/drawingml/2006/main"/>
-          <a:p xmlns:a="http://schemas.openxmlformats.org/drawingml/2006/main">
-            <a:pPr>
-              <a:defRPr sz="1350" b="0">
-                <a:solidFill>
-                  <a:srgbClr val="22313F"/>
-                </a:solidFill>
-                <a:latin typeface="Helvetica Neue"/>
-                <a:ea typeface="Helvetica Neue"/>
-                <a:cs typeface="Helvetica Neue"/>
-              </a:defRPr>
-            </a:pPr>
-            <a:r>
-              <a:rPr sz="1350" b="0">
-                <a:solidFill>
-                  <a:srgbClr val="22313F"/>
-                </a:solidFill>
-                <a:latin typeface="Helvetica Neue"/>
-                <a:ea typeface="Helvetica Neue"/>
-                <a:cs typeface="Helvetica Neue"/>
-              </a:rPr>
-              <a:t>Anything that can be bought or sold, including goods and services</a:t>
-            </a:r>
-          </a:p>
-        </p:txBody>
-      </p:sp>
-      <p:sp>
-        <p:nvSpPr>
-          <p:cNvPr id="20" name="">
-            <a:extLst xmlns:a="http://schemas.openxmlformats.org/drawingml/2006/main">
-              <a:ext uri="{FF2B5EF4-FFF2-40B4-BE49-F238E27FC236}">
-                <a16:creationId xmlns:a16="http://schemas.microsoft.com/office/drawing/2014/main" id="{B46D6A6A-C547-47B7-A131-C1F74396DE12}"/>
-              </a:ext>
-            </a:extLst>
-          </p:cNvPr>
-          <p:cNvSpPr>
-            <a:spLocks xmlns:a="http://schemas.openxmlformats.org/drawingml/2006/main" noGrp="1"/>
-          </p:cNvSpPr>
-          <p:nvPr/>
-        </p:nvSpPr>
-        <p:spPr>
-          <a:xfrm xmlns:a="http://schemas.openxmlformats.org/drawingml/2006/main">
-            <a:off x="685800" y="5029200"/>
-            <a:ext cx="10820400" cy="1104900"/>
-          </a:xfrm>
-          <a:prstGeom xmlns:a="http://schemas.openxmlformats.org/drawingml/2006/main" prst="roundRect">
-            <a:avLst>
-              <a:gd name="adj" fmla="val 15517"/>
-            </a:avLst>
-          </a:prstGeom>
-          <a:solidFill xmlns:a="http://schemas.openxmlformats.org/drawingml/2006/main">
-            <a:srgbClr val="17324D"/>
-          </a:solidFill>
-          <a:ln xmlns:a="http://schemas.openxmlformats.org/drawingml/2006/main" w="0">
-            <a:noFill/>
-          </a:ln>
-        </p:spPr>
-      </p:sp>
-      <p:sp>
-        <p:nvSpPr>
-          <p:cNvPr id="21" name="">
-            <a:extLst xmlns:a="http://schemas.openxmlformats.org/drawingml/2006/main">
-              <a:ext uri="{FF2B5EF4-FFF2-40B4-BE49-F238E27FC236}">
-                <a16:creationId xmlns:a16="http://schemas.microsoft.com/office/drawing/2014/main" id="{2B08615C-B493-43F3-928E-6BC71E099D5E}"/>
-              </a:ext>
-            </a:extLst>
-          </p:cNvPr>
-          <p:cNvSpPr>
-            <a:spLocks xmlns:a="http://schemas.openxmlformats.org/drawingml/2006/main" noGrp="1"/>
-          </p:cNvSpPr>
-          <p:nvPr/>
-        </p:nvSpPr>
-        <p:spPr>
-          <a:xfrm xmlns:a="http://schemas.openxmlformats.org/drawingml/2006/main">
-            <a:off x="914400" y="5143500"/>
-            <a:ext cx="10363200" cy="514350"/>
-          </a:xfrm>
-          <a:prstGeom xmlns:a="http://schemas.openxmlformats.org/drawingml/2006/main" prst="rect">
-            <a:avLst/>
-          </a:prstGeom>
-          <a:noFill xmlns:a="http://schemas.openxmlformats.org/drawingml/2006/main"/>
-          <a:ln xmlns:a="http://schemas.openxmlformats.org/drawingml/2006/main" w="0">
-            <a:noFill/>
-          </a:ln>
-        </p:spPr>
-        <p:txBody>
-          <a:bodyPr xmlns:a="http://schemas.openxmlformats.org/drawingml/2006/main" anchor="ctr">
-            <a:normAutofit fontScale="100000"/>
-          </a:bodyPr>
-          <a:lstStyle xmlns:a="http://schemas.openxmlformats.org/drawingml/2006/main"/>
-          <a:p xmlns:a="http://schemas.openxmlformats.org/drawingml/2006/main">
-            <a:pPr>
-              <a:defRPr sz="1650" b="1">
-                <a:solidFill>
-                  <a:srgbClr val="FFFFFF"/>
-                </a:solidFill>
-                <a:latin typeface="Helvetica Neue"/>
-                <a:ea typeface="Helvetica Neue"/>
-                <a:cs typeface="Helvetica Neue"/>
-              </a:defRPr>
-            </a:pPr>
-            <a:r>
-              <a:rPr sz="1650" b="1">
-                <a:solidFill>
-                  <a:srgbClr val="FFFFFF"/>
-                </a:solidFill>
-                <a:latin typeface="Helvetica Neue"/>
-                <a:ea typeface="Helvetica Neue"/>
-                <a:cs typeface="Helvetica Neue"/>
-              </a:rPr>
-              <a:t>Goods, services, and ideas give businesses different things to offer and market.</a:t>
-            </a:r>
-          </a:p>
-        </p:txBody>
-      </p:sp>
-      <p:sp>
-        <p:nvSpPr>
-          <p:cNvPr id="22" name="">
-            <a:extLst xmlns:a="http://schemas.openxmlformats.org/drawingml/2006/main">
-              <a:ext uri="{FF2B5EF4-FFF2-40B4-BE49-F238E27FC236}">
-                <a16:creationId xmlns:a16="http://schemas.microsoft.com/office/drawing/2014/main" id="{51A6E292-D856-4002-A94E-EAE76AEFB4EC}"/>
-              </a:ext>
-            </a:extLst>
-          </p:cNvPr>
-          <p:cNvSpPr>
-            <a:spLocks xmlns:a="http://schemas.openxmlformats.org/drawingml/2006/main" noGrp="1"/>
-          </p:cNvSpPr>
-          <p:nvPr/>
-        </p:nvSpPr>
-        <p:spPr>
-          <a:xfrm xmlns:a="http://schemas.openxmlformats.org/drawingml/2006/main">
-            <a:off x="914400" y="5734050"/>
-            <a:ext cx="10363200" cy="228600"/>
-          </a:xfrm>
-          <a:prstGeom xmlns:a="http://schemas.openxmlformats.org/drawingml/2006/main" prst="rect">
-            <a:avLst/>
-          </a:prstGeom>
-          <a:noFill xmlns:a="http://schemas.openxmlformats.org/drawingml/2006/main"/>
-          <a:ln xmlns:a="http://schemas.openxmlformats.org/drawingml/2006/main" w="0">
-            <a:noFill/>
-          </a:ln>
-        </p:spPr>
-        <p:txBody>
-          <a:bodyPr xmlns:a="http://schemas.openxmlformats.org/drawingml/2006/main" anchor="ctr">
-            <a:normAutofit fontScale="80000"/>
-          </a:bodyPr>
-          <a:lstStyle xmlns:a="http://schemas.openxmlformats.org/drawingml/2006/main"/>
-          <a:p xmlns:a="http://schemas.openxmlformats.org/drawingml/2006/main">
-            <a:pPr>
-              <a:defRPr sz="1125" b="1">
-                <a:solidFill>
-                  <a:srgbClr val="DCEEF4"/>
-                </a:solidFill>
-                <a:latin typeface="Helvetica Neue"/>
-                <a:ea typeface="Helvetica Neue"/>
-                <a:cs typeface="Helvetica Neue"/>
-              </a:defRPr>
-            </a:pPr>
-            <a:r>
-              <a:rPr sz="1125" b="1">
-                <a:solidFill>
-                  <a:srgbClr val="DCEEF4"/>
-                </a:solidFill>
-                <a:latin typeface="Helvetica Neue"/>
-                <a:ea typeface="Helvetica Neue"/>
-                <a:cs typeface="Helvetica Neue"/>
-              </a:rPr>
-              <a:t>NEXT: Use page 4 to check the three definitions, then continue the Chapter 1 work.</a:t>
-            </a:r>
-          </a:p>
-        </p:txBody>
-      </p:sp>
-    </p:spTree>
-    <p:extLst>
-      <p:ext uri="{BB962C8B-B14F-4D97-AF65-F5344CB8AC3E}">
-        <p14:creationId xmlns:p14="http://schemas.microsoft.com/office/powerpoint/2010/main" val="2046019007"/>
-      </p:ext>
-    </p:extLst>
-  </p:cSld>
-  <p:timing>
-    <p:tnLst>
-      <p:par>
-        <p:cTn id="1" dur="indefinite" restart="never" nodeType="tmRoot">
-          <p:childTnLst>
-            <p:seq concurrent="1" nextAc="seek">
-              <p:cTn id="2" dur="indefinite" nodeType="mainSeq">
-                <p:childTnLst>
-                  <p:par>
-                    <p:cTn id="3" fill="hold">
-                      <p:stCondLst>
-                        <p:cond delay="indefinite"/>
-                      </p:stCondLst>
-                      <p:childTnLst>
-                        <p:par>
-                          <p:cTn id="4" fill="hold">
-                            <p:stCondLst>
-                              <p:cond delay="0"/>
-                            </p:stCondLst>
-                            <p:childTnLst>
-                              <p:par>
-                                <p:cTn id="5" presetID="1" presetClass="entr" presetSubtype="0" fill="hold" nodeType="clickEffect">
-                                  <p:stCondLst>
-                                    <p:cond delay="0"/>
-                                  </p:stCondLst>
-                                  <p:childTnLst>
-                                    <p:set>
-                                      <p:cBhvr>
-                                        <p:cTn id="6" dur="1" fill="hold">
-                                          <p:stCondLst>
-                                            <p:cond delay="0"/>
-                                          </p:stCondLst>
-                                        </p:cTn>
-                                        <p:tgtEl>
-                                          <p:spTgt spid="8"/>
-                                        </p:tgtEl>
-                                        <p:attrNameLst>
-                                          <p:attrName>style.visibility</p:attrName>
-                                        </p:attrNameLst>
-                                      </p:cBhvr>
-                                      <p:to>
-                                        <p:strVal val="visible"/>
-                                      </p:to>
-                                    </p:set>
-                                  </p:childTnLst>
-                                </p:cTn>
-                              </p:par>
-                              <p:par>
-                                <p:cTn id="7" presetID="1" presetClass="entr" presetSubtype="0" fill="hold" nodeType="withEffect">
-                                  <p:stCondLst>
-                                    <p:cond delay="0"/>
-                                  </p:stCondLst>
-                                  <p:childTnLst>
-                                    <p:set>
-                                      <p:cBhvr>
-                                        <p:cTn id="8" dur="1" fill="hold">
-                                          <p:stCondLst>
-                                            <p:cond delay="0"/>
-                                          </p:stCondLst>
-                                        </p:cTn>
-                                        <p:tgtEl>
-                                          <p:spTgt spid="9"/>
-                                        </p:tgtEl>
-                                        <p:attrNameLst>
-                                          <p:attrName>style.visibility</p:attrName>
-                                        </p:attrNameLst>
-                                      </p:cBhvr>
-                                      <p:to>
-                                        <p:strVal val="visible"/>
-                                      </p:to>
-                                    </p:set>
-                                  </p:childTnLst>
-                                </p:cTn>
-                              </p:par>
-                              <p:par>
-                                <p:cTn id="9" presetID="1" presetClass="entr" presetSubtype="0" fill="hold" nodeType="withEffect">
-                                  <p:stCondLst>
-                                    <p:cond delay="0"/>
-                                  </p:stCondLst>
-                                  <p:childTnLst>
-                                    <p:set>
-                                      <p:cBhvr>
-                                        <p:cTn id="10" dur="1" fill="hold">
-                                          <p:stCondLst>
-                                            <p:cond delay="0"/>
-                                          </p:stCondLst>
-                                        </p:cTn>
-                                        <p:tgtEl>
-                                          <p:spTgt spid="10"/>
-                                        </p:tgtEl>
-                                        <p:attrNameLst>
-                                          <p:attrName>style.visibility</p:attrName>
-                                        </p:attrNameLst>
-                                      </p:cBhvr>
-                                      <p:to>
-                                        <p:strVal val="visible"/>
-                                      </p:to>
-                                    </p:set>
-                                  </p:childTnLst>
-                                </p:cTn>
-                              </p:par>
-                              <p:par>
-                                <p:cTn id="11" presetID="1" presetClass="entr" presetSubtype="0" fill="hold" nodeType="withEffect">
-                                  <p:stCondLst>
-                                    <p:cond delay="0"/>
-                                  </p:stCondLst>
-                                  <p:childTnLst>
-                                    <p:set>
-                                      <p:cBhvr>
-                                        <p:cTn id="12" dur="1" fill="hold">
-                                          <p:stCondLst>
-                                            <p:cond delay="0"/>
-                                          </p:stCondLst>
-                                        </p:cTn>
-                                        <p:tgtEl>
-                                          <p:spTgt spid="11"/>
-                                        </p:tgtEl>
-                                        <p:attrNameLst>
-                                          <p:attrName>style.visibility</p:attrName>
-                                        </p:attrNameLst>
-                                      </p:cBhvr>
-                                      <p:to>
-                                        <p:strVal val="visible"/>
-                                      </p:to>
-                                    </p:set>
-                                  </p:childTnLst>
-                                </p:cTn>
-                              </p:par>
-                            </p:childTnLst>
-                          </p:cTn>
-                        </p:par>
-                      </p:childTnLst>
-                    </p:cTn>
-                  </p:par>
-                  <p:par>
-                    <p:cTn id="13" fill="hold">
-                      <p:stCondLst>
-                        <p:cond delay="indefinite"/>
-                      </p:stCondLst>
-                      <p:childTnLst>
-                        <p:par>
-                          <p:cTn id="14" fill="hold">
-                            <p:stCondLst>
-                              <p:cond delay="0"/>
-                            </p:stCondLst>
-                            <p:childTnLst>
-                              <p:par>
-                                <p:cTn id="15" presetID="1" presetClass="entr" presetSubtype="0" fill="hold" nodeType="clickEffect">
-                                  <p:stCondLst>
-                                    <p:cond delay="0"/>
-                                  </p:stCondLst>
-                                  <p:childTnLst>
-                                    <p:set>
-                                      <p:cBhvr>
-                                        <p:cTn id="16" dur="1" fill="hold">
-                                          <p:stCondLst>
-                                            <p:cond delay="0"/>
-                                          </p:stCondLst>
-                                        </p:cTn>
-                                        <p:tgtEl>
-                                          <p:spTgt spid="12"/>
-                                        </p:tgtEl>
-                                        <p:attrNameLst>
-                                          <p:attrName>style.visibility</p:attrName>
-                                        </p:attrNameLst>
-                                      </p:cBhvr>
-                                      <p:to>
-                                        <p:strVal val="visible"/>
-                                      </p:to>
-                                    </p:set>
-                                  </p:childTnLst>
-                                </p:cTn>
-                              </p:par>
-                              <p:par>
-                                <p:cTn id="17" presetID="1" presetClass="entr" presetSubtype="0" fill="hold" nodeType="withEffect">
-                                  <p:stCondLst>
-                                    <p:cond delay="0"/>
-                                  </p:stCondLst>
-                                  <p:childTnLst>
-                                    <p:set>
-                                      <p:cBhvr>
-                                        <p:cTn id="18" dur="1" fill="hold">
-                                          <p:stCondLst>
-                                            <p:cond delay="0"/>
-                                          </p:stCondLst>
-                                        </p:cTn>
-                                        <p:tgtEl>
-                                          <p:spTgt spid="13"/>
-                                        </p:tgtEl>
-                                        <p:attrNameLst>
-                                          <p:attrName>style.visibility</p:attrName>
-                                        </p:attrNameLst>
-                                      </p:cBhvr>
-                                      <p:to>
-                                        <p:strVal val="visible"/>
-                                      </p:to>
-                                    </p:set>
-                                  </p:childTnLst>
-                                </p:cTn>
-                              </p:par>
-                              <p:par>
-                                <p:cTn id="19" presetID="1" presetClass="entr" presetSubtype="0" fill="hold" nodeType="withEffect">
-                                  <p:stCondLst>
-                                    <p:cond delay="0"/>
-                                  </p:stCondLst>
-                                  <p:childTnLst>
-                                    <p:set>
-                                      <p:cBhvr>
-                                        <p:cTn id="20" dur="1" fill="hold">
-                                          <p:stCondLst>
-                                            <p:cond delay="0"/>
-                                          </p:stCondLst>
-                                        </p:cTn>
-                                        <p:tgtEl>
-                                          <p:spTgt spid="14"/>
-                                        </p:tgtEl>
-                                        <p:attrNameLst>
-                                          <p:attrName>style.visibility</p:attrName>
-                                        </p:attrNameLst>
-                                      </p:cBhvr>
-                                      <p:to>
-                                        <p:strVal val="visible"/>
-                                      </p:to>
-                                    </p:set>
-                                  </p:childTnLst>
-                                </p:cTn>
-                              </p:par>
-                              <p:par>
-                                <p:cTn id="21" presetID="1" presetClass="entr" presetSubtype="0" fill="hold" nodeType="withEffect">
-                                  <p:stCondLst>
-                                    <p:cond delay="0"/>
-                                  </p:stCondLst>
-                                  <p:childTnLst>
-                                    <p:set>
-                                      <p:cBhvr>
-                                        <p:cTn id="22" dur="1" fill="hold">
-                                          <p:stCondLst>
-                                            <p:cond delay="0"/>
-                                          </p:stCondLst>
-                                        </p:cTn>
-                                        <p:tgtEl>
-                                          <p:spTgt spid="15"/>
-                                        </p:tgtEl>
-                                        <p:attrNameLst>
-                                          <p:attrName>style.visibility</p:attrName>
-                                        </p:attrNameLst>
-                                      </p:cBhvr>
-                                      <p:to>
-                                        <p:strVal val="visible"/>
-                                      </p:to>
-                                    </p:set>
-                                  </p:childTnLst>
-                                </p:cTn>
-                              </p:par>
-                            </p:childTnLst>
-                          </p:cTn>
-                        </p:par>
-                      </p:childTnLst>
-                    </p:cTn>
-                  </p:par>
-                  <p:par>
-                    <p:cTn id="23" fill="hold">
-                      <p:stCondLst>
-                        <p:cond delay="indefinite"/>
-                      </p:stCondLst>
-                      <p:childTnLst>
-                        <p:par>
-                          <p:cTn id="24" fill="hold">
-                            <p:stCondLst>
-                              <p:cond delay="0"/>
-                            </p:stCondLst>
-                            <p:childTnLst>
-                              <p:par>
-                                <p:cTn id="25" presetID="1" presetClass="entr" presetSubtype="0" fill="hold" nodeType="clickEffect">
-                                  <p:stCondLst>
-                                    <p:cond delay="0"/>
-                                  </p:stCondLst>
-                                  <p:childTnLst>
-                                    <p:set>
-                                      <p:cBhvr>
-                                        <p:cTn id="26" dur="1" fill="hold">
-                                          <p:stCondLst>
-                                            <p:cond delay="0"/>
-                                          </p:stCondLst>
-                                        </p:cTn>
-                                        <p:tgtEl>
-                                          <p:spTgt spid="16"/>
-                                        </p:tgtEl>
-                                        <p:attrNameLst>
-                                          <p:attrName>style.visibility</p:attrName>
-                                        </p:attrNameLst>
-                                      </p:cBhvr>
-                                      <p:to>
-                                        <p:strVal val="visible"/>
-                                      </p:to>
-                                    </p:set>
-                                  </p:childTnLst>
-                                </p:cTn>
-                              </p:par>
-                              <p:par>
-                                <p:cTn id="27" presetID="1" presetClass="entr" presetSubtype="0" fill="hold" nodeType="withEffect">
-                                  <p:stCondLst>
-                                    <p:cond delay="0"/>
-                                  </p:stCondLst>
-                                  <p:childTnLst>
-                                    <p:set>
-                                      <p:cBhvr>
-                                        <p:cTn id="28" dur="1" fill="hold">
-                                          <p:stCondLst>
-                                            <p:cond delay="0"/>
-                                          </p:stCondLst>
-                                        </p:cTn>
-                                        <p:tgtEl>
-                                          <p:spTgt spid="17"/>
-                                        </p:tgtEl>
-                                        <p:attrNameLst>
-                                          <p:attrName>style.visibility</p:attrName>
-                                        </p:attrNameLst>
-                                      </p:cBhvr>
-                                      <p:to>
-                                        <p:strVal val="visible"/>
-                                      </p:to>
-                                    </p:set>
-                                  </p:childTnLst>
-                                </p:cTn>
-                              </p:par>
-                              <p:par>
-                                <p:cTn id="29" presetID="1" presetClass="entr" presetSubtype="0" fill="hold" nodeType="withEffect">
-                                  <p:stCondLst>
-                                    <p:cond delay="0"/>
-                                  </p:stCondLst>
-                                  <p:childTnLst>
-                                    <p:set>
-                                      <p:cBhvr>
-                                        <p:cTn id="30" dur="1" fill="hold">
-                                          <p:stCondLst>
-                                            <p:cond delay="0"/>
-                                          </p:stCondLst>
-                                        </p:cTn>
-                                        <p:tgtEl>
-                                          <p:spTgt spid="18"/>
-                                        </p:tgtEl>
-                                        <p:attrNameLst>
-                                          <p:attrName>style.visibility</p:attrName>
-                                        </p:attrNameLst>
-                                      </p:cBhvr>
-                                      <p:to>
-                                        <p:strVal val="visible"/>
-                                      </p:to>
-                                    </p:set>
-                                  </p:childTnLst>
-                                </p:cTn>
-                              </p:par>
-                              <p:par>
-                                <p:cTn id="31" presetID="1" presetClass="entr" presetSubtype="0" fill="hold" nodeType="withEffect">
-                                  <p:stCondLst>
-                                    <p:cond delay="0"/>
-                                  </p:stCondLst>
-                                  <p:childTnLst>
-                                    <p:set>
-                                      <p:cBhvr>
-                                        <p:cTn id="32" dur="1" fill="hold">
-                                          <p:stCondLst>
-                                            <p:cond delay="0"/>
-                                          </p:stCondLst>
-                                        </p:cTn>
-                                        <p:tgtEl>
-                                          <p:spTgt spid="19"/>
-                                        </p:tgtEl>
-                                        <p:attrNameLst>
-                                          <p:attrName>style.visibility</p:attrName>
-                                        </p:attrNameLst>
-                                      </p:cBhvr>
-                                      <p:to>
-                                        <p:strVal val="visible"/>
-                                      </p:to>
-                                    </p:set>
-                                  </p:childTnLst>
-                                </p:cTn>
-                              </p:par>
-                            </p:childTnLst>
-                          </p:cTn>
-                        </p:par>
-                      </p:childTnLst>
-                    </p:cTn>
-                  </p:par>
-                  <p:par>
-                    <p:cTn id="33" fill="hold">
-                      <p:stCondLst>
-                        <p:cond delay="indefinite"/>
-                      </p:stCondLst>
-                      <p:childTnLst>
-                        <p:par>
-                          <p:cTn id="34" fill="hold">
-                            <p:stCondLst>
-                              <p:cond delay="0"/>
-                            </p:stCondLst>
-                            <p:childTnLst>
-                              <p:par>
-                                <p:cTn id="35" presetID="1" presetClass="entr" presetSubtype="0" fill="hold" nodeType="clickEffect">
-                                  <p:stCondLst>
-                                    <p:cond delay="0"/>
-                                  </p:stCondLst>
-                                  <p:childTnLst>
-                                    <p:set>
-                                      <p:cBhvr>
-                                        <p:cTn id="36" dur="1" fill="hold">
-                                          <p:stCondLst>
-                                            <p:cond delay="0"/>
-                                          </p:stCondLst>
-                                        </p:cTn>
-                                        <p:tgtEl>
-                                          <p:spTgt spid="20"/>
-                                        </p:tgtEl>
-                                        <p:attrNameLst>
-                                          <p:attrName>style.visibility</p:attrName>
-                                        </p:attrNameLst>
-                                      </p:cBhvr>
-                                      <p:to>
-                                        <p:strVal val="visible"/>
-                                      </p:to>
-                                    </p:set>
-                                  </p:childTnLst>
-                                </p:cTn>
-                              </p:par>
-                              <p:par>
-                                <p:cTn id="37" presetID="1" presetClass="entr" presetSubtype="0" fill="hold" nodeType="withEffect">
-                                  <p:stCondLst>
-                                    <p:cond delay="0"/>
-                                  </p:stCondLst>
-                                  <p:childTnLst>
-                                    <p:set>
-                                      <p:cBhvr>
-                                        <p:cTn id="38" dur="1" fill="hold">
-                                          <p:stCondLst>
-                                            <p:cond delay="0"/>
-                                          </p:stCondLst>
-                                        </p:cTn>
-                                        <p:tgtEl>
-                                          <p:spTgt spid="21"/>
-                                        </p:tgtEl>
-                                        <p:attrNameLst>
-                                          <p:attrName>style.visibility</p:attrName>
-                                        </p:attrNameLst>
-                                      </p:cBhvr>
-                                      <p:to>
-                                        <p:strVal val="visible"/>
-                                      </p:to>
-                                    </p:set>
-                                  </p:childTnLst>
-                                </p:cTn>
-                              </p:par>
-                              <p:par>
-                                <p:cTn id="39" presetID="1" presetClass="entr" presetSubtype="0" fill="hold" nodeType="withEffect">
-                                  <p:stCondLst>
-                                    <p:cond delay="0"/>
-                                  </p:stCondLst>
-                                  <p:childTnLst>
-                                    <p:set>
-                                      <p:cBhvr>
-                                        <p:cTn id="40" dur="1" fill="hold">
                                           <p:stCondLst>
                                             <p:cond delay="0"/>
                                           </p:stCondLst>

</xml_diff>